<commit_message>
fix(script): update presenters in Jul 9 status meeting script and refine feedback questions
</commit_message>
<xml_diff>
--- a/output/jul09_status_meeting_vi.pptx
+++ b/output/jul09_status_meeting_vi.pptx
@@ -131,25 +131,47 @@
 </p:presentation>
 </file>
 
-<file path=ppt/revisionInfo.xml><?xml version="1.0" encoding="utf-8"?>
-<p1510:revInfo xmlns:a="http://schemas.openxmlformats.org/drawingml/2006/main" xmlns:r="http://schemas.openxmlformats.org/officeDocument/2006/relationships" xmlns:p1510="http://schemas.microsoft.com/office/powerpoint/2015/10/main">
-  <p1510:revLst>
-    <p1510:client id="{19126A97-8A32-48D3-816A-BE208FDD5764}" v="11" dt="2026-07-03T13:45:42.318"/>
-  </p1510:revLst>
-</p1510:revInfo>
-</file>
-
 <file path=ppt/changesInfos/changesInfo1.xml><?xml version="1.0" encoding="utf-8"?>
 <pc:chgInfo xmlns:a="http://schemas.openxmlformats.org/drawingml/2006/main" xmlns:r="http://schemas.openxmlformats.org/officeDocument/2006/relationships" xmlns:ac="http://schemas.microsoft.com/office/drawing/2013/main/command" xmlns:pc="http://schemas.microsoft.com/office/powerpoint/2013/main/command">
   <pc:docChgLst>
     <pc:chgData name="Saad Anwar" userId="895f82935b6f72c7" providerId="LiveId" clId="{CB245C93-BFC3-42DE-907C-BC8C402E9DA4}"/>
     <pc:docChg chg="custSel modSld">
-      <pc:chgData name="Saad Anwar" userId="895f82935b6f72c7" providerId="LiveId" clId="{CB245C93-BFC3-42DE-907C-BC8C402E9DA4}" dt="2026-07-03T13:45:44.126" v="69" actId="20577"/>
+      <pc:chgData name="Saad Anwar" userId="895f82935b6f72c7" providerId="LiveId" clId="{CB245C93-BFC3-42DE-907C-BC8C402E9DA4}" dt="2026-07-08T19:13:09.752" v="241" actId="1035"/>
       <pc:docMkLst>
         <pc:docMk/>
       </pc:docMkLst>
+      <pc:sldChg chg="modSp mod">
+        <pc:chgData name="Saad Anwar" userId="895f82935b6f72c7" providerId="LiveId" clId="{CB245C93-BFC3-42DE-907C-BC8C402E9DA4}" dt="2026-07-08T14:35:02.955" v="78" actId="20577"/>
+        <pc:sldMkLst>
+          <pc:docMk/>
+          <pc:sldMk cId="0" sldId="256"/>
+        </pc:sldMkLst>
+        <pc:spChg chg="mod">
+          <ac:chgData name="Saad Anwar" userId="895f82935b6f72c7" providerId="LiveId" clId="{CB245C93-BFC3-42DE-907C-BC8C402E9DA4}" dt="2026-07-08T14:35:02.955" v="78" actId="20577"/>
+          <ac:spMkLst>
+            <pc:docMk/>
+            <pc:sldMk cId="0" sldId="256"/>
+            <ac:spMk id="5" creationId="{00000000-0000-0000-0000-000000000000}"/>
+          </ac:spMkLst>
+        </pc:spChg>
+      </pc:sldChg>
+      <pc:sldChg chg="modSp mod">
+        <pc:chgData name="Saad Anwar" userId="895f82935b6f72c7" providerId="LiveId" clId="{CB245C93-BFC3-42DE-907C-BC8C402E9DA4}" dt="2026-07-08T19:12:35.982" v="231" actId="1036"/>
+        <pc:sldMkLst>
+          <pc:docMk/>
+          <pc:sldMk cId="0" sldId="257"/>
+        </pc:sldMkLst>
+        <pc:spChg chg="mod">
+          <ac:chgData name="Saad Anwar" userId="895f82935b6f72c7" providerId="LiveId" clId="{CB245C93-BFC3-42DE-907C-BC8C402E9DA4}" dt="2026-07-08T19:12:35.982" v="231" actId="1036"/>
+          <ac:spMkLst>
+            <pc:docMk/>
+            <pc:sldMk cId="0" sldId="257"/>
+            <ac:spMk id="11" creationId="{00000000-0000-0000-0000-000000000000}"/>
+          </ac:spMkLst>
+        </pc:spChg>
+      </pc:sldChg>
       <pc:sldChg chg="delSp modSp mod">
-        <pc:chgData name="Saad Anwar" userId="895f82935b6f72c7" providerId="LiveId" clId="{CB245C93-BFC3-42DE-907C-BC8C402E9DA4}" dt="2026-07-03T13:42:14.131" v="62" actId="1037"/>
+        <pc:chgData name="Saad Anwar" userId="895f82935b6f72c7" providerId="LiveId" clId="{CB245C93-BFC3-42DE-907C-BC8C402E9DA4}" dt="2026-07-08T14:35:26.759" v="101" actId="1035"/>
         <pc:sldMkLst>
           <pc:docMk/>
           <pc:sldMk cId="0" sldId="258"/>
@@ -186,12 +208,95 @@
             <ac:spMk id="10" creationId="{00000000-0000-0000-0000-000000000000}"/>
           </ac:spMkLst>
         </pc:spChg>
-        <pc:spChg chg="del">
-          <ac:chgData name="Saad Anwar" userId="895f82935b6f72c7" providerId="LiveId" clId="{CB245C93-BFC3-42DE-907C-BC8C402E9DA4}" dt="2026-07-03T13:41:15.265" v="0" actId="478"/>
+        <pc:spChg chg="mod">
+          <ac:chgData name="Saad Anwar" userId="895f82935b6f72c7" providerId="LiveId" clId="{CB245C93-BFC3-42DE-907C-BC8C402E9DA4}" dt="2026-07-08T14:35:26.759" v="101" actId="1035"/>
           <ac:spMkLst>
             <pc:docMk/>
             <pc:sldMk cId="0" sldId="258"/>
+            <ac:spMk id="12" creationId="{00000000-0000-0000-0000-000000000000}"/>
+          </ac:spMkLst>
+        </pc:spChg>
+      </pc:sldChg>
+      <pc:sldChg chg="modSp mod">
+        <pc:chgData name="Saad Anwar" userId="895f82935b6f72c7" providerId="LiveId" clId="{CB245C93-BFC3-42DE-907C-BC8C402E9DA4}" dt="2026-07-08T14:35:39.668" v="121" actId="1035"/>
+        <pc:sldMkLst>
+          <pc:docMk/>
+          <pc:sldMk cId="0" sldId="259"/>
+        </pc:sldMkLst>
+        <pc:spChg chg="mod">
+          <ac:chgData name="Saad Anwar" userId="895f82935b6f72c7" providerId="LiveId" clId="{CB245C93-BFC3-42DE-907C-BC8C402E9DA4}" dt="2026-07-08T14:35:39.668" v="121" actId="1035"/>
+          <ac:spMkLst>
+            <pc:docMk/>
+            <pc:sldMk cId="0" sldId="259"/>
             <ac:spMk id="11" creationId="{00000000-0000-0000-0000-000000000000}"/>
+          </ac:spMkLst>
+        </pc:spChg>
+      </pc:sldChg>
+      <pc:sldChg chg="modSp mod">
+        <pc:chgData name="Saad Anwar" userId="895f82935b6f72c7" providerId="LiveId" clId="{CB245C93-BFC3-42DE-907C-BC8C402E9DA4}" dt="2026-07-08T14:35:47.971" v="141" actId="1035"/>
+        <pc:sldMkLst>
+          <pc:docMk/>
+          <pc:sldMk cId="0" sldId="260"/>
+        </pc:sldMkLst>
+        <pc:spChg chg="mod">
+          <ac:chgData name="Saad Anwar" userId="895f82935b6f72c7" providerId="LiveId" clId="{CB245C93-BFC3-42DE-907C-BC8C402E9DA4}" dt="2026-07-08T14:35:47.971" v="141" actId="1035"/>
+          <ac:spMkLst>
+            <pc:docMk/>
+            <pc:sldMk cId="0" sldId="260"/>
+            <ac:spMk id="8" creationId="{00000000-0000-0000-0000-000000000000}"/>
+          </ac:spMkLst>
+        </pc:spChg>
+      </pc:sldChg>
+      <pc:sldChg chg="modSp mod">
+        <pc:chgData name="Saad Anwar" userId="895f82935b6f72c7" providerId="LiveId" clId="{CB245C93-BFC3-42DE-907C-BC8C402E9DA4}" dt="2026-07-08T19:13:09.752" v="241" actId="1035"/>
+        <pc:sldMkLst>
+          <pc:docMk/>
+          <pc:sldMk cId="0" sldId="261"/>
+        </pc:sldMkLst>
+        <pc:spChg chg="mod">
+          <ac:chgData name="Saad Anwar" userId="895f82935b6f72c7" providerId="LiveId" clId="{CB245C93-BFC3-42DE-907C-BC8C402E9DA4}" dt="2026-07-08T19:13:09.752" v="241" actId="1035"/>
+          <ac:spMkLst>
+            <pc:docMk/>
+            <pc:sldMk cId="0" sldId="261"/>
+            <ac:spMk id="13" creationId="{00000000-0000-0000-0000-000000000000}"/>
+          </ac:spMkLst>
+        </pc:spChg>
+      </pc:sldChg>
+      <pc:sldChg chg="modSp mod">
+        <pc:chgData name="Saad Anwar" userId="895f82935b6f72c7" providerId="LiveId" clId="{CB245C93-BFC3-42DE-907C-BC8C402E9DA4}" dt="2026-07-08T14:36:06.831" v="170" actId="1035"/>
+        <pc:sldMkLst>
+          <pc:docMk/>
+          <pc:sldMk cId="0" sldId="262"/>
+        </pc:sldMkLst>
+        <pc:spChg chg="mod">
+          <ac:chgData name="Saad Anwar" userId="895f82935b6f72c7" providerId="LiveId" clId="{CB245C93-BFC3-42DE-907C-BC8C402E9DA4}" dt="2026-07-08T14:36:06.831" v="170" actId="1035"/>
+          <ac:spMkLst>
+            <pc:docMk/>
+            <pc:sldMk cId="0" sldId="262"/>
+            <ac:spMk id="8" creationId="{00000000-0000-0000-0000-000000000000}"/>
+          </ac:spMkLst>
+        </pc:spChg>
+      </pc:sldChg>
+      <pc:sldChg chg="modSp mod">
+        <pc:chgData name="Saad Anwar" userId="895f82935b6f72c7" providerId="LiveId" clId="{CB245C93-BFC3-42DE-907C-BC8C402E9DA4}" dt="2026-07-08T19:12:04.620" v="221" actId="1036"/>
+        <pc:sldMkLst>
+          <pc:docMk/>
+          <pc:sldMk cId="0" sldId="263"/>
+        </pc:sldMkLst>
+        <pc:spChg chg="mod">
+          <ac:chgData name="Saad Anwar" userId="895f82935b6f72c7" providerId="LiveId" clId="{CB245C93-BFC3-42DE-907C-BC8C402E9DA4}" dt="2026-07-08T19:11:50.284" v="217" actId="20577"/>
+          <ac:spMkLst>
+            <pc:docMk/>
+            <pc:sldMk cId="0" sldId="263"/>
+            <ac:spMk id="10" creationId="{00000000-0000-0000-0000-000000000000}"/>
+          </ac:spMkLst>
+        </pc:spChg>
+        <pc:spChg chg="mod">
+          <ac:chgData name="Saad Anwar" userId="895f82935b6f72c7" providerId="LiveId" clId="{CB245C93-BFC3-42DE-907C-BC8C402E9DA4}" dt="2026-07-08T19:12:04.620" v="221" actId="1036"/>
+          <ac:spMkLst>
+            <pc:docMk/>
+            <pc:sldMk cId="0" sldId="263"/>
+            <ac:spMk id="12" creationId="{00000000-0000-0000-0000-000000000000}"/>
           </ac:spMkLst>
         </pc:spChg>
       </pc:sldChg>
@@ -394,7 +499,7 @@
           <a:p>
             <a:fld id="{5BCAD085-E8A6-8845-BD4E-CB4CCA059FC4}" type="datetimeFigureOut">
               <a:rPr lang="en-US" smtClean="0"/>
-              <a:t>7/3/2026</a:t>
+              <a:t>7/8/2026</a:t>
             </a:fld>
             <a:endParaRPr lang="en-US"/>
           </a:p>
@@ -562,7 +667,7 @@
           <a:p>
             <a:fld id="{5BCAD085-E8A6-8845-BD4E-CB4CCA059FC4}" type="datetimeFigureOut">
               <a:rPr lang="en-US" smtClean="0"/>
-              <a:t>7/3/2026</a:t>
+              <a:t>7/8/2026</a:t>
             </a:fld>
             <a:endParaRPr lang="en-US"/>
           </a:p>
@@ -740,7 +845,7 @@
           <a:p>
             <a:fld id="{5BCAD085-E8A6-8845-BD4E-CB4CCA059FC4}" type="datetimeFigureOut">
               <a:rPr lang="en-US" smtClean="0"/>
-              <a:t>7/3/2026</a:t>
+              <a:t>7/8/2026</a:t>
             </a:fld>
             <a:endParaRPr lang="en-US"/>
           </a:p>
@@ -908,7 +1013,7 @@
           <a:p>
             <a:fld id="{5BCAD085-E8A6-8845-BD4E-CB4CCA059FC4}" type="datetimeFigureOut">
               <a:rPr lang="en-US" smtClean="0"/>
-              <a:t>7/3/2026</a:t>
+              <a:t>7/8/2026</a:t>
             </a:fld>
             <a:endParaRPr lang="en-US"/>
           </a:p>
@@ -1153,7 +1258,7 @@
           <a:p>
             <a:fld id="{5BCAD085-E8A6-8845-BD4E-CB4CCA059FC4}" type="datetimeFigureOut">
               <a:rPr lang="en-US" smtClean="0"/>
-              <a:t>7/3/2026</a:t>
+              <a:t>7/8/2026</a:t>
             </a:fld>
             <a:endParaRPr lang="en-US"/>
           </a:p>
@@ -1438,7 +1543,7 @@
           <a:p>
             <a:fld id="{5BCAD085-E8A6-8845-BD4E-CB4CCA059FC4}" type="datetimeFigureOut">
               <a:rPr lang="en-US" smtClean="0"/>
-              <a:t>7/3/2026</a:t>
+              <a:t>7/8/2026</a:t>
             </a:fld>
             <a:endParaRPr lang="en-US"/>
           </a:p>
@@ -1857,7 +1962,7 @@
           <a:p>
             <a:fld id="{5BCAD085-E8A6-8845-BD4E-CB4CCA059FC4}" type="datetimeFigureOut">
               <a:rPr lang="en-US" smtClean="0"/>
-              <a:t>7/3/2026</a:t>
+              <a:t>7/8/2026</a:t>
             </a:fld>
             <a:endParaRPr lang="en-US"/>
           </a:p>
@@ -1974,7 +2079,7 @@
           <a:p>
             <a:fld id="{5BCAD085-E8A6-8845-BD4E-CB4CCA059FC4}" type="datetimeFigureOut">
               <a:rPr lang="en-US" smtClean="0"/>
-              <a:t>7/3/2026</a:t>
+              <a:t>7/8/2026</a:t>
             </a:fld>
             <a:endParaRPr lang="en-US"/>
           </a:p>
@@ -2069,7 +2174,7 @@
           <a:p>
             <a:fld id="{5BCAD085-E8A6-8845-BD4E-CB4CCA059FC4}" type="datetimeFigureOut">
               <a:rPr lang="en-US" smtClean="0"/>
-              <a:t>7/3/2026</a:t>
+              <a:t>7/8/2026</a:t>
             </a:fld>
             <a:endParaRPr lang="en-US"/>
           </a:p>
@@ -2344,7 +2449,7 @@
           <a:p>
             <a:fld id="{5BCAD085-E8A6-8845-BD4E-CB4CCA059FC4}" type="datetimeFigureOut">
               <a:rPr lang="en-US" smtClean="0"/>
-              <a:t>7/3/2026</a:t>
+              <a:t>7/8/2026</a:t>
             </a:fld>
             <a:endParaRPr lang="en-US"/>
           </a:p>
@@ -2596,7 +2701,7 @@
           <a:p>
             <a:fld id="{5BCAD085-E8A6-8845-BD4E-CB4CCA059FC4}" type="datetimeFigureOut">
               <a:rPr lang="en-US" smtClean="0"/>
-              <a:t>7/3/2026</a:t>
+              <a:t>7/8/2026</a:t>
             </a:fld>
             <a:endParaRPr lang="en-US"/>
           </a:p>
@@ -2807,7 +2912,7 @@
           <a:p>
             <a:fld id="{5BCAD085-E8A6-8845-BD4E-CB4CCA059FC4}" type="datetimeFigureOut">
               <a:rPr lang="en-US" smtClean="0"/>
-              <a:t>7/3/2026</a:t>
+              <a:t>7/8/2026</a:t>
             </a:fld>
             <a:endParaRPr lang="en-US"/>
           </a:p>
@@ -3316,7 +3421,7 @@
         <p:spPr>
           <a:xfrm>
             <a:off x="502920" y="4434840"/>
-            <a:ext cx="11185855" cy="365760"/>
+            <a:ext cx="11185855" cy="283154"/>
           </a:xfrm>
           <a:prstGeom prst="rect">
             <a:avLst/>
@@ -3335,13 +3440,40 @@
               </a:lnSpc>
             </a:pPr>
             <a:r>
-              <a:rPr sz="1600" b="1">
+              <a:rPr sz="1600" b="1" dirty="0">
                 <a:solidFill>
                   <a:srgbClr val="FDFBF5"/>
                 </a:solidFill>
                 <a:latin typeface="Segoe UI"/>
               </a:rPr>
-              <a:t>Presented by Zuraiz, on behalf of the team</a:t>
+              <a:t>Presented by </a:t>
+            </a:r>
+            <a:r>
+              <a:rPr lang="en-US" sz="1600" b="1" dirty="0">
+                <a:solidFill>
+                  <a:srgbClr val="FDFBF5"/>
+                </a:solidFill>
+                <a:latin typeface="Segoe UI"/>
+              </a:rPr>
+              <a:t>Hammad &amp; </a:t>
+            </a:r>
+            <a:r>
+              <a:rPr sz="1600" b="1" dirty="0" err="1">
+                <a:solidFill>
+                  <a:srgbClr val="FDFBF5"/>
+                </a:solidFill>
+                <a:latin typeface="Segoe UI"/>
+              </a:rPr>
+              <a:t>Zuraiz</a:t>
+            </a:r>
+            <a:r>
+              <a:rPr sz="1600" b="1" dirty="0">
+                <a:solidFill>
+                  <a:srgbClr val="FDFBF5"/>
+                </a:solidFill>
+                <a:latin typeface="Segoe UI"/>
+              </a:rPr>
+              <a:t>, on behalf of the team</a:t>
             </a:r>
           </a:p>
         </p:txBody>
@@ -3964,7 +4096,7 @@
         </p:nvSpPr>
         <p:spPr>
           <a:xfrm>
-            <a:off x="502920" y="6144768"/>
+            <a:off x="502920" y="5964534"/>
             <a:ext cx="11185855" cy="475488"/>
           </a:xfrm>
           <a:prstGeom prst="roundRect">
@@ -4550,7 +4682,7 @@
         </p:nvSpPr>
         <p:spPr>
           <a:xfrm>
-            <a:off x="502920" y="6144768"/>
+            <a:off x="502920" y="5977989"/>
             <a:ext cx="11185855" cy="475488"/>
           </a:xfrm>
           <a:prstGeom prst="roundRect">
@@ -5160,7 +5292,7 @@
         </p:nvSpPr>
         <p:spPr>
           <a:xfrm>
-            <a:off x="502920" y="6144768"/>
+            <a:off x="502920" y="5977989"/>
             <a:ext cx="11185855" cy="475488"/>
           </a:xfrm>
           <a:prstGeom prst="roundRect">
@@ -5473,7 +5605,7 @@
         </p:nvSpPr>
         <p:spPr>
           <a:xfrm>
-            <a:off x="502920" y="6144768"/>
+            <a:off x="502920" y="5977989"/>
             <a:ext cx="11185855" cy="475488"/>
           </a:xfrm>
           <a:prstGeom prst="roundRect">
@@ -6166,7 +6298,7 @@
         </p:nvSpPr>
         <p:spPr>
           <a:xfrm>
-            <a:off x="502920" y="6144768"/>
+            <a:off x="502920" y="5983740"/>
             <a:ext cx="11185855" cy="475488"/>
           </a:xfrm>
           <a:prstGeom prst="roundRect">
@@ -6479,7 +6611,7 @@
         </p:nvSpPr>
         <p:spPr>
           <a:xfrm>
-            <a:off x="502920" y="6144768"/>
+            <a:off x="502920" y="5983740"/>
             <a:ext cx="11185855" cy="475488"/>
           </a:xfrm>
           <a:prstGeom prst="roundRect">
@@ -7030,7 +7162,7 @@
               </a:spcAft>
             </a:pPr>
             <a:r>
-              <a:rPr sz="1400" b="1">
+              <a:rPr sz="1400" b="1" dirty="0">
                 <a:solidFill>
                   <a:srgbClr val="0E4D5E"/>
                 </a:solidFill>
@@ -7046,13 +7178,67 @@
               </a:spcAft>
             </a:pPr>
             <a:r>
-              <a:rPr sz="1250" b="0">
+              <a:rPr sz="1250" b="0" dirty="0">
                 <a:solidFill>
                   <a:srgbClr val="24262E"/>
                 </a:solidFill>
                 <a:latin typeface="Segoe UI"/>
               </a:rPr>
-              <a:t>Prepare the presentation laptop and rehearse the demo path.</a:t>
+              <a:t>Prepare</a:t>
+            </a:r>
+            <a:r>
+              <a:rPr lang="en-US" sz="1250" b="0" dirty="0">
+                <a:solidFill>
+                  <a:srgbClr val="24262E"/>
+                </a:solidFill>
+                <a:latin typeface="Segoe UI"/>
+              </a:rPr>
+              <a:t> for</a:t>
+            </a:r>
+            <a:r>
+              <a:rPr sz="1250" b="0" dirty="0">
+                <a:solidFill>
+                  <a:srgbClr val="24262E"/>
+                </a:solidFill>
+                <a:latin typeface="Segoe UI"/>
+              </a:rPr>
+              <a:t> the presentation and </a:t>
+            </a:r>
+            <a:r>
+              <a:rPr lang="en-US" sz="1250" b="0" dirty="0">
+                <a:solidFill>
+                  <a:srgbClr val="24262E"/>
+                </a:solidFill>
+                <a:latin typeface="Segoe UI"/>
+              </a:rPr>
+              <a:t>final few test for</a:t>
+            </a:r>
+            <a:r>
+              <a:rPr sz="1250" b="0" dirty="0">
+                <a:solidFill>
+                  <a:srgbClr val="24262E"/>
+                </a:solidFill>
+                <a:latin typeface="Segoe UI"/>
+              </a:rPr>
+              <a:t> the dem</a:t>
+            </a:r>
+            <a:r>
+              <a:rPr lang="en-US" sz="1250" b="0" dirty="0">
+                <a:solidFill>
+                  <a:srgbClr val="24262E"/>
+                </a:solidFill>
+                <a:latin typeface="Segoe UI"/>
+              </a:rPr>
+              <a:t>o</a:t>
+            </a:r>
+            <a:r>
+              <a:rPr sz="1250" b="0" dirty="0">
+                <a:solidFill>
+                  <a:srgbClr val="24262E"/>
+                </a:solidFill>
+                <a:latin typeface="Segoe UI"/>
+              </a:rPr>
+              <a:t>.</a:t>
             </a:r>
           </a:p>
         </p:txBody>
@@ -7141,7 +7327,7 @@
         </p:nvSpPr>
         <p:spPr>
           <a:xfrm>
-            <a:off x="502920" y="6144768"/>
+            <a:off x="502920" y="5977989"/>
             <a:ext cx="11185855" cy="475488"/>
           </a:xfrm>
           <a:prstGeom prst="roundRect">

</xml_diff>

<commit_message>
docs(jul09): answer Hacker's Status-V question with the operational H2 definition
Prof. Hacker asked at Status V what 'leader dominance' means; the Jul-9
materials had only a plain-language gloss. Now all four artifacts carry the
formal operationalization: leader dominance = out-degree centralization of
the directed influence graph (Gini of node out-degree; 0 = democratic,
toward 1 = one singer Granger-causes the rest without reciprocation),
tested vs 1000 density-matched random graphs; corpus mean 0.154 vs null
0.139 on the slide.

- deck slide 6 + PPTX: definition with numbers replaces the informal note.
- script slide 6: explicitly closes the loop ('Professor Hacker asked ...
  here is the precise answer') before the result.
- qa Q5b: why Gini/out-degree over eigenvector (near-tie instability we
  observed) and Freeman as an equivalent alternative; per-dataset numbers.
PPTX re-rendered (9 slides). No em-dashes. All numbers from
_h2_centralization.csv.
</commit_message>
<xml_diff>
--- a/output/jul09_status_meeting_vi.pptx
+++ b/output/jul09_status_meeting_vi.pptx
@@ -5,17 +5,17 @@
     <p:sldMasterId id="2147483648" r:id="rId1"/>
   </p:sldMasterIdLst>
   <p:sldIdLst>
-    <p:sldId id="256" r:id="rId2"/>
-    <p:sldId id="257" r:id="rId3"/>
-    <p:sldId id="258" r:id="rId4"/>
-    <p:sldId id="259" r:id="rId5"/>
-    <p:sldId id="260" r:id="rId6"/>
-    <p:sldId id="261" r:id="rId7"/>
-    <p:sldId id="262" r:id="rId8"/>
-    <p:sldId id="263" r:id="rId9"/>
-    <p:sldId id="264" r:id="rId10"/>
+    <p:sldId id="256" r:id="rId7"/>
+    <p:sldId id="257" r:id="rId8"/>
+    <p:sldId id="258" r:id="rId9"/>
+    <p:sldId id="259" r:id="rId10"/>
+    <p:sldId id="260" r:id="rId11"/>
+    <p:sldId id="261" r:id="rId12"/>
+    <p:sldId id="262" r:id="rId13"/>
+    <p:sldId id="263" r:id="rId14"/>
+    <p:sldId id="264" r:id="rId15"/>
   </p:sldIdLst>
-  <p:sldSz cx="12192000" cy="6858000"/>
+  <p:sldSz cx="12191695" cy="6858000" type="screen4x3"/>
   <p:notesSz cx="6858000" cy="9144000"/>
   <p:defaultTextStyle>
     <a:defPPr>
@@ -112,212 +112,7 @@
       </a:defRPr>
     </a:lvl9pPr>
   </p:defaultTextStyle>
-  <p:extLst>
-    <p:ext uri="{EFAFB233-063F-42B5-8137-9DF3F51BA10A}">
-      <p15:sldGuideLst xmlns:p15="http://schemas.microsoft.com/office/powerpoint/2012/main">
-        <p15:guide id="1" orient="horz" pos="2160">
-          <p15:clr>
-            <a:srgbClr val="A4A3A4"/>
-          </p15:clr>
-        </p15:guide>
-        <p15:guide id="2" pos="2880">
-          <p15:clr>
-            <a:srgbClr val="A4A3A4"/>
-          </p15:clr>
-        </p15:guide>
-      </p15:sldGuideLst>
-    </p:ext>
-  </p:extLst>
 </p:presentation>
-</file>
-
-<file path=ppt/changesInfos/changesInfo1.xml><?xml version="1.0" encoding="utf-8"?>
-<pc:chgInfo xmlns:a="http://schemas.openxmlformats.org/drawingml/2006/main" xmlns:r="http://schemas.openxmlformats.org/officeDocument/2006/relationships" xmlns:ac="http://schemas.microsoft.com/office/drawing/2013/main/command" xmlns:pc="http://schemas.microsoft.com/office/powerpoint/2013/main/command">
-  <pc:docChgLst>
-    <pc:chgData name="Saad Anwar" userId="895f82935b6f72c7" providerId="LiveId" clId="{CB245C93-BFC3-42DE-907C-BC8C402E9DA4}"/>
-    <pc:docChg chg="custSel modSld">
-      <pc:chgData name="Saad Anwar" userId="895f82935b6f72c7" providerId="LiveId" clId="{CB245C93-BFC3-42DE-907C-BC8C402E9DA4}" dt="2026-07-08T19:13:09.752" v="241" actId="1035"/>
-      <pc:docMkLst>
-        <pc:docMk/>
-      </pc:docMkLst>
-      <pc:sldChg chg="modSp mod">
-        <pc:chgData name="Saad Anwar" userId="895f82935b6f72c7" providerId="LiveId" clId="{CB245C93-BFC3-42DE-907C-BC8C402E9DA4}" dt="2026-07-08T14:35:02.955" v="78" actId="20577"/>
-        <pc:sldMkLst>
-          <pc:docMk/>
-          <pc:sldMk cId="0" sldId="256"/>
-        </pc:sldMkLst>
-        <pc:spChg chg="mod">
-          <ac:chgData name="Saad Anwar" userId="895f82935b6f72c7" providerId="LiveId" clId="{CB245C93-BFC3-42DE-907C-BC8C402E9DA4}" dt="2026-07-08T14:35:02.955" v="78" actId="20577"/>
-          <ac:spMkLst>
-            <pc:docMk/>
-            <pc:sldMk cId="0" sldId="256"/>
-            <ac:spMk id="5" creationId="{00000000-0000-0000-0000-000000000000}"/>
-          </ac:spMkLst>
-        </pc:spChg>
-      </pc:sldChg>
-      <pc:sldChg chg="modSp mod">
-        <pc:chgData name="Saad Anwar" userId="895f82935b6f72c7" providerId="LiveId" clId="{CB245C93-BFC3-42DE-907C-BC8C402E9DA4}" dt="2026-07-08T19:12:35.982" v="231" actId="1036"/>
-        <pc:sldMkLst>
-          <pc:docMk/>
-          <pc:sldMk cId="0" sldId="257"/>
-        </pc:sldMkLst>
-        <pc:spChg chg="mod">
-          <ac:chgData name="Saad Anwar" userId="895f82935b6f72c7" providerId="LiveId" clId="{CB245C93-BFC3-42DE-907C-BC8C402E9DA4}" dt="2026-07-08T19:12:35.982" v="231" actId="1036"/>
-          <ac:spMkLst>
-            <pc:docMk/>
-            <pc:sldMk cId="0" sldId="257"/>
-            <ac:spMk id="11" creationId="{00000000-0000-0000-0000-000000000000}"/>
-          </ac:spMkLst>
-        </pc:spChg>
-      </pc:sldChg>
-      <pc:sldChg chg="delSp modSp mod">
-        <pc:chgData name="Saad Anwar" userId="895f82935b6f72c7" providerId="LiveId" clId="{CB245C93-BFC3-42DE-907C-BC8C402E9DA4}" dt="2026-07-08T14:35:26.759" v="101" actId="1035"/>
-        <pc:sldMkLst>
-          <pc:docMk/>
-          <pc:sldMk cId="0" sldId="258"/>
-        </pc:sldMkLst>
-        <pc:spChg chg="mod">
-          <ac:chgData name="Saad Anwar" userId="895f82935b6f72c7" providerId="LiveId" clId="{CB245C93-BFC3-42DE-907C-BC8C402E9DA4}" dt="2026-07-03T13:41:55.405" v="33" actId="14100"/>
-          <ac:spMkLst>
-            <pc:docMk/>
-            <pc:sldMk cId="0" sldId="258"/>
-            <ac:spMk id="7" creationId="{00000000-0000-0000-0000-000000000000}"/>
-          </ac:spMkLst>
-        </pc:spChg>
-        <pc:spChg chg="mod">
-          <ac:chgData name="Saad Anwar" userId="895f82935b6f72c7" providerId="LiveId" clId="{CB245C93-BFC3-42DE-907C-BC8C402E9DA4}" dt="2026-07-03T13:42:07.633" v="57" actId="1036"/>
-          <ac:spMkLst>
-            <pc:docMk/>
-            <pc:sldMk cId="0" sldId="258"/>
-            <ac:spMk id="8" creationId="{00000000-0000-0000-0000-000000000000}"/>
-          </ac:spMkLst>
-        </pc:spChg>
-        <pc:spChg chg="mod">
-          <ac:chgData name="Saad Anwar" userId="895f82935b6f72c7" providerId="LiveId" clId="{CB245C93-BFC3-42DE-907C-BC8C402E9DA4}" dt="2026-07-03T13:42:03.723" v="48" actId="1035"/>
-          <ac:spMkLst>
-            <pc:docMk/>
-            <pc:sldMk cId="0" sldId="258"/>
-            <ac:spMk id="9" creationId="{00000000-0000-0000-0000-000000000000}"/>
-          </ac:spMkLst>
-        </pc:spChg>
-        <pc:spChg chg="mod">
-          <ac:chgData name="Saad Anwar" userId="895f82935b6f72c7" providerId="LiveId" clId="{CB245C93-BFC3-42DE-907C-BC8C402E9DA4}" dt="2026-07-03T13:42:14.131" v="62" actId="1037"/>
-          <ac:spMkLst>
-            <pc:docMk/>
-            <pc:sldMk cId="0" sldId="258"/>
-            <ac:spMk id="10" creationId="{00000000-0000-0000-0000-000000000000}"/>
-          </ac:spMkLst>
-        </pc:spChg>
-        <pc:spChg chg="mod">
-          <ac:chgData name="Saad Anwar" userId="895f82935b6f72c7" providerId="LiveId" clId="{CB245C93-BFC3-42DE-907C-BC8C402E9DA4}" dt="2026-07-08T14:35:26.759" v="101" actId="1035"/>
-          <ac:spMkLst>
-            <pc:docMk/>
-            <pc:sldMk cId="0" sldId="258"/>
-            <ac:spMk id="12" creationId="{00000000-0000-0000-0000-000000000000}"/>
-          </ac:spMkLst>
-        </pc:spChg>
-      </pc:sldChg>
-      <pc:sldChg chg="modSp mod">
-        <pc:chgData name="Saad Anwar" userId="895f82935b6f72c7" providerId="LiveId" clId="{CB245C93-BFC3-42DE-907C-BC8C402E9DA4}" dt="2026-07-08T14:35:39.668" v="121" actId="1035"/>
-        <pc:sldMkLst>
-          <pc:docMk/>
-          <pc:sldMk cId="0" sldId="259"/>
-        </pc:sldMkLst>
-        <pc:spChg chg="mod">
-          <ac:chgData name="Saad Anwar" userId="895f82935b6f72c7" providerId="LiveId" clId="{CB245C93-BFC3-42DE-907C-BC8C402E9DA4}" dt="2026-07-08T14:35:39.668" v="121" actId="1035"/>
-          <ac:spMkLst>
-            <pc:docMk/>
-            <pc:sldMk cId="0" sldId="259"/>
-            <ac:spMk id="11" creationId="{00000000-0000-0000-0000-000000000000}"/>
-          </ac:spMkLst>
-        </pc:spChg>
-      </pc:sldChg>
-      <pc:sldChg chg="modSp mod">
-        <pc:chgData name="Saad Anwar" userId="895f82935b6f72c7" providerId="LiveId" clId="{CB245C93-BFC3-42DE-907C-BC8C402E9DA4}" dt="2026-07-08T14:35:47.971" v="141" actId="1035"/>
-        <pc:sldMkLst>
-          <pc:docMk/>
-          <pc:sldMk cId="0" sldId="260"/>
-        </pc:sldMkLst>
-        <pc:spChg chg="mod">
-          <ac:chgData name="Saad Anwar" userId="895f82935b6f72c7" providerId="LiveId" clId="{CB245C93-BFC3-42DE-907C-BC8C402E9DA4}" dt="2026-07-08T14:35:47.971" v="141" actId="1035"/>
-          <ac:spMkLst>
-            <pc:docMk/>
-            <pc:sldMk cId="0" sldId="260"/>
-            <ac:spMk id="8" creationId="{00000000-0000-0000-0000-000000000000}"/>
-          </ac:spMkLst>
-        </pc:spChg>
-      </pc:sldChg>
-      <pc:sldChg chg="modSp mod">
-        <pc:chgData name="Saad Anwar" userId="895f82935b6f72c7" providerId="LiveId" clId="{CB245C93-BFC3-42DE-907C-BC8C402E9DA4}" dt="2026-07-08T19:13:09.752" v="241" actId="1035"/>
-        <pc:sldMkLst>
-          <pc:docMk/>
-          <pc:sldMk cId="0" sldId="261"/>
-        </pc:sldMkLst>
-        <pc:spChg chg="mod">
-          <ac:chgData name="Saad Anwar" userId="895f82935b6f72c7" providerId="LiveId" clId="{CB245C93-BFC3-42DE-907C-BC8C402E9DA4}" dt="2026-07-08T19:13:09.752" v="241" actId="1035"/>
-          <ac:spMkLst>
-            <pc:docMk/>
-            <pc:sldMk cId="0" sldId="261"/>
-            <ac:spMk id="13" creationId="{00000000-0000-0000-0000-000000000000}"/>
-          </ac:spMkLst>
-        </pc:spChg>
-      </pc:sldChg>
-      <pc:sldChg chg="modSp mod">
-        <pc:chgData name="Saad Anwar" userId="895f82935b6f72c7" providerId="LiveId" clId="{CB245C93-BFC3-42DE-907C-BC8C402E9DA4}" dt="2026-07-08T14:36:06.831" v="170" actId="1035"/>
-        <pc:sldMkLst>
-          <pc:docMk/>
-          <pc:sldMk cId="0" sldId="262"/>
-        </pc:sldMkLst>
-        <pc:spChg chg="mod">
-          <ac:chgData name="Saad Anwar" userId="895f82935b6f72c7" providerId="LiveId" clId="{CB245C93-BFC3-42DE-907C-BC8C402E9DA4}" dt="2026-07-08T14:36:06.831" v="170" actId="1035"/>
-          <ac:spMkLst>
-            <pc:docMk/>
-            <pc:sldMk cId="0" sldId="262"/>
-            <ac:spMk id="8" creationId="{00000000-0000-0000-0000-000000000000}"/>
-          </ac:spMkLst>
-        </pc:spChg>
-      </pc:sldChg>
-      <pc:sldChg chg="modSp mod">
-        <pc:chgData name="Saad Anwar" userId="895f82935b6f72c7" providerId="LiveId" clId="{CB245C93-BFC3-42DE-907C-BC8C402E9DA4}" dt="2026-07-08T19:12:04.620" v="221" actId="1036"/>
-        <pc:sldMkLst>
-          <pc:docMk/>
-          <pc:sldMk cId="0" sldId="263"/>
-        </pc:sldMkLst>
-        <pc:spChg chg="mod">
-          <ac:chgData name="Saad Anwar" userId="895f82935b6f72c7" providerId="LiveId" clId="{CB245C93-BFC3-42DE-907C-BC8C402E9DA4}" dt="2026-07-08T19:11:50.284" v="217" actId="20577"/>
-          <ac:spMkLst>
-            <pc:docMk/>
-            <pc:sldMk cId="0" sldId="263"/>
-            <ac:spMk id="10" creationId="{00000000-0000-0000-0000-000000000000}"/>
-          </ac:spMkLst>
-        </pc:spChg>
-        <pc:spChg chg="mod">
-          <ac:chgData name="Saad Anwar" userId="895f82935b6f72c7" providerId="LiveId" clId="{CB245C93-BFC3-42DE-907C-BC8C402E9DA4}" dt="2026-07-08T19:12:04.620" v="221" actId="1036"/>
-          <ac:spMkLst>
-            <pc:docMk/>
-            <pc:sldMk cId="0" sldId="263"/>
-            <ac:spMk id="12" creationId="{00000000-0000-0000-0000-000000000000}"/>
-          </ac:spMkLst>
-        </pc:spChg>
-      </pc:sldChg>
-      <pc:sldChg chg="modSp mod">
-        <pc:chgData name="Saad Anwar" userId="895f82935b6f72c7" providerId="LiveId" clId="{CB245C93-BFC3-42DE-907C-BC8C402E9DA4}" dt="2026-07-03T13:45:44.126" v="69" actId="20577"/>
-        <pc:sldMkLst>
-          <pc:docMk/>
-          <pc:sldMk cId="0" sldId="264"/>
-        </pc:sldMkLst>
-        <pc:spChg chg="mod">
-          <ac:chgData name="Saad Anwar" userId="895f82935b6f72c7" providerId="LiveId" clId="{CB245C93-BFC3-42DE-907C-BC8C402E9DA4}" dt="2026-07-03T13:45:44.126" v="69" actId="20577"/>
-          <ac:spMkLst>
-            <pc:docMk/>
-            <pc:sldMk cId="0" sldId="264"/>
-            <ac:spMk id="8" creationId="{00000000-0000-0000-0000-000000000000}"/>
-          </ac:spMkLst>
-        </pc:spChg>
-      </pc:sldChg>
-    </pc:docChg>
-  </pc:docChgLst>
-</pc:chgInfo>
 </file>
 
 <file path=ppt/slideLayouts/slideLayout1.xml><?xml version="1.0" encoding="utf-8"?>
@@ -358,9 +153,10 @@
           <a:lstStyle/>
           <a:p>
             <a:r>
-              <a:rPr lang="en-US"/>
+              <a:rPr lang="en-US" smtClean="0"/>
               <a:t>Click to edit Master title style</a:t>
             </a:r>
+            <a:endParaRPr lang="en-US"/>
           </a:p>
         </p:txBody>
       </p:sp>
@@ -476,9 +272,10 @@
           </a:lstStyle>
           <a:p>
             <a:r>
-              <a:rPr lang="en-US"/>
+              <a:rPr lang="en-US" smtClean="0"/>
               <a:t>Click to edit Master subtitle style</a:t>
             </a:r>
+            <a:endParaRPr lang="en-US"/>
           </a:p>
         </p:txBody>
       </p:sp>
@@ -499,7 +296,7 @@
           <a:p>
             <a:fld id="{5BCAD085-E8A6-8845-BD4E-CB4CCA059FC4}" type="datetimeFigureOut">
               <a:rPr lang="en-US" smtClean="0"/>
-              <a:t>7/8/2026</a:t>
+              <a:t>1/27/13</a:t>
             </a:fld>
             <a:endParaRPr lang="en-US"/>
           </a:p>
@@ -593,9 +390,10 @@
           <a:lstStyle/>
           <a:p>
             <a:r>
-              <a:rPr lang="en-US"/>
+              <a:rPr lang="en-US" smtClean="0"/>
               <a:t>Click to edit Master title style</a:t>
             </a:r>
+            <a:endParaRPr lang="en-US"/>
           </a:p>
         </p:txBody>
       </p:sp>
@@ -616,37 +414,38 @@
           <a:p>
             <a:pPr lvl="0"/>
             <a:r>
-              <a:rPr lang="en-US"/>
+              <a:rPr lang="en-US" smtClean="0"/>
               <a:t>Click to edit Master text styles</a:t>
             </a:r>
           </a:p>
           <a:p>
             <a:pPr lvl="1"/>
             <a:r>
-              <a:rPr lang="en-US"/>
+              <a:rPr lang="en-US" smtClean="0"/>
               <a:t>Second level</a:t>
             </a:r>
           </a:p>
           <a:p>
             <a:pPr lvl="2"/>
             <a:r>
-              <a:rPr lang="en-US"/>
+              <a:rPr lang="en-US" smtClean="0"/>
               <a:t>Third level</a:t>
             </a:r>
           </a:p>
           <a:p>
             <a:pPr lvl="3"/>
             <a:r>
-              <a:rPr lang="en-US"/>
+              <a:rPr lang="en-US" smtClean="0"/>
               <a:t>Fourth level</a:t>
             </a:r>
           </a:p>
           <a:p>
             <a:pPr lvl="4"/>
             <a:r>
-              <a:rPr lang="en-US"/>
+              <a:rPr lang="en-US" smtClean="0"/>
               <a:t>Fifth level</a:t>
             </a:r>
+            <a:endParaRPr lang="en-US"/>
           </a:p>
         </p:txBody>
       </p:sp>
@@ -667,7 +466,7 @@
           <a:p>
             <a:fld id="{5BCAD085-E8A6-8845-BD4E-CB4CCA059FC4}" type="datetimeFigureOut">
               <a:rPr lang="en-US" smtClean="0"/>
-              <a:t>7/8/2026</a:t>
+              <a:t>1/27/13</a:t>
             </a:fld>
             <a:endParaRPr lang="en-US"/>
           </a:p>
@@ -766,9 +565,10 @@
           <a:lstStyle/>
           <a:p>
             <a:r>
-              <a:rPr lang="en-US"/>
+              <a:rPr lang="en-US" smtClean="0"/>
               <a:t>Click to edit Master title style</a:t>
             </a:r>
+            <a:endParaRPr lang="en-US"/>
           </a:p>
         </p:txBody>
       </p:sp>
@@ -794,37 +594,38 @@
           <a:p>
             <a:pPr lvl="0"/>
             <a:r>
-              <a:rPr lang="en-US"/>
+              <a:rPr lang="en-US" smtClean="0"/>
               <a:t>Click to edit Master text styles</a:t>
             </a:r>
           </a:p>
           <a:p>
             <a:pPr lvl="1"/>
             <a:r>
-              <a:rPr lang="en-US"/>
+              <a:rPr lang="en-US" smtClean="0"/>
               <a:t>Second level</a:t>
             </a:r>
           </a:p>
           <a:p>
             <a:pPr lvl="2"/>
             <a:r>
-              <a:rPr lang="en-US"/>
+              <a:rPr lang="en-US" smtClean="0"/>
               <a:t>Third level</a:t>
             </a:r>
           </a:p>
           <a:p>
             <a:pPr lvl="3"/>
             <a:r>
-              <a:rPr lang="en-US"/>
+              <a:rPr lang="en-US" smtClean="0"/>
               <a:t>Fourth level</a:t>
             </a:r>
           </a:p>
           <a:p>
             <a:pPr lvl="4"/>
             <a:r>
-              <a:rPr lang="en-US"/>
+              <a:rPr lang="en-US" smtClean="0"/>
               <a:t>Fifth level</a:t>
             </a:r>
+            <a:endParaRPr lang="en-US"/>
           </a:p>
         </p:txBody>
       </p:sp>
@@ -845,7 +646,7 @@
           <a:p>
             <a:fld id="{5BCAD085-E8A6-8845-BD4E-CB4CCA059FC4}" type="datetimeFigureOut">
               <a:rPr lang="en-US" smtClean="0"/>
-              <a:t>7/8/2026</a:t>
+              <a:t>1/27/13</a:t>
             </a:fld>
             <a:endParaRPr lang="en-US"/>
           </a:p>
@@ -939,9 +740,10 @@
           <a:lstStyle/>
           <a:p>
             <a:r>
-              <a:rPr lang="en-US"/>
+              <a:rPr lang="en-US" smtClean="0"/>
               <a:t>Click to edit Master title style</a:t>
             </a:r>
+            <a:endParaRPr lang="en-US"/>
           </a:p>
         </p:txBody>
       </p:sp>
@@ -962,37 +764,38 @@
           <a:p>
             <a:pPr lvl="0"/>
             <a:r>
-              <a:rPr lang="en-US"/>
+              <a:rPr lang="en-US" smtClean="0"/>
               <a:t>Click to edit Master text styles</a:t>
             </a:r>
           </a:p>
           <a:p>
             <a:pPr lvl="1"/>
             <a:r>
-              <a:rPr lang="en-US"/>
+              <a:rPr lang="en-US" smtClean="0"/>
               <a:t>Second level</a:t>
             </a:r>
           </a:p>
           <a:p>
             <a:pPr lvl="2"/>
             <a:r>
-              <a:rPr lang="en-US"/>
+              <a:rPr lang="en-US" smtClean="0"/>
               <a:t>Third level</a:t>
             </a:r>
           </a:p>
           <a:p>
             <a:pPr lvl="3"/>
             <a:r>
-              <a:rPr lang="en-US"/>
+              <a:rPr lang="en-US" smtClean="0"/>
               <a:t>Fourth level</a:t>
             </a:r>
           </a:p>
           <a:p>
             <a:pPr lvl="4"/>
             <a:r>
-              <a:rPr lang="en-US"/>
+              <a:rPr lang="en-US" smtClean="0"/>
               <a:t>Fifth level</a:t>
             </a:r>
+            <a:endParaRPr lang="en-US"/>
           </a:p>
         </p:txBody>
       </p:sp>
@@ -1013,7 +816,7 @@
           <a:p>
             <a:fld id="{5BCAD085-E8A6-8845-BD4E-CB4CCA059FC4}" type="datetimeFigureOut">
               <a:rPr lang="en-US" smtClean="0"/>
-              <a:t>7/8/2026</a:t>
+              <a:t>1/27/13</a:t>
             </a:fld>
             <a:endParaRPr lang="en-US"/>
           </a:p>
@@ -1116,9 +919,10 @@
           </a:lstStyle>
           <a:p>
             <a:r>
-              <a:rPr lang="en-US"/>
+              <a:rPr lang="en-US" smtClean="0"/>
               <a:t>Click to edit Master title style</a:t>
             </a:r>
+            <a:endParaRPr lang="en-US"/>
           </a:p>
         </p:txBody>
       </p:sp>
@@ -1235,7 +1039,7 @@
           <a:p>
             <a:pPr lvl="0"/>
             <a:r>
-              <a:rPr lang="en-US"/>
+              <a:rPr lang="en-US" smtClean="0"/>
               <a:t>Click to edit Master text styles</a:t>
             </a:r>
           </a:p>
@@ -1258,7 +1062,7 @@
           <a:p>
             <a:fld id="{5BCAD085-E8A6-8845-BD4E-CB4CCA059FC4}" type="datetimeFigureOut">
               <a:rPr lang="en-US" smtClean="0"/>
-              <a:t>7/8/2026</a:t>
+              <a:t>1/27/13</a:t>
             </a:fld>
             <a:endParaRPr lang="en-US"/>
           </a:p>
@@ -1352,9 +1156,10 @@
           <a:lstStyle/>
           <a:p>
             <a:r>
-              <a:rPr lang="en-US"/>
+              <a:rPr lang="en-US" smtClean="0"/>
               <a:t>Click to edit Master title style</a:t>
             </a:r>
+            <a:endParaRPr lang="en-US"/>
           </a:p>
         </p:txBody>
       </p:sp>
@@ -1408,37 +1213,38 @@
           <a:p>
             <a:pPr lvl="0"/>
             <a:r>
-              <a:rPr lang="en-US"/>
+              <a:rPr lang="en-US" smtClean="0"/>
               <a:t>Click to edit Master text styles</a:t>
             </a:r>
           </a:p>
           <a:p>
             <a:pPr lvl="1"/>
             <a:r>
-              <a:rPr lang="en-US"/>
+              <a:rPr lang="en-US" smtClean="0"/>
               <a:t>Second level</a:t>
             </a:r>
           </a:p>
           <a:p>
             <a:pPr lvl="2"/>
             <a:r>
-              <a:rPr lang="en-US"/>
+              <a:rPr lang="en-US" smtClean="0"/>
               <a:t>Third level</a:t>
             </a:r>
           </a:p>
           <a:p>
             <a:pPr lvl="3"/>
             <a:r>
-              <a:rPr lang="en-US"/>
+              <a:rPr lang="en-US" smtClean="0"/>
               <a:t>Fourth level</a:t>
             </a:r>
           </a:p>
           <a:p>
             <a:pPr lvl="4"/>
             <a:r>
-              <a:rPr lang="en-US"/>
+              <a:rPr lang="en-US" smtClean="0"/>
               <a:t>Fifth level</a:t>
             </a:r>
+            <a:endParaRPr lang="en-US"/>
           </a:p>
         </p:txBody>
       </p:sp>
@@ -1492,37 +1298,38 @@
           <a:p>
             <a:pPr lvl="0"/>
             <a:r>
-              <a:rPr lang="en-US"/>
+              <a:rPr lang="en-US" smtClean="0"/>
               <a:t>Click to edit Master text styles</a:t>
             </a:r>
           </a:p>
           <a:p>
             <a:pPr lvl="1"/>
             <a:r>
-              <a:rPr lang="en-US"/>
+              <a:rPr lang="en-US" smtClean="0"/>
               <a:t>Second level</a:t>
             </a:r>
           </a:p>
           <a:p>
             <a:pPr lvl="2"/>
             <a:r>
-              <a:rPr lang="en-US"/>
+              <a:rPr lang="en-US" smtClean="0"/>
               <a:t>Third level</a:t>
             </a:r>
           </a:p>
           <a:p>
             <a:pPr lvl="3"/>
             <a:r>
-              <a:rPr lang="en-US"/>
+              <a:rPr lang="en-US" smtClean="0"/>
               <a:t>Fourth level</a:t>
             </a:r>
           </a:p>
           <a:p>
             <a:pPr lvl="4"/>
             <a:r>
-              <a:rPr lang="en-US"/>
+              <a:rPr lang="en-US" smtClean="0"/>
               <a:t>Fifth level</a:t>
             </a:r>
+            <a:endParaRPr lang="en-US"/>
           </a:p>
         </p:txBody>
       </p:sp>
@@ -1543,7 +1350,7 @@
           <a:p>
             <a:fld id="{5BCAD085-E8A6-8845-BD4E-CB4CCA059FC4}" type="datetimeFigureOut">
               <a:rPr lang="en-US" smtClean="0"/>
-              <a:t>7/8/2026</a:t>
+              <a:t>1/27/13</a:t>
             </a:fld>
             <a:endParaRPr lang="en-US"/>
           </a:p>
@@ -1641,9 +1448,10 @@
           </a:lstStyle>
           <a:p>
             <a:r>
-              <a:rPr lang="en-US"/>
+              <a:rPr lang="en-US" smtClean="0"/>
               <a:t>Click to edit Master title style</a:t>
             </a:r>
+            <a:endParaRPr lang="en-US"/>
           </a:p>
         </p:txBody>
       </p:sp>
@@ -1706,7 +1514,7 @@
           <a:p>
             <a:pPr lvl="0"/>
             <a:r>
-              <a:rPr lang="en-US"/>
+              <a:rPr lang="en-US" smtClean="0"/>
               <a:t>Click to edit Master text styles</a:t>
             </a:r>
           </a:p>
@@ -1762,37 +1570,38 @@
           <a:p>
             <a:pPr lvl="0"/>
             <a:r>
-              <a:rPr lang="en-US"/>
+              <a:rPr lang="en-US" smtClean="0"/>
               <a:t>Click to edit Master text styles</a:t>
             </a:r>
           </a:p>
           <a:p>
             <a:pPr lvl="1"/>
             <a:r>
-              <a:rPr lang="en-US"/>
+              <a:rPr lang="en-US" smtClean="0"/>
               <a:t>Second level</a:t>
             </a:r>
           </a:p>
           <a:p>
             <a:pPr lvl="2"/>
             <a:r>
-              <a:rPr lang="en-US"/>
+              <a:rPr lang="en-US" smtClean="0"/>
               <a:t>Third level</a:t>
             </a:r>
           </a:p>
           <a:p>
             <a:pPr lvl="3"/>
             <a:r>
-              <a:rPr lang="en-US"/>
+              <a:rPr lang="en-US" smtClean="0"/>
               <a:t>Fourth level</a:t>
             </a:r>
           </a:p>
           <a:p>
             <a:pPr lvl="4"/>
             <a:r>
-              <a:rPr lang="en-US"/>
+              <a:rPr lang="en-US" smtClean="0"/>
               <a:t>Fifth level</a:t>
             </a:r>
+            <a:endParaRPr lang="en-US"/>
           </a:p>
         </p:txBody>
       </p:sp>
@@ -1855,7 +1664,7 @@
           <a:p>
             <a:pPr lvl="0"/>
             <a:r>
-              <a:rPr lang="en-US"/>
+              <a:rPr lang="en-US" smtClean="0"/>
               <a:t>Click to edit Master text styles</a:t>
             </a:r>
           </a:p>
@@ -1911,37 +1720,38 @@
           <a:p>
             <a:pPr lvl="0"/>
             <a:r>
-              <a:rPr lang="en-US"/>
+              <a:rPr lang="en-US" smtClean="0"/>
               <a:t>Click to edit Master text styles</a:t>
             </a:r>
           </a:p>
           <a:p>
             <a:pPr lvl="1"/>
             <a:r>
-              <a:rPr lang="en-US"/>
+              <a:rPr lang="en-US" smtClean="0"/>
               <a:t>Second level</a:t>
             </a:r>
           </a:p>
           <a:p>
             <a:pPr lvl="2"/>
             <a:r>
-              <a:rPr lang="en-US"/>
+              <a:rPr lang="en-US" smtClean="0"/>
               <a:t>Third level</a:t>
             </a:r>
           </a:p>
           <a:p>
             <a:pPr lvl="3"/>
             <a:r>
-              <a:rPr lang="en-US"/>
+              <a:rPr lang="en-US" smtClean="0"/>
               <a:t>Fourth level</a:t>
             </a:r>
           </a:p>
           <a:p>
             <a:pPr lvl="4"/>
             <a:r>
-              <a:rPr lang="en-US"/>
+              <a:rPr lang="en-US" smtClean="0"/>
               <a:t>Fifth level</a:t>
             </a:r>
+            <a:endParaRPr lang="en-US"/>
           </a:p>
         </p:txBody>
       </p:sp>
@@ -1962,7 +1772,7 @@
           <a:p>
             <a:fld id="{5BCAD085-E8A6-8845-BD4E-CB4CCA059FC4}" type="datetimeFigureOut">
               <a:rPr lang="en-US" smtClean="0"/>
-              <a:t>7/8/2026</a:t>
+              <a:t>1/27/13</a:t>
             </a:fld>
             <a:endParaRPr lang="en-US"/>
           </a:p>
@@ -2056,9 +1866,10 @@
           <a:lstStyle/>
           <a:p>
             <a:r>
-              <a:rPr lang="en-US"/>
+              <a:rPr lang="en-US" smtClean="0"/>
               <a:t>Click to edit Master title style</a:t>
             </a:r>
+            <a:endParaRPr lang="en-US"/>
           </a:p>
         </p:txBody>
       </p:sp>
@@ -2079,7 +1890,7 @@
           <a:p>
             <a:fld id="{5BCAD085-E8A6-8845-BD4E-CB4CCA059FC4}" type="datetimeFigureOut">
               <a:rPr lang="en-US" smtClean="0"/>
-              <a:t>7/8/2026</a:t>
+              <a:t>1/27/13</a:t>
             </a:fld>
             <a:endParaRPr lang="en-US"/>
           </a:p>
@@ -2174,7 +1985,7 @@
           <a:p>
             <a:fld id="{5BCAD085-E8A6-8845-BD4E-CB4CCA059FC4}" type="datetimeFigureOut">
               <a:rPr lang="en-US" smtClean="0"/>
-              <a:t>7/8/2026</a:t>
+              <a:t>1/27/13</a:t>
             </a:fld>
             <a:endParaRPr lang="en-US"/>
           </a:p>
@@ -2277,9 +2088,10 @@
           </a:lstStyle>
           <a:p>
             <a:r>
-              <a:rPr lang="en-US"/>
+              <a:rPr lang="en-US" smtClean="0"/>
               <a:t>Click to edit Master title style</a:t>
             </a:r>
+            <a:endParaRPr lang="en-US"/>
           </a:p>
         </p:txBody>
       </p:sp>
@@ -2333,37 +2145,38 @@
           <a:p>
             <a:pPr lvl="0"/>
             <a:r>
-              <a:rPr lang="en-US"/>
+              <a:rPr lang="en-US" smtClean="0"/>
               <a:t>Click to edit Master text styles</a:t>
             </a:r>
           </a:p>
           <a:p>
             <a:pPr lvl="1"/>
             <a:r>
-              <a:rPr lang="en-US"/>
+              <a:rPr lang="en-US" smtClean="0"/>
               <a:t>Second level</a:t>
             </a:r>
           </a:p>
           <a:p>
             <a:pPr lvl="2"/>
             <a:r>
-              <a:rPr lang="en-US"/>
+              <a:rPr lang="en-US" smtClean="0"/>
               <a:t>Third level</a:t>
             </a:r>
           </a:p>
           <a:p>
             <a:pPr lvl="3"/>
             <a:r>
-              <a:rPr lang="en-US"/>
+              <a:rPr lang="en-US" smtClean="0"/>
               <a:t>Fourth level</a:t>
             </a:r>
           </a:p>
           <a:p>
             <a:pPr lvl="4"/>
             <a:r>
-              <a:rPr lang="en-US"/>
+              <a:rPr lang="en-US" smtClean="0"/>
               <a:t>Fifth level</a:t>
             </a:r>
+            <a:endParaRPr lang="en-US"/>
           </a:p>
         </p:txBody>
       </p:sp>
@@ -2426,7 +2239,7 @@
           <a:p>
             <a:pPr lvl="0"/>
             <a:r>
-              <a:rPr lang="en-US"/>
+              <a:rPr lang="en-US" smtClean="0"/>
               <a:t>Click to edit Master text styles</a:t>
             </a:r>
           </a:p>
@@ -2449,7 +2262,7 @@
           <a:p>
             <a:fld id="{5BCAD085-E8A6-8845-BD4E-CB4CCA059FC4}" type="datetimeFigureOut">
               <a:rPr lang="en-US" smtClean="0"/>
-              <a:t>7/8/2026</a:t>
+              <a:t>1/27/13</a:t>
             </a:fld>
             <a:endParaRPr lang="en-US"/>
           </a:p>
@@ -2552,9 +2365,10 @@
           </a:lstStyle>
           <a:p>
             <a:r>
-              <a:rPr lang="en-US"/>
+              <a:rPr lang="en-US" smtClean="0"/>
               <a:t>Click to edit Master title style</a:t>
             </a:r>
+            <a:endParaRPr lang="en-US"/>
           </a:p>
         </p:txBody>
       </p:sp>
@@ -2678,7 +2492,7 @@
           <a:p>
             <a:pPr lvl="0"/>
             <a:r>
-              <a:rPr lang="en-US"/>
+              <a:rPr lang="en-US" smtClean="0"/>
               <a:t>Click to edit Master text styles</a:t>
             </a:r>
           </a:p>
@@ -2701,7 +2515,7 @@
           <a:p>
             <a:fld id="{5BCAD085-E8A6-8845-BD4E-CB4CCA059FC4}" type="datetimeFigureOut">
               <a:rPr lang="en-US" smtClean="0"/>
-              <a:t>7/8/2026</a:t>
+              <a:t>1/27/13</a:t>
             </a:fld>
             <a:endParaRPr lang="en-US"/>
           </a:p>
@@ -2810,9 +2624,10 @@
           <a:lstStyle/>
           <a:p>
             <a:r>
-              <a:rPr lang="en-US"/>
+              <a:rPr lang="en-US" smtClean="0"/>
               <a:t>Click to edit Master title style</a:t>
             </a:r>
+            <a:endParaRPr lang="en-US"/>
           </a:p>
         </p:txBody>
       </p:sp>
@@ -2843,37 +2658,38 @@
           <a:p>
             <a:pPr lvl="0"/>
             <a:r>
-              <a:rPr lang="en-US"/>
+              <a:rPr lang="en-US" smtClean="0"/>
               <a:t>Click to edit Master text styles</a:t>
             </a:r>
           </a:p>
           <a:p>
             <a:pPr lvl="1"/>
             <a:r>
-              <a:rPr lang="en-US"/>
+              <a:rPr lang="en-US" smtClean="0"/>
               <a:t>Second level</a:t>
             </a:r>
           </a:p>
           <a:p>
             <a:pPr lvl="2"/>
             <a:r>
-              <a:rPr lang="en-US"/>
+              <a:rPr lang="en-US" smtClean="0"/>
               <a:t>Third level</a:t>
             </a:r>
           </a:p>
           <a:p>
             <a:pPr lvl="3"/>
             <a:r>
-              <a:rPr lang="en-US"/>
+              <a:rPr lang="en-US" smtClean="0"/>
               <a:t>Fourth level</a:t>
             </a:r>
           </a:p>
           <a:p>
             <a:pPr lvl="4"/>
             <a:r>
-              <a:rPr lang="en-US"/>
+              <a:rPr lang="en-US" smtClean="0"/>
               <a:t>Fifth level</a:t>
             </a:r>
+            <a:endParaRPr lang="en-US"/>
           </a:p>
         </p:txBody>
       </p:sp>
@@ -2912,7 +2728,7 @@
           <a:p>
             <a:fld id="{5BCAD085-E8A6-8845-BD4E-CB4CCA059FC4}" type="datetimeFigureOut">
               <a:rPr lang="en-US" smtClean="0"/>
-              <a:t>7/8/2026</a:t>
+              <a:t>1/27/13</a:t>
             </a:fld>
             <a:endParaRPr lang="en-US"/>
           </a:p>
@@ -3271,7 +3087,7 @@
 </file>
 
 <file path=ppt/slides/slide1.xml><?xml version="1.0" encoding="utf-8"?>
-<p:sld xmlns:a="http://schemas.openxmlformats.org/drawingml/2006/main" xmlns:r="http://schemas.openxmlformats.org/officeDocument/2006/relationships" xmlns:p="http://schemas.openxmlformats.org/presentationml/2006/main">
+<p:sld xmlns:a="http://schemas.openxmlformats.org/drawingml/2006/main" xmlns:p="http://schemas.openxmlformats.org/presentationml/2006/main" xmlns:r="http://schemas.openxmlformats.org/officeDocument/2006/relationships">
   <p:cSld>
     <p:bg>
       <p:bgPr>
@@ -3287,14 +3103,7 @@
         <p:cNvGrpSpPr/>
         <p:nvPr/>
       </p:nvGrpSpPr>
-      <p:grpSpPr>
-        <a:xfrm>
-          <a:off x="0" y="0"/>
-          <a:ext cx="0" cy="0"/>
-          <a:chOff x="0" y="0"/>
-          <a:chExt cx="0" cy="0"/>
-        </a:xfrm>
-      </p:grpSpPr>
+      <p:grpSpPr/>
       <p:sp>
         <p:nvSpPr>
           <p:cNvPr id="2" name="TextBox 1"/>
@@ -3312,7 +3121,7 @@
           <a:noFill/>
         </p:spPr>
         <p:txBody>
-          <a:bodyPr wrap="square" lIns="27432" tIns="18288" rIns="27432" bIns="18288" anchor="t">
+          <a:bodyPr wrap="square" anchor="t" lIns="27432" rIns="27432" tIns="18288" bIns="18288">
             <a:spAutoFit/>
           </a:bodyPr>
           <a:lstStyle/>
@@ -3351,7 +3160,7 @@
           <a:noFill/>
         </p:spPr>
         <p:txBody>
-          <a:bodyPr wrap="square" lIns="27432" tIns="18288" rIns="27432" bIns="18288" anchor="t">
+          <a:bodyPr wrap="square" anchor="t" lIns="27432" rIns="27432" tIns="18288" bIns="18288">
             <a:spAutoFit/>
           </a:bodyPr>
           <a:lstStyle/>
@@ -3390,7 +3199,7 @@
           <a:noFill/>
         </p:spPr>
         <p:txBody>
-          <a:bodyPr wrap="square" lIns="27432" tIns="18288" rIns="27432" bIns="18288" anchor="t">
+          <a:bodyPr wrap="square" anchor="t" lIns="27432" rIns="27432" tIns="18288" bIns="18288">
             <a:spAutoFit/>
           </a:bodyPr>
           <a:lstStyle/>
@@ -3421,7 +3230,7 @@
         <p:spPr>
           <a:xfrm>
             <a:off x="502920" y="4434840"/>
-            <a:ext cx="11185855" cy="283154"/>
+            <a:ext cx="11185855" cy="365760"/>
           </a:xfrm>
           <a:prstGeom prst="rect">
             <a:avLst/>
@@ -3429,7 +3238,7 @@
           <a:noFill/>
         </p:spPr>
         <p:txBody>
-          <a:bodyPr wrap="square" lIns="27432" tIns="18288" rIns="27432" bIns="18288" anchor="t">
+          <a:bodyPr wrap="square" anchor="t" lIns="27432" rIns="27432" tIns="18288" bIns="18288">
             <a:spAutoFit/>
           </a:bodyPr>
           <a:lstStyle/>
@@ -3440,40 +3249,13 @@
               </a:lnSpc>
             </a:pPr>
             <a:r>
-              <a:rPr sz="1600" b="1" dirty="0">
+              <a:rPr sz="1600" b="1">
                 <a:solidFill>
                   <a:srgbClr val="FDFBF5"/>
                 </a:solidFill>
                 <a:latin typeface="Segoe UI"/>
               </a:rPr>
-              <a:t>Presented by </a:t>
-            </a:r>
-            <a:r>
-              <a:rPr lang="en-US" sz="1600" b="1" dirty="0">
-                <a:solidFill>
-                  <a:srgbClr val="FDFBF5"/>
-                </a:solidFill>
-                <a:latin typeface="Segoe UI"/>
-              </a:rPr>
-              <a:t>Hammad &amp; </a:t>
-            </a:r>
-            <a:r>
-              <a:rPr sz="1600" b="1" dirty="0" err="1">
-                <a:solidFill>
-                  <a:srgbClr val="FDFBF5"/>
-                </a:solidFill>
-                <a:latin typeface="Segoe UI"/>
-              </a:rPr>
-              <a:t>Zuraiz</a:t>
-            </a:r>
-            <a:r>
-              <a:rPr sz="1600" b="1" dirty="0">
-                <a:solidFill>
-                  <a:srgbClr val="FDFBF5"/>
-                </a:solidFill>
-                <a:latin typeface="Segoe UI"/>
-              </a:rPr>
-              <a:t>, on behalf of the team</a:t>
+              <a:t>Presented by Zuraiz, on behalf of the team</a:t>
             </a:r>
           </a:p>
         </p:txBody>
@@ -3495,7 +3277,7 @@
           <a:noFill/>
         </p:spPr>
         <p:txBody>
-          <a:bodyPr wrap="square" lIns="27432" tIns="18288" rIns="27432" bIns="18288" anchor="t">
+          <a:bodyPr wrap="square" anchor="t" lIns="27432" rIns="27432" tIns="18288" bIns="18288">
             <a:spAutoFit/>
           </a:bodyPr>
           <a:lstStyle/>
@@ -3534,7 +3316,7 @@
           <a:noFill/>
         </p:spPr>
         <p:txBody>
-          <a:bodyPr wrap="square" lIns="27432" tIns="18288" rIns="27432" bIns="18288" anchor="t">
+          <a:bodyPr wrap="square" anchor="t" lIns="27432" rIns="27432" tIns="18288" bIns="18288">
             <a:spAutoFit/>
           </a:bodyPr>
           <a:lstStyle/>
@@ -3565,7 +3347,7 @@
 </file>
 
 <file path=ppt/slides/slide2.xml><?xml version="1.0" encoding="utf-8"?>
-<p:sld xmlns:a="http://schemas.openxmlformats.org/drawingml/2006/main" xmlns:r="http://schemas.openxmlformats.org/officeDocument/2006/relationships" xmlns:p="http://schemas.openxmlformats.org/presentationml/2006/main">
+<p:sld xmlns:a="http://schemas.openxmlformats.org/drawingml/2006/main" xmlns:p="http://schemas.openxmlformats.org/presentationml/2006/main" xmlns:r="http://schemas.openxmlformats.org/officeDocument/2006/relationships">
   <p:cSld>
     <p:bg>
       <p:bgPr>
@@ -3581,14 +3363,7 @@
         <p:cNvGrpSpPr/>
         <p:nvPr/>
       </p:nvGrpSpPr>
-      <p:grpSpPr>
-        <a:xfrm>
-          <a:off x="0" y="0"/>
-          <a:ext cx="0" cy="0"/>
-          <a:chOff x="0" y="0"/>
-          <a:chExt cx="0" cy="0"/>
-        </a:xfrm>
-      </p:grpSpPr>
+      <p:grpSpPr/>
       <p:sp>
         <p:nvSpPr>
           <p:cNvPr id="2" name="TextBox 1"/>
@@ -3606,7 +3381,7 @@
           <a:noFill/>
         </p:spPr>
         <p:txBody>
-          <a:bodyPr wrap="square" lIns="27432" tIns="18288" rIns="27432" bIns="18288" anchor="t">
+          <a:bodyPr wrap="square" anchor="t" lIns="27432" rIns="27432" tIns="18288" bIns="18288">
             <a:spAutoFit/>
           </a:bodyPr>
           <a:lstStyle/>
@@ -3645,7 +3420,7 @@
           <a:noFill/>
         </p:spPr>
         <p:txBody>
-          <a:bodyPr wrap="square" lIns="27432" tIns="18288" rIns="27432" bIns="18288" anchor="t">
+          <a:bodyPr wrap="square" anchor="t" lIns="27432" rIns="27432" tIns="18288" bIns="18288">
             <a:spAutoFit/>
           </a:bodyPr>
           <a:lstStyle/>
@@ -3684,7 +3459,7 @@
           <a:noFill/>
         </p:spPr>
         <p:txBody>
-          <a:bodyPr wrap="square" lIns="27432" tIns="18288" rIns="27432" bIns="18288" anchor="t">
+          <a:bodyPr wrap="square" anchor="t" lIns="27432" rIns="27432" tIns="18288" bIns="18288">
             <a:spAutoFit/>
           </a:bodyPr>
           <a:lstStyle/>
@@ -3723,7 +3498,7 @@
           <a:noFill/>
         </p:spPr>
         <p:txBody>
-          <a:bodyPr wrap="square" lIns="27432" tIns="18288" rIns="27432" bIns="18288" anchor="t">
+          <a:bodyPr wrap="square" anchor="t" lIns="27432" rIns="27432" tIns="18288" bIns="18288">
             <a:spAutoFit/>
           </a:bodyPr>
           <a:lstStyle/>
@@ -3762,7 +3537,7 @@
           <a:noFill/>
         </p:spPr>
         <p:txBody>
-          <a:bodyPr wrap="square" lIns="27432" tIns="18288" rIns="27432" bIns="18288" anchor="t">
+          <a:bodyPr wrap="square" anchor="t" lIns="27432" rIns="27432" tIns="18288" bIns="18288">
             <a:spAutoFit/>
           </a:bodyPr>
           <a:lstStyle/>
@@ -3824,7 +3599,7 @@
           </a:fontRef>
         </p:style>
         <p:txBody>
-          <a:bodyPr wrap="square" lIns="201168" tIns="146304" rIns="201168" rtlCol="0" anchor="t"/>
+          <a:bodyPr rtlCol="0" anchor="t" wrap="square" lIns="201168" rIns="201168" tIns="146304"/>
           <a:lstStyle/>
           <a:p>
             <a:pPr algn="l" latinLnBrk="0">
@@ -3900,7 +3675,7 @@
           </a:fontRef>
         </p:style>
         <p:txBody>
-          <a:bodyPr wrap="square" lIns="201168" tIns="146304" rIns="201168" rtlCol="0" anchor="t"/>
+          <a:bodyPr rtlCol="0" anchor="t" wrap="square" lIns="201168" rIns="201168" tIns="146304"/>
           <a:lstStyle/>
           <a:p>
             <a:pPr algn="l" latinLnBrk="0">
@@ -3976,7 +3751,7 @@
           </a:fontRef>
         </p:style>
         <p:txBody>
-          <a:bodyPr wrap="square" lIns="201168" tIns="146304" rIns="201168" rtlCol="0" anchor="t"/>
+          <a:bodyPr rtlCol="0" anchor="t" wrap="square" lIns="201168" rIns="201168" tIns="146304"/>
           <a:lstStyle/>
           <a:p>
             <a:pPr algn="l" latinLnBrk="0">
@@ -4052,7 +3827,7 @@
           </a:fontRef>
         </p:style>
         <p:txBody>
-          <a:bodyPr wrap="square" lIns="201168" tIns="146304" rIns="201168" rtlCol="0" anchor="t"/>
+          <a:bodyPr rtlCol="0" anchor="t" wrap="square" lIns="201168" rIns="201168" tIns="146304"/>
           <a:lstStyle/>
           <a:p>
             <a:pPr algn="l" latinLnBrk="0">
@@ -4096,7 +3871,7 @@
         </p:nvSpPr>
         <p:spPr>
           <a:xfrm>
-            <a:off x="502920" y="5964534"/>
+            <a:off x="502920" y="6144768"/>
             <a:ext cx="11185855" cy="475488"/>
           </a:xfrm>
           <a:prstGeom prst="roundRect">
@@ -4126,7 +3901,7 @@
           </a:fontRef>
         </p:style>
         <p:txBody>
-          <a:bodyPr wrap="square" rtlCol="0" anchor="ctr"/>
+          <a:bodyPr rtlCol="0" anchor="ctr" wrap="square"/>
           <a:lstStyle/>
           <a:p>
             <a:pPr algn="ctr" latinLnBrk="0"/>
@@ -4151,7 +3926,7 @@
 </file>
 
 <file path=ppt/slides/slide3.xml><?xml version="1.0" encoding="utf-8"?>
-<p:sld xmlns:a="http://schemas.openxmlformats.org/drawingml/2006/main" xmlns:r="http://schemas.openxmlformats.org/officeDocument/2006/relationships" xmlns:p="http://schemas.openxmlformats.org/presentationml/2006/main">
+<p:sld xmlns:a="http://schemas.openxmlformats.org/drawingml/2006/main" xmlns:p="http://schemas.openxmlformats.org/presentationml/2006/main" xmlns:r="http://schemas.openxmlformats.org/officeDocument/2006/relationships">
   <p:cSld>
     <p:bg>
       <p:bgPr>
@@ -4167,14 +3942,7 @@
         <p:cNvGrpSpPr/>
         <p:nvPr/>
       </p:nvGrpSpPr>
-      <p:grpSpPr>
-        <a:xfrm>
-          <a:off x="0" y="0"/>
-          <a:ext cx="0" cy="0"/>
-          <a:chOff x="0" y="0"/>
-          <a:chExt cx="0" cy="0"/>
-        </a:xfrm>
-      </p:grpSpPr>
+      <p:grpSpPr/>
       <p:sp>
         <p:nvSpPr>
           <p:cNvPr id="2" name="TextBox 1"/>
@@ -4192,7 +3960,7 @@
           <a:noFill/>
         </p:spPr>
         <p:txBody>
-          <a:bodyPr wrap="square" lIns="27432" tIns="18288" rIns="27432" bIns="18288" anchor="t">
+          <a:bodyPr wrap="square" anchor="t" lIns="27432" rIns="27432" tIns="18288" bIns="18288">
             <a:spAutoFit/>
           </a:bodyPr>
           <a:lstStyle/>
@@ -4231,7 +3999,7 @@
           <a:noFill/>
         </p:spPr>
         <p:txBody>
-          <a:bodyPr wrap="square" lIns="27432" tIns="18288" rIns="27432" bIns="18288" anchor="t">
+          <a:bodyPr wrap="square" anchor="t" lIns="27432" rIns="27432" tIns="18288" bIns="18288">
             <a:spAutoFit/>
           </a:bodyPr>
           <a:lstStyle/>
@@ -4270,7 +4038,7 @@
           <a:noFill/>
         </p:spPr>
         <p:txBody>
-          <a:bodyPr wrap="square" lIns="27432" tIns="18288" rIns="27432" bIns="18288" anchor="t">
+          <a:bodyPr wrap="square" anchor="t" lIns="27432" rIns="27432" tIns="18288" bIns="18288">
             <a:spAutoFit/>
           </a:bodyPr>
           <a:lstStyle/>
@@ -4309,7 +4077,7 @@
           <a:noFill/>
         </p:spPr>
         <p:txBody>
-          <a:bodyPr wrap="square" lIns="27432" tIns="18288" rIns="27432" bIns="18288" anchor="t">
+          <a:bodyPr wrap="square" anchor="t" lIns="27432" rIns="27432" tIns="18288" bIns="18288">
             <a:spAutoFit/>
           </a:bodyPr>
           <a:lstStyle/>
@@ -4348,7 +4116,7 @@
           <a:noFill/>
         </p:spPr>
         <p:txBody>
-          <a:bodyPr wrap="square" lIns="27432" tIns="18288" rIns="27432" bIns="18288" anchor="t">
+          <a:bodyPr wrap="square" anchor="t" lIns="27432" rIns="27432" tIns="18288" bIns="18288">
             <a:spAutoFit/>
           </a:bodyPr>
           <a:lstStyle/>
@@ -4378,8 +4146,8 @@
         </p:nvSpPr>
         <p:spPr>
           <a:xfrm>
-            <a:off x="502920" y="1874518"/>
-            <a:ext cx="11185855" cy="764759"/>
+            <a:off x="502920" y="1874519"/>
+            <a:ext cx="11185855" cy="658368"/>
           </a:xfrm>
           <a:prstGeom prst="roundRect">
             <a:avLst>
@@ -4410,7 +4178,7 @@
           </a:fontRef>
         </p:style>
         <p:txBody>
-          <a:bodyPr wrap="square" lIns="201168" tIns="146304" rIns="201168" rtlCol="0" anchor="t"/>
+          <a:bodyPr rtlCol="0" anchor="t" wrap="square" lIns="201168" rIns="201168" tIns="146304"/>
           <a:lstStyle/>
           <a:p>
             <a:pPr algn="l" latinLnBrk="0">
@@ -4454,8 +4222,8 @@
         </p:nvSpPr>
         <p:spPr>
           <a:xfrm>
-            <a:off x="502920" y="2773852"/>
-            <a:ext cx="11185855" cy="764759"/>
+            <a:off x="502920" y="2624327"/>
+            <a:ext cx="11185855" cy="658368"/>
           </a:xfrm>
           <a:prstGeom prst="roundRect">
             <a:avLst>
@@ -4486,7 +4254,7 @@
           </a:fontRef>
         </p:style>
         <p:txBody>
-          <a:bodyPr wrap="square" lIns="201168" tIns="146304" rIns="201168" rtlCol="0" anchor="t"/>
+          <a:bodyPr rtlCol="0" anchor="t" wrap="square" lIns="201168" rIns="201168" tIns="146304"/>
           <a:lstStyle/>
           <a:p>
             <a:pPr algn="l" latinLnBrk="0">
@@ -4530,8 +4298,8 @@
         </p:nvSpPr>
         <p:spPr>
           <a:xfrm>
-            <a:off x="503072" y="3681034"/>
-            <a:ext cx="11185855" cy="798865"/>
+            <a:off x="502920" y="3374135"/>
+            <a:ext cx="11185855" cy="658368"/>
           </a:xfrm>
           <a:prstGeom prst="roundRect">
             <a:avLst>
@@ -4562,7 +4330,7 @@
           </a:fontRef>
         </p:style>
         <p:txBody>
-          <a:bodyPr wrap="square" lIns="201168" tIns="146304" rIns="201168" rtlCol="0" anchor="t"/>
+          <a:bodyPr rtlCol="0" anchor="t" wrap="square" lIns="201168" rIns="201168" tIns="146304"/>
           <a:lstStyle/>
           <a:p>
             <a:pPr algn="l" latinLnBrk="0">
@@ -4606,8 +4374,8 @@
         </p:nvSpPr>
         <p:spPr>
           <a:xfrm>
-            <a:off x="502632" y="4616570"/>
-            <a:ext cx="11185855" cy="798865"/>
+            <a:off x="502920" y="4123943"/>
+            <a:ext cx="11185855" cy="658368"/>
           </a:xfrm>
           <a:prstGeom prst="roundRect">
             <a:avLst>
@@ -4638,7 +4406,7 @@
           </a:fontRef>
         </p:style>
         <p:txBody>
-          <a:bodyPr wrap="square" lIns="201168" tIns="146304" rIns="201168" rtlCol="0" anchor="t"/>
+          <a:bodyPr rtlCol="0" anchor="t" wrap="square" lIns="201168" rIns="201168" tIns="146304"/>
           <a:lstStyle/>
           <a:p>
             <a:pPr algn="l" latinLnBrk="0">
@@ -4647,7 +4415,7 @@
               </a:spcAft>
             </a:pPr>
             <a:r>
-              <a:rPr sz="1400" b="1" dirty="0">
+              <a:rPr sz="1400" b="1">
                 <a:solidFill>
                   <a:srgbClr val="0E4D5E"/>
                 </a:solidFill>
@@ -4663,13 +4431,89 @@
               </a:spcAft>
             </a:pPr>
             <a:r>
-              <a:rPr sz="1250" b="0" dirty="0">
+              <a:rPr sz="1250" b="0">
                 <a:solidFill>
                   <a:srgbClr val="24262E"/>
                 </a:solidFill>
                 <a:latin typeface="Segoe UI"/>
               </a:rPr>
               <a:t>Open because the needed paired audio-video data is unavailable.</a:t>
+            </a:r>
+          </a:p>
+        </p:txBody>
+      </p:sp>
+      <p:sp>
+        <p:nvSpPr>
+          <p:cNvPr id="11" name="Rounded Rectangle 10"/>
+          <p:cNvSpPr/>
+          <p:nvPr/>
+        </p:nvSpPr>
+        <p:spPr>
+          <a:xfrm>
+            <a:off x="502920" y="4873751"/>
+            <a:ext cx="11185855" cy="658368"/>
+          </a:xfrm>
+          <a:prstGeom prst="roundRect">
+            <a:avLst>
+              <a:gd name="adj" fmla="val 4000"/>
+            </a:avLst>
+          </a:prstGeom>
+          <a:solidFill>
+            <a:srgbClr val="FDFBF5"/>
+          </a:solidFill>
+          <a:ln w="12700">
+            <a:solidFill>
+              <a:srgbClr val="CBD9DD"/>
+            </a:solidFill>
+          </a:ln>
+        </p:spPr>
+        <p:style>
+          <a:lnRef idx="1">
+            <a:schemeClr val="accent1"/>
+          </a:lnRef>
+          <a:fillRef idx="3">
+            <a:schemeClr val="accent1"/>
+          </a:fillRef>
+          <a:effectRef idx="2">
+            <a:schemeClr val="accent1"/>
+          </a:effectRef>
+          <a:fontRef idx="minor">
+            <a:schemeClr val="lt1"/>
+          </a:fontRef>
+        </p:style>
+        <p:txBody>
+          <a:bodyPr rtlCol="0" anchor="t" wrap="square" lIns="201168" rIns="201168" tIns="146304"/>
+          <a:lstStyle/>
+          <a:p>
+            <a:pPr algn="l" latinLnBrk="0">
+              <a:spcAft>
+                <a:spcPts val="600"/>
+              </a:spcAft>
+            </a:pPr>
+            <a:r>
+              <a:rPr sz="1400" b="1">
+                <a:solidFill>
+                  <a:srgbClr val="0E4D5E"/>
+                </a:solidFill>
+                <a:latin typeface="Segoe UI Semibold"/>
+              </a:rPr>
+              <a:t>Status VI</a:t>
+            </a:r>
+          </a:p>
+          <a:p>
+            <a:pPr algn="l" latinLnBrk="0">
+              <a:spcAft>
+                <a:spcPts val="400"/>
+              </a:spcAft>
+            </a:pPr>
+            <a:r>
+              <a:rPr sz="1250" b="0">
+                <a:solidFill>
+                  <a:srgbClr val="24262E"/>
+                </a:solidFill>
+                <a:latin typeface="Segoe UI"/>
+              </a:rPr>
+              <a:t>Slides, script, and Q&amp;A notes are prepared.</a:t>
             </a:r>
           </a:p>
         </p:txBody>
@@ -4682,7 +4526,7 @@
         </p:nvSpPr>
         <p:spPr>
           <a:xfrm>
-            <a:off x="502920" y="5977989"/>
+            <a:off x="502920" y="6144768"/>
             <a:ext cx="11185855" cy="475488"/>
           </a:xfrm>
           <a:prstGeom prst="roundRect">
@@ -4712,7 +4556,7 @@
           </a:fontRef>
         </p:style>
         <p:txBody>
-          <a:bodyPr wrap="square" rtlCol="0" anchor="ctr"/>
+          <a:bodyPr rtlCol="0" anchor="ctr" wrap="square"/>
           <a:lstStyle/>
           <a:p>
             <a:pPr algn="ctr" latinLnBrk="0"/>
@@ -4737,7 +4581,7 @@
 </file>
 
 <file path=ppt/slides/slide4.xml><?xml version="1.0" encoding="utf-8"?>
-<p:sld xmlns:a="http://schemas.openxmlformats.org/drawingml/2006/main" xmlns:r="http://schemas.openxmlformats.org/officeDocument/2006/relationships" xmlns:p="http://schemas.openxmlformats.org/presentationml/2006/main">
+<p:sld xmlns:a="http://schemas.openxmlformats.org/drawingml/2006/main" xmlns:p="http://schemas.openxmlformats.org/presentationml/2006/main" xmlns:r="http://schemas.openxmlformats.org/officeDocument/2006/relationships">
   <p:cSld>
     <p:bg>
       <p:bgPr>
@@ -4753,14 +4597,7 @@
         <p:cNvGrpSpPr/>
         <p:nvPr/>
       </p:nvGrpSpPr>
-      <p:grpSpPr>
-        <a:xfrm>
-          <a:off x="0" y="0"/>
-          <a:ext cx="0" cy="0"/>
-          <a:chOff x="0" y="0"/>
-          <a:chExt cx="0" cy="0"/>
-        </a:xfrm>
-      </p:grpSpPr>
+      <p:grpSpPr/>
       <p:sp>
         <p:nvSpPr>
           <p:cNvPr id="2" name="TextBox 1"/>
@@ -4778,7 +4615,7 @@
           <a:noFill/>
         </p:spPr>
         <p:txBody>
-          <a:bodyPr wrap="square" lIns="27432" tIns="18288" rIns="27432" bIns="18288" anchor="t">
+          <a:bodyPr wrap="square" anchor="t" lIns="27432" rIns="27432" tIns="18288" bIns="18288">
             <a:spAutoFit/>
           </a:bodyPr>
           <a:lstStyle/>
@@ -4817,7 +4654,7 @@
           <a:noFill/>
         </p:spPr>
         <p:txBody>
-          <a:bodyPr wrap="square" lIns="27432" tIns="18288" rIns="27432" bIns="18288" anchor="t">
+          <a:bodyPr wrap="square" anchor="t" lIns="27432" rIns="27432" tIns="18288" bIns="18288">
             <a:spAutoFit/>
           </a:bodyPr>
           <a:lstStyle/>
@@ -4856,7 +4693,7 @@
           <a:noFill/>
         </p:spPr>
         <p:txBody>
-          <a:bodyPr wrap="square" lIns="27432" tIns="18288" rIns="27432" bIns="18288" anchor="t">
+          <a:bodyPr wrap="square" anchor="t" lIns="27432" rIns="27432" tIns="18288" bIns="18288">
             <a:spAutoFit/>
           </a:bodyPr>
           <a:lstStyle/>
@@ -4895,7 +4732,7 @@
           <a:noFill/>
         </p:spPr>
         <p:txBody>
-          <a:bodyPr wrap="square" lIns="27432" tIns="18288" rIns="27432" bIns="18288" anchor="t">
+          <a:bodyPr wrap="square" anchor="t" lIns="27432" rIns="27432" tIns="18288" bIns="18288">
             <a:spAutoFit/>
           </a:bodyPr>
           <a:lstStyle/>
@@ -4957,7 +4794,7 @@
           </a:fontRef>
         </p:style>
         <p:txBody>
-          <a:bodyPr wrap="square" lIns="201168" tIns="146304" rIns="201168" rtlCol="0" anchor="t"/>
+          <a:bodyPr rtlCol="0" anchor="t" wrap="square" lIns="201168" rIns="201168" tIns="146304"/>
           <a:lstStyle/>
           <a:p>
             <a:pPr algn="l" latinLnBrk="0">
@@ -5081,7 +4918,7 @@
           </a:fontRef>
         </p:style>
         <p:txBody>
-          <a:bodyPr wrap="square" rtlCol="0" anchor="ctr"/>
+          <a:bodyPr rtlCol="0" anchor="ctr" wrap="square"/>
           <a:lstStyle/>
           <a:p>
             <a:pPr algn="ctr" latinLnBrk="0"/>
@@ -5149,7 +4986,7 @@
           </a:fontRef>
         </p:style>
         <p:txBody>
-          <a:bodyPr wrap="square" rtlCol="0" anchor="ctr"/>
+          <a:bodyPr rtlCol="0" anchor="ctr" wrap="square"/>
           <a:lstStyle/>
           <a:p>
             <a:pPr algn="ctr" latinLnBrk="0"/>
@@ -5217,7 +5054,7 @@
           </a:fontRef>
         </p:style>
         <p:txBody>
-          <a:bodyPr wrap="square" rtlCol="0" anchor="ctr"/>
+          <a:bodyPr rtlCol="0" anchor="ctr" wrap="square"/>
           <a:lstStyle/>
           <a:p>
             <a:pPr algn="ctr" latinLnBrk="0"/>
@@ -5262,7 +5099,7 @@
           <a:noFill/>
         </p:spPr>
         <p:txBody>
-          <a:bodyPr wrap="square" lIns="27432" tIns="18288" rIns="27432" bIns="18288" anchor="t">
+          <a:bodyPr wrap="square" anchor="t" lIns="27432" rIns="27432" tIns="18288" bIns="18288">
             <a:spAutoFit/>
           </a:bodyPr>
           <a:lstStyle/>
@@ -5292,7 +5129,7 @@
         </p:nvSpPr>
         <p:spPr>
           <a:xfrm>
-            <a:off x="502920" y="5977989"/>
+            <a:off x="502920" y="6144768"/>
             <a:ext cx="11185855" cy="475488"/>
           </a:xfrm>
           <a:prstGeom prst="roundRect">
@@ -5322,7 +5159,7 @@
           </a:fontRef>
         </p:style>
         <p:txBody>
-          <a:bodyPr wrap="square" rtlCol="0" anchor="ctr"/>
+          <a:bodyPr rtlCol="0" anchor="ctr" wrap="square"/>
           <a:lstStyle/>
           <a:p>
             <a:pPr algn="ctr" latinLnBrk="0"/>
@@ -5347,7 +5184,7 @@
 </file>
 
 <file path=ppt/slides/slide5.xml><?xml version="1.0" encoding="utf-8"?>
-<p:sld xmlns:a="http://schemas.openxmlformats.org/drawingml/2006/main" xmlns:r="http://schemas.openxmlformats.org/officeDocument/2006/relationships" xmlns:p="http://schemas.openxmlformats.org/presentationml/2006/main">
+<p:sld xmlns:a="http://schemas.openxmlformats.org/drawingml/2006/main" xmlns:p="http://schemas.openxmlformats.org/presentationml/2006/main" xmlns:r="http://schemas.openxmlformats.org/officeDocument/2006/relationships">
   <p:cSld>
     <p:bg>
       <p:bgPr>
@@ -5363,14 +5200,7 @@
         <p:cNvGrpSpPr/>
         <p:nvPr/>
       </p:nvGrpSpPr>
-      <p:grpSpPr>
-        <a:xfrm>
-          <a:off x="0" y="0"/>
-          <a:ext cx="0" cy="0"/>
-          <a:chOff x="0" y="0"/>
-          <a:chExt cx="0" cy="0"/>
-        </a:xfrm>
-      </p:grpSpPr>
+      <p:grpSpPr/>
       <p:sp>
         <p:nvSpPr>
           <p:cNvPr id="2" name="TextBox 1"/>
@@ -5388,7 +5218,7 @@
           <a:noFill/>
         </p:spPr>
         <p:txBody>
-          <a:bodyPr wrap="square" lIns="27432" tIns="18288" rIns="27432" bIns="18288" anchor="t">
+          <a:bodyPr wrap="square" anchor="t" lIns="27432" rIns="27432" tIns="18288" bIns="18288">
             <a:spAutoFit/>
           </a:bodyPr>
           <a:lstStyle/>
@@ -5427,7 +5257,7 @@
           <a:noFill/>
         </p:spPr>
         <p:txBody>
-          <a:bodyPr wrap="square" lIns="27432" tIns="18288" rIns="27432" bIns="18288" anchor="t">
+          <a:bodyPr wrap="square" anchor="t" lIns="27432" rIns="27432" tIns="18288" bIns="18288">
             <a:spAutoFit/>
           </a:bodyPr>
           <a:lstStyle/>
@@ -5466,7 +5296,7 @@
           <a:noFill/>
         </p:spPr>
         <p:txBody>
-          <a:bodyPr wrap="square" lIns="27432" tIns="18288" rIns="27432" bIns="18288" anchor="t">
+          <a:bodyPr wrap="square" anchor="t" lIns="27432" rIns="27432" tIns="18288" bIns="18288">
             <a:spAutoFit/>
           </a:bodyPr>
           <a:lstStyle/>
@@ -5505,7 +5335,7 @@
           <a:noFill/>
         </p:spPr>
         <p:txBody>
-          <a:bodyPr wrap="square" lIns="27432" tIns="18288" rIns="27432" bIns="18288" anchor="t">
+          <a:bodyPr wrap="square" anchor="t" lIns="27432" rIns="27432" tIns="18288" bIns="18288">
             <a:spAutoFit/>
           </a:bodyPr>
           <a:lstStyle/>
@@ -5568,7 +5398,7 @@
           <a:noFill/>
         </p:spPr>
         <p:txBody>
-          <a:bodyPr wrap="square" lIns="27432" tIns="18288" rIns="27432" bIns="18288" anchor="t">
+          <a:bodyPr wrap="square" anchor="t" lIns="27432" rIns="27432" tIns="18288" bIns="18288">
             <a:spAutoFit/>
           </a:bodyPr>
           <a:lstStyle/>
@@ -5605,7 +5435,7 @@
         </p:nvSpPr>
         <p:spPr>
           <a:xfrm>
-            <a:off x="502920" y="5977989"/>
+            <a:off x="502920" y="6144768"/>
             <a:ext cx="11185855" cy="475488"/>
           </a:xfrm>
           <a:prstGeom prst="roundRect">
@@ -5635,7 +5465,7 @@
           </a:fontRef>
         </p:style>
         <p:txBody>
-          <a:bodyPr wrap="square" rtlCol="0" anchor="ctr"/>
+          <a:bodyPr rtlCol="0" anchor="ctr" wrap="square"/>
           <a:lstStyle/>
           <a:p>
             <a:pPr algn="ctr" latinLnBrk="0"/>
@@ -5660,7 +5490,7 @@
 </file>
 
 <file path=ppt/slides/slide6.xml><?xml version="1.0" encoding="utf-8"?>
-<p:sld xmlns:a="http://schemas.openxmlformats.org/drawingml/2006/main" xmlns:r="http://schemas.openxmlformats.org/officeDocument/2006/relationships" xmlns:p="http://schemas.openxmlformats.org/presentationml/2006/main">
+<p:sld xmlns:a="http://schemas.openxmlformats.org/drawingml/2006/main" xmlns:p="http://schemas.openxmlformats.org/presentationml/2006/main" xmlns:r="http://schemas.openxmlformats.org/officeDocument/2006/relationships">
   <p:cSld>
     <p:bg>
       <p:bgPr>
@@ -5676,14 +5506,7 @@
         <p:cNvGrpSpPr/>
         <p:nvPr/>
       </p:nvGrpSpPr>
-      <p:grpSpPr>
-        <a:xfrm>
-          <a:off x="0" y="0"/>
-          <a:ext cx="0" cy="0"/>
-          <a:chOff x="0" y="0"/>
-          <a:chExt cx="0" cy="0"/>
-        </a:xfrm>
-      </p:grpSpPr>
+      <p:grpSpPr/>
       <p:sp>
         <p:nvSpPr>
           <p:cNvPr id="2" name="TextBox 1"/>
@@ -5701,7 +5524,7 @@
           <a:noFill/>
         </p:spPr>
         <p:txBody>
-          <a:bodyPr wrap="square" lIns="27432" tIns="18288" rIns="27432" bIns="18288" anchor="t">
+          <a:bodyPr wrap="square" anchor="t" lIns="27432" rIns="27432" tIns="18288" bIns="18288">
             <a:spAutoFit/>
           </a:bodyPr>
           <a:lstStyle/>
@@ -5740,7 +5563,7 @@
           <a:noFill/>
         </p:spPr>
         <p:txBody>
-          <a:bodyPr wrap="square" lIns="27432" tIns="18288" rIns="27432" bIns="18288" anchor="t">
+          <a:bodyPr wrap="square" anchor="t" lIns="27432" rIns="27432" tIns="18288" bIns="18288">
             <a:spAutoFit/>
           </a:bodyPr>
           <a:lstStyle/>
@@ -5779,7 +5602,7 @@
           <a:noFill/>
         </p:spPr>
         <p:txBody>
-          <a:bodyPr wrap="square" lIns="27432" tIns="18288" rIns="27432" bIns="18288" anchor="t">
+          <a:bodyPr wrap="square" anchor="t" lIns="27432" rIns="27432" tIns="18288" bIns="18288">
             <a:spAutoFit/>
           </a:bodyPr>
           <a:lstStyle/>
@@ -5818,7 +5641,7 @@
           <a:noFill/>
         </p:spPr>
         <p:txBody>
-          <a:bodyPr wrap="square" lIns="27432" tIns="18288" rIns="27432" bIns="18288" anchor="t">
+          <a:bodyPr wrap="square" anchor="t" lIns="27432" rIns="27432" tIns="18288" bIns="18288">
             <a:spAutoFit/>
           </a:bodyPr>
           <a:lstStyle/>
@@ -5880,7 +5703,7 @@
           </a:fontRef>
         </p:style>
         <p:txBody>
-          <a:bodyPr wrap="square" lIns="201168" tIns="146304" rIns="201168" rtlCol="0" anchor="t"/>
+          <a:bodyPr rtlCol="0" anchor="t" wrap="square" lIns="201168" rIns="201168" tIns="146304"/>
           <a:lstStyle/>
           <a:p>
             <a:pPr algn="l" latinLnBrk="0">
@@ -5972,7 +5795,7 @@
           </a:fontRef>
         </p:style>
         <p:txBody>
-          <a:bodyPr wrap="square" lIns="201168" tIns="146304" rIns="201168" rtlCol="0" anchor="t"/>
+          <a:bodyPr rtlCol="0" anchor="t" wrap="square" lIns="201168" rIns="201168" tIns="146304"/>
           <a:lstStyle/>
           <a:p>
             <a:pPr algn="l" latinLnBrk="0">
@@ -6048,7 +5871,7 @@
           </a:fontRef>
         </p:style>
         <p:txBody>
-          <a:bodyPr wrap="square" rtlCol="0" anchor="ctr"/>
+          <a:bodyPr rtlCol="0" anchor="ctr" wrap="square"/>
           <a:lstStyle/>
           <a:p>
             <a:pPr algn="ctr" latinLnBrk="0"/>
@@ -6116,7 +5939,7 @@
           </a:fontRef>
         </p:style>
         <p:txBody>
-          <a:bodyPr wrap="square" rtlCol="0" anchor="ctr"/>
+          <a:bodyPr rtlCol="0" anchor="ctr" wrap="square"/>
           <a:lstStyle/>
           <a:p>
             <a:pPr algn="ctr" latinLnBrk="0"/>
@@ -6184,7 +6007,7 @@
           </a:fontRef>
         </p:style>
         <p:txBody>
-          <a:bodyPr wrap="square" rtlCol="0" anchor="ctr"/>
+          <a:bodyPr rtlCol="0" anchor="ctr" wrap="square"/>
           <a:lstStyle/>
           <a:p>
             <a:pPr algn="ctr" latinLnBrk="0"/>
@@ -6229,7 +6052,7 @@
           <a:noFill/>
         </p:spPr>
         <p:txBody>
-          <a:bodyPr wrap="square" lIns="27432" tIns="18288" rIns="27432" bIns="18288" anchor="t">
+          <a:bodyPr wrap="square" anchor="t" lIns="27432" rIns="27432" tIns="18288" bIns="18288">
             <a:spAutoFit/>
           </a:bodyPr>
           <a:lstStyle/>
@@ -6259,8 +6082,8 @@
         </p:nvSpPr>
         <p:spPr>
           <a:xfrm>
-            <a:off x="502920" y="5321808"/>
-            <a:ext cx="5486400" cy="411480"/>
+            <a:off x="502920" y="5074920"/>
+            <a:ext cx="11185855" cy="777240"/>
           </a:xfrm>
           <a:prstGeom prst="rect">
             <a:avLst/>
@@ -6268,7 +6091,7 @@
           <a:noFill/>
         </p:spPr>
         <p:txBody>
-          <a:bodyPr wrap="square" lIns="27432" tIns="18288" rIns="27432" bIns="18288" anchor="t">
+          <a:bodyPr wrap="square" anchor="t" lIns="27432" rIns="27432" tIns="18288" bIns="18288">
             <a:spAutoFit/>
           </a:bodyPr>
           <a:lstStyle/>
@@ -6279,13 +6102,13 @@
               </a:lnSpc>
             </a:pPr>
             <a:r>
-              <a:rPr sz="1100" b="0">
+              <a:rPr sz="1150" b="0">
                 <a:solidFill>
                   <a:srgbClr val="6E6A60"/>
                 </a:solidFill>
                 <a:latin typeface="Segoe UI"/>
               </a:rPr>
-              <a:t>Note: leader-dominated means influence is concentrated around one singer or section instead of shared across the choir.</a:t>
+              <a:t>Definition (operational): leader dominance = out-degree centralization of the directed influence graph, measured as the Gini coefficient of node out-degree. 0 = every singer exerts equal outgoing influence (democratic); toward 1 = one singer Granger-causes the others without following back (a leader). Test: observed Gini vs 1000 random graphs of identical size and density. Observed corpus mean 0.154 vs null 0.139.</a:t>
             </a:r>
           </a:p>
         </p:txBody>
@@ -6298,7 +6121,7 @@
         </p:nvSpPr>
         <p:spPr>
           <a:xfrm>
-            <a:off x="502920" y="5983740"/>
+            <a:off x="502920" y="6144768"/>
             <a:ext cx="11185855" cy="475488"/>
           </a:xfrm>
           <a:prstGeom prst="roundRect">
@@ -6328,7 +6151,7 @@
           </a:fontRef>
         </p:style>
         <p:txBody>
-          <a:bodyPr wrap="square" rtlCol="0" anchor="ctr"/>
+          <a:bodyPr rtlCol="0" anchor="ctr" wrap="square"/>
           <a:lstStyle/>
           <a:p>
             <a:pPr algn="ctr" latinLnBrk="0"/>
@@ -6353,7 +6176,7 @@
 </file>
 
 <file path=ppt/slides/slide7.xml><?xml version="1.0" encoding="utf-8"?>
-<p:sld xmlns:a="http://schemas.openxmlformats.org/drawingml/2006/main" xmlns:r="http://schemas.openxmlformats.org/officeDocument/2006/relationships" xmlns:p="http://schemas.openxmlformats.org/presentationml/2006/main">
+<p:sld xmlns:a="http://schemas.openxmlformats.org/drawingml/2006/main" xmlns:p="http://schemas.openxmlformats.org/presentationml/2006/main" xmlns:r="http://schemas.openxmlformats.org/officeDocument/2006/relationships">
   <p:cSld>
     <p:bg>
       <p:bgPr>
@@ -6369,14 +6192,7 @@
         <p:cNvGrpSpPr/>
         <p:nvPr/>
       </p:nvGrpSpPr>
-      <p:grpSpPr>
-        <a:xfrm>
-          <a:off x="0" y="0"/>
-          <a:ext cx="0" cy="0"/>
-          <a:chOff x="0" y="0"/>
-          <a:chExt cx="0" cy="0"/>
-        </a:xfrm>
-      </p:grpSpPr>
+      <p:grpSpPr/>
       <p:sp>
         <p:nvSpPr>
           <p:cNvPr id="2" name="TextBox 1"/>
@@ -6394,7 +6210,7 @@
           <a:noFill/>
         </p:spPr>
         <p:txBody>
-          <a:bodyPr wrap="square" lIns="27432" tIns="18288" rIns="27432" bIns="18288" anchor="t">
+          <a:bodyPr wrap="square" anchor="t" lIns="27432" rIns="27432" tIns="18288" bIns="18288">
             <a:spAutoFit/>
           </a:bodyPr>
           <a:lstStyle/>
@@ -6433,7 +6249,7 @@
           <a:noFill/>
         </p:spPr>
         <p:txBody>
-          <a:bodyPr wrap="square" lIns="27432" tIns="18288" rIns="27432" bIns="18288" anchor="t">
+          <a:bodyPr wrap="square" anchor="t" lIns="27432" rIns="27432" tIns="18288" bIns="18288">
             <a:spAutoFit/>
           </a:bodyPr>
           <a:lstStyle/>
@@ -6472,7 +6288,7 @@
           <a:noFill/>
         </p:spPr>
         <p:txBody>
-          <a:bodyPr wrap="square" lIns="27432" tIns="18288" rIns="27432" bIns="18288" anchor="t">
+          <a:bodyPr wrap="square" anchor="t" lIns="27432" rIns="27432" tIns="18288" bIns="18288">
             <a:spAutoFit/>
           </a:bodyPr>
           <a:lstStyle/>
@@ -6511,7 +6327,7 @@
           <a:noFill/>
         </p:spPr>
         <p:txBody>
-          <a:bodyPr wrap="square" lIns="27432" tIns="18288" rIns="27432" bIns="18288" anchor="t">
+          <a:bodyPr wrap="square" anchor="t" lIns="27432" rIns="27432" tIns="18288" bIns="18288">
             <a:spAutoFit/>
           </a:bodyPr>
           <a:lstStyle/>
@@ -6574,7 +6390,7 @@
           <a:noFill/>
         </p:spPr>
         <p:txBody>
-          <a:bodyPr wrap="square" lIns="27432" tIns="18288" rIns="27432" bIns="18288" anchor="t">
+          <a:bodyPr wrap="square" anchor="t" lIns="27432" rIns="27432" tIns="18288" bIns="18288">
             <a:spAutoFit/>
           </a:bodyPr>
           <a:lstStyle/>
@@ -6611,7 +6427,7 @@
         </p:nvSpPr>
         <p:spPr>
           <a:xfrm>
-            <a:off x="502920" y="5983740"/>
+            <a:off x="502920" y="6144768"/>
             <a:ext cx="11185855" cy="475488"/>
           </a:xfrm>
           <a:prstGeom prst="roundRect">
@@ -6641,7 +6457,7 @@
           </a:fontRef>
         </p:style>
         <p:txBody>
-          <a:bodyPr wrap="square" rtlCol="0" anchor="ctr"/>
+          <a:bodyPr rtlCol="0" anchor="ctr" wrap="square"/>
           <a:lstStyle/>
           <a:p>
             <a:pPr algn="ctr" latinLnBrk="0"/>
@@ -6666,7 +6482,7 @@
 </file>
 
 <file path=ppt/slides/slide8.xml><?xml version="1.0" encoding="utf-8"?>
-<p:sld xmlns:a="http://schemas.openxmlformats.org/drawingml/2006/main" xmlns:r="http://schemas.openxmlformats.org/officeDocument/2006/relationships" xmlns:p="http://schemas.openxmlformats.org/presentationml/2006/main">
+<p:sld xmlns:a="http://schemas.openxmlformats.org/drawingml/2006/main" xmlns:p="http://schemas.openxmlformats.org/presentationml/2006/main" xmlns:r="http://schemas.openxmlformats.org/officeDocument/2006/relationships">
   <p:cSld>
     <p:bg>
       <p:bgPr>
@@ -6682,14 +6498,7 @@
         <p:cNvGrpSpPr/>
         <p:nvPr/>
       </p:nvGrpSpPr>
-      <p:grpSpPr>
-        <a:xfrm>
-          <a:off x="0" y="0"/>
-          <a:ext cx="0" cy="0"/>
-          <a:chOff x="0" y="0"/>
-          <a:chExt cx="0" cy="0"/>
-        </a:xfrm>
-      </p:grpSpPr>
+      <p:grpSpPr/>
       <p:sp>
         <p:nvSpPr>
           <p:cNvPr id="2" name="TextBox 1"/>
@@ -6707,7 +6516,7 @@
           <a:noFill/>
         </p:spPr>
         <p:txBody>
-          <a:bodyPr wrap="square" lIns="27432" tIns="18288" rIns="27432" bIns="18288" anchor="t">
+          <a:bodyPr wrap="square" anchor="t" lIns="27432" rIns="27432" tIns="18288" bIns="18288">
             <a:spAutoFit/>
           </a:bodyPr>
           <a:lstStyle/>
@@ -6746,7 +6555,7 @@
           <a:noFill/>
         </p:spPr>
         <p:txBody>
-          <a:bodyPr wrap="square" lIns="27432" tIns="18288" rIns="27432" bIns="18288" anchor="t">
+          <a:bodyPr wrap="square" anchor="t" lIns="27432" rIns="27432" tIns="18288" bIns="18288">
             <a:spAutoFit/>
           </a:bodyPr>
           <a:lstStyle/>
@@ -6785,7 +6594,7 @@
           <a:noFill/>
         </p:spPr>
         <p:txBody>
-          <a:bodyPr wrap="square" lIns="27432" tIns="18288" rIns="27432" bIns="18288" anchor="t">
+          <a:bodyPr wrap="square" anchor="t" lIns="27432" rIns="27432" tIns="18288" bIns="18288">
             <a:spAutoFit/>
           </a:bodyPr>
           <a:lstStyle/>
@@ -6824,7 +6633,7 @@
           <a:noFill/>
         </p:spPr>
         <p:txBody>
-          <a:bodyPr wrap="square" lIns="27432" tIns="18288" rIns="27432" bIns="18288" anchor="t">
+          <a:bodyPr wrap="square" anchor="t" lIns="27432" rIns="27432" tIns="18288" bIns="18288">
             <a:spAutoFit/>
           </a:bodyPr>
           <a:lstStyle/>
@@ -6863,7 +6672,7 @@
           <a:noFill/>
         </p:spPr>
         <p:txBody>
-          <a:bodyPr wrap="square" lIns="27432" tIns="18288" rIns="27432" bIns="18288" anchor="t">
+          <a:bodyPr wrap="square" anchor="t" lIns="27432" rIns="27432" tIns="18288" bIns="18288">
             <a:spAutoFit/>
           </a:bodyPr>
           <a:lstStyle/>
@@ -6925,7 +6734,7 @@
           </a:fontRef>
         </p:style>
         <p:txBody>
-          <a:bodyPr wrap="square" lIns="201168" tIns="146304" rIns="201168" rtlCol="0" anchor="t"/>
+          <a:bodyPr rtlCol="0" anchor="t" wrap="square" lIns="201168" rIns="201168" tIns="146304"/>
           <a:lstStyle/>
           <a:p>
             <a:pPr algn="l" latinLnBrk="0">
@@ -7001,7 +6810,7 @@
           </a:fontRef>
         </p:style>
         <p:txBody>
-          <a:bodyPr wrap="square" lIns="201168" tIns="146304" rIns="201168" rtlCol="0" anchor="t"/>
+          <a:bodyPr rtlCol="0" anchor="t" wrap="square" lIns="201168" rIns="201168" tIns="146304"/>
           <a:lstStyle/>
           <a:p>
             <a:pPr algn="l" latinLnBrk="0">
@@ -7077,7 +6886,7 @@
           </a:fontRef>
         </p:style>
         <p:txBody>
-          <a:bodyPr wrap="square" lIns="201168" tIns="146304" rIns="201168" rtlCol="0" anchor="t"/>
+          <a:bodyPr rtlCol="0" anchor="t" wrap="square" lIns="201168" rIns="201168" tIns="146304"/>
           <a:lstStyle/>
           <a:p>
             <a:pPr algn="l" latinLnBrk="0">
@@ -7153,7 +6962,7 @@
           </a:fontRef>
         </p:style>
         <p:txBody>
-          <a:bodyPr wrap="square" lIns="201168" tIns="146304" rIns="201168" rtlCol="0" anchor="t"/>
+          <a:bodyPr rtlCol="0" anchor="t" wrap="square" lIns="201168" rIns="201168" tIns="146304"/>
           <a:lstStyle/>
           <a:p>
             <a:pPr algn="l" latinLnBrk="0">
@@ -7162,7 +6971,7 @@
               </a:spcAft>
             </a:pPr>
             <a:r>
-              <a:rPr sz="1400" b="1" dirty="0">
+              <a:rPr sz="1400" b="1">
                 <a:solidFill>
                   <a:srgbClr val="0E4D5E"/>
                 </a:solidFill>
@@ -7178,67 +6987,13 @@
               </a:spcAft>
             </a:pPr>
             <a:r>
-              <a:rPr sz="1250" b="0" dirty="0">
+              <a:rPr sz="1250" b="0">
                 <a:solidFill>
                   <a:srgbClr val="24262E"/>
                 </a:solidFill>
                 <a:latin typeface="Segoe UI"/>
               </a:rPr>
-              <a:t>Prepare</a:t>
-            </a:r>
-            <a:r>
-              <a:rPr lang="en-US" sz="1250" b="0" dirty="0">
-                <a:solidFill>
-                  <a:srgbClr val="24262E"/>
-                </a:solidFill>
-                <a:latin typeface="Segoe UI"/>
-              </a:rPr>
-              <a:t> for</a:t>
-            </a:r>
-            <a:r>
-              <a:rPr sz="1250" b="0" dirty="0">
-                <a:solidFill>
-                  <a:srgbClr val="24262E"/>
-                </a:solidFill>
-                <a:latin typeface="Segoe UI"/>
-              </a:rPr>
-              <a:t> the presentation and </a:t>
-            </a:r>
-            <a:r>
-              <a:rPr lang="en-US" sz="1250" b="0" dirty="0">
-                <a:solidFill>
-                  <a:srgbClr val="24262E"/>
-                </a:solidFill>
-                <a:latin typeface="Segoe UI"/>
-              </a:rPr>
-              <a:t>final few test for</a:t>
-            </a:r>
-            <a:r>
-              <a:rPr sz="1250" b="0" dirty="0">
-                <a:solidFill>
-                  <a:srgbClr val="24262E"/>
-                </a:solidFill>
-                <a:latin typeface="Segoe UI"/>
-              </a:rPr>
-              <a:t> the dem</a:t>
-            </a:r>
-            <a:r>
-              <a:rPr lang="en-US" sz="1250" b="0" dirty="0">
-                <a:solidFill>
-                  <a:srgbClr val="24262E"/>
-                </a:solidFill>
-                <a:latin typeface="Segoe UI"/>
-              </a:rPr>
-              <a:t>o</a:t>
-            </a:r>
-            <a:r>
-              <a:rPr sz="1250" b="0" dirty="0">
-                <a:solidFill>
-                  <a:srgbClr val="24262E"/>
-                </a:solidFill>
-                <a:latin typeface="Segoe UI"/>
-              </a:rPr>
-              <a:t>.</a:t>
+              <a:t>Prepare the presentation laptop and rehearse the demo path.</a:t>
             </a:r>
           </a:p>
         </p:txBody>
@@ -7283,7 +7038,7 @@
           </a:fontRef>
         </p:style>
         <p:txBody>
-          <a:bodyPr wrap="square" lIns="201168" tIns="146304" rIns="201168" rtlCol="0" anchor="t"/>
+          <a:bodyPr rtlCol="0" anchor="t" wrap="square" lIns="201168" rIns="201168" tIns="146304"/>
           <a:lstStyle/>
           <a:p>
             <a:pPr algn="l" latinLnBrk="0">
@@ -7327,7 +7082,7 @@
         </p:nvSpPr>
         <p:spPr>
           <a:xfrm>
-            <a:off x="502920" y="5977989"/>
+            <a:off x="502920" y="6144768"/>
             <a:ext cx="11185855" cy="475488"/>
           </a:xfrm>
           <a:prstGeom prst="roundRect">
@@ -7357,7 +7112,7 @@
           </a:fontRef>
         </p:style>
         <p:txBody>
-          <a:bodyPr wrap="square" rtlCol="0" anchor="ctr"/>
+          <a:bodyPr rtlCol="0" anchor="ctr" wrap="square"/>
           <a:lstStyle/>
           <a:p>
             <a:pPr algn="ctr" latinLnBrk="0"/>
@@ -7382,7 +7137,7 @@
 </file>
 
 <file path=ppt/slides/slide9.xml><?xml version="1.0" encoding="utf-8"?>
-<p:sld xmlns:a="http://schemas.openxmlformats.org/drawingml/2006/main" xmlns:r="http://schemas.openxmlformats.org/officeDocument/2006/relationships" xmlns:p="http://schemas.openxmlformats.org/presentationml/2006/main">
+<p:sld xmlns:a="http://schemas.openxmlformats.org/drawingml/2006/main" xmlns:p="http://schemas.openxmlformats.org/presentationml/2006/main" xmlns:r="http://schemas.openxmlformats.org/officeDocument/2006/relationships">
   <p:cSld>
     <p:bg>
       <p:bgPr>
@@ -7398,14 +7153,7 @@
         <p:cNvGrpSpPr/>
         <p:nvPr/>
       </p:nvGrpSpPr>
-      <p:grpSpPr>
-        <a:xfrm>
-          <a:off x="0" y="0"/>
-          <a:ext cx="0" cy="0"/>
-          <a:chOff x="0" y="0"/>
-          <a:chExt cx="0" cy="0"/>
-        </a:xfrm>
-      </p:grpSpPr>
+      <p:grpSpPr/>
       <p:sp>
         <p:nvSpPr>
           <p:cNvPr id="2" name="TextBox 1"/>
@@ -7423,7 +7171,7 @@
           <a:noFill/>
         </p:spPr>
         <p:txBody>
-          <a:bodyPr wrap="square" lIns="27432" tIns="18288" rIns="27432" bIns="18288" anchor="t">
+          <a:bodyPr wrap="square" anchor="t" lIns="27432" rIns="27432" tIns="18288" bIns="18288">
             <a:spAutoFit/>
           </a:bodyPr>
           <a:lstStyle/>
@@ -7462,7 +7210,7 @@
           <a:noFill/>
         </p:spPr>
         <p:txBody>
-          <a:bodyPr wrap="square" lIns="27432" tIns="18288" rIns="27432" bIns="18288" anchor="t">
+          <a:bodyPr wrap="square" anchor="t" lIns="27432" rIns="27432" tIns="18288" bIns="18288">
             <a:spAutoFit/>
           </a:bodyPr>
           <a:lstStyle/>
@@ -7501,7 +7249,7 @@
           <a:noFill/>
         </p:spPr>
         <p:txBody>
-          <a:bodyPr wrap="square" lIns="27432" tIns="18288" rIns="27432" bIns="18288" anchor="t">
+          <a:bodyPr wrap="square" anchor="t" lIns="27432" rIns="27432" tIns="18288" bIns="18288">
             <a:spAutoFit/>
           </a:bodyPr>
           <a:lstStyle/>
@@ -7540,7 +7288,7 @@
           <a:noFill/>
         </p:spPr>
         <p:txBody>
-          <a:bodyPr wrap="square" lIns="27432" tIns="18288" rIns="27432" bIns="18288" anchor="t">
+          <a:bodyPr wrap="square" anchor="t" lIns="27432" rIns="27432" tIns="18288" bIns="18288">
             <a:spAutoFit/>
           </a:bodyPr>
           <a:lstStyle/>
@@ -7602,7 +7350,7 @@
           </a:fontRef>
         </p:style>
         <p:txBody>
-          <a:bodyPr wrap="square" lIns="201168" tIns="146304" rIns="201168" rtlCol="0" anchor="t"/>
+          <a:bodyPr rtlCol="0" anchor="t" wrap="square" lIns="201168" rIns="201168" tIns="146304"/>
           <a:lstStyle/>
           <a:p>
             <a:pPr algn="l" latinLnBrk="0">
@@ -7710,7 +7458,7 @@
           </a:fontRef>
         </p:style>
         <p:txBody>
-          <a:bodyPr wrap="square" lIns="201168" tIns="146304" rIns="201168" rtlCol="0" anchor="t"/>
+          <a:bodyPr rtlCol="0" anchor="t" wrap="square" lIns="201168" rIns="201168" tIns="146304"/>
           <a:lstStyle/>
           <a:p>
             <a:pPr algn="l" latinLnBrk="0">
@@ -7725,7 +7473,7 @@
                 </a:solidFill>
                 <a:latin typeface="Segoe UI Semibold"/>
               </a:rPr>
-              <a:t>What we fixed</a:t>
+              <a:t>Proposed structure</a:t>
             </a:r>
           </a:p>
           <a:p>
@@ -7741,7 +7489,7 @@
                 </a:solidFill>
                 <a:latin typeface="Segoe UI"/>
               </a:rPr>
-              <a:t>The first latency method was replaced after the control check.</a:t>
+              <a:t>Research question and hypotheses.</a:t>
             </a:r>
           </a:p>
           <a:p>
@@ -7757,7 +7505,7 @@
                 </a:solidFill>
                 <a:latin typeface="Segoe UI"/>
               </a:rPr>
-              <a:t>Dataset selection now uses verified availability, not memory.</a:t>
+              <a:t>Method, datasets, results, and interpretation.</a:t>
             </a:r>
           </a:p>
           <a:p>
@@ -7773,7 +7521,7 @@
                 </a:solidFill>
                 <a:latin typeface="Segoe UI"/>
               </a:rPr>
-              <a:t>Dashboard wording now separates current results from final-demo planning.</a:t>
+              <a:t>Implementation, limitations, and next steps.</a:t>
             </a:r>
           </a:p>
         </p:txBody>
@@ -7818,7 +7566,7 @@
           </a:fontRef>
         </p:style>
         <p:txBody>
-          <a:bodyPr wrap="square" lIns="201168" tIns="146304" rIns="201168" rtlCol="0" anchor="t"/>
+          <a:bodyPr rtlCol="0" anchor="t" wrap="square" lIns="201168" rIns="201168" tIns="146304"/>
           <a:lstStyle/>
           <a:p>
             <a:pPr algn="l" latinLnBrk="0">
@@ -7827,7 +7575,7 @@
               </a:spcAft>
             </a:pPr>
             <a:r>
-              <a:rPr sz="1400" b="1" dirty="0">
+              <a:rPr sz="1400" b="1">
                 <a:solidFill>
                   <a:srgbClr val="0E4D5E"/>
                 </a:solidFill>
@@ -7837,26 +7585,20 @@
             </a:r>
           </a:p>
           <a:p>
-            <a:pPr>
+            <a:pPr algn="l" latinLnBrk="0">
               <a:spcAft>
                 <a:spcPts val="400"/>
               </a:spcAft>
             </a:pPr>
             <a:r>
-              <a:rPr lang="en-US" sz="1300" dirty="0">
+              <a:rPr sz="1300" b="0">
                 <a:solidFill>
                   <a:srgbClr val="24262E"/>
                 </a:solidFill>
                 <a:latin typeface="Segoe UI"/>
               </a:rPr>
-              <a:t>What should the final presentation structure be?</a:t>
-            </a:r>
-            <a:endParaRPr sz="1300" b="0" dirty="0">
-              <a:solidFill>
-                <a:srgbClr val="24262E"/>
-              </a:solidFill>
-              <a:latin typeface="Segoe UI"/>
-            </a:endParaRPr>
+              <a:t>Final structure: research question, hypotheses, method, results, implementation, limitations, next steps.</a:t>
+            </a:r>
           </a:p>
           <a:p>
             <a:pPr algn="l" latinLnBrk="0">
@@ -7865,7 +7607,7 @@
               </a:spcAft>
             </a:pPr>
             <a:r>
-              <a:rPr sz="1300" b="0" dirty="0">
+              <a:rPr sz="1300" b="0">
                 <a:solidFill>
                   <a:srgbClr val="24262E"/>
                 </a:solidFill>
@@ -7881,7 +7623,7 @@
               </a:spcAft>
             </a:pPr>
             <a:r>
-              <a:rPr sz="1300" b="0" dirty="0">
+              <a:rPr sz="1300" b="0">
                 <a:solidFill>
                   <a:srgbClr val="24262E"/>
                 </a:solidFill>
@@ -7909,7 +7651,7 @@
           <a:noFill/>
         </p:spPr>
         <p:txBody>
-          <a:bodyPr wrap="square" lIns="27432" tIns="18288" rIns="27432" bIns="18288" anchor="t">
+          <a:bodyPr wrap="square" anchor="t" lIns="27432" rIns="27432" tIns="18288" bIns="18288">
             <a:spAutoFit/>
           </a:bodyPr>
           <a:lstStyle/>

</xml_diff>

<commit_message>
chore(presentation): update Jul 9 status meeting presentation file
</commit_message>
<xml_diff>
--- a/output/jul09_status_meeting_vi.pptx
+++ b/output/jul09_status_meeting_vi.pptx
@@ -5,17 +5,17 @@
     <p:sldMasterId id="2147483648" r:id="rId1"/>
   </p:sldMasterIdLst>
   <p:sldIdLst>
-    <p:sldId id="256" r:id="rId7"/>
-    <p:sldId id="257" r:id="rId8"/>
-    <p:sldId id="258" r:id="rId9"/>
-    <p:sldId id="259" r:id="rId10"/>
-    <p:sldId id="260" r:id="rId11"/>
-    <p:sldId id="261" r:id="rId12"/>
-    <p:sldId id="262" r:id="rId13"/>
-    <p:sldId id="263" r:id="rId14"/>
-    <p:sldId id="264" r:id="rId15"/>
+    <p:sldId id="256" r:id="rId2"/>
+    <p:sldId id="257" r:id="rId3"/>
+    <p:sldId id="258" r:id="rId4"/>
+    <p:sldId id="259" r:id="rId5"/>
+    <p:sldId id="260" r:id="rId6"/>
+    <p:sldId id="261" r:id="rId7"/>
+    <p:sldId id="262" r:id="rId8"/>
+    <p:sldId id="263" r:id="rId9"/>
+    <p:sldId id="264" r:id="rId10"/>
   </p:sldIdLst>
-  <p:sldSz cx="12191695" cy="6858000" type="screen4x3"/>
+  <p:sldSz cx="12192000" cy="6858000"/>
   <p:notesSz cx="6858000" cy="9144000"/>
   <p:defaultTextStyle>
     <a:defPPr>
@@ -112,6 +112,22 @@
       </a:defRPr>
     </a:lvl9pPr>
   </p:defaultTextStyle>
+  <p:extLst>
+    <p:ext uri="{EFAFB233-063F-42B5-8137-9DF3F51BA10A}">
+      <p15:sldGuideLst xmlns:p15="http://schemas.microsoft.com/office/powerpoint/2012/main">
+        <p15:guide id="1" orient="horz" pos="2160">
+          <p15:clr>
+            <a:srgbClr val="A4A3A4"/>
+          </p15:clr>
+        </p15:guide>
+        <p15:guide id="2" pos="2880">
+          <p15:clr>
+            <a:srgbClr val="A4A3A4"/>
+          </p15:clr>
+        </p15:guide>
+      </p15:sldGuideLst>
+    </p:ext>
+  </p:extLst>
 </p:presentation>
 </file>
 
@@ -153,10 +169,9 @@
           <a:lstStyle/>
           <a:p>
             <a:r>
-              <a:rPr lang="en-US" smtClean="0"/>
+              <a:rPr lang="en-US"/>
               <a:t>Click to edit Master title style</a:t>
             </a:r>
-            <a:endParaRPr lang="en-US"/>
           </a:p>
         </p:txBody>
       </p:sp>
@@ -272,10 +287,9 @@
           </a:lstStyle>
           <a:p>
             <a:r>
-              <a:rPr lang="en-US" smtClean="0"/>
+              <a:rPr lang="en-US"/>
               <a:t>Click to edit Master subtitle style</a:t>
             </a:r>
-            <a:endParaRPr lang="en-US"/>
           </a:p>
         </p:txBody>
       </p:sp>
@@ -296,7 +310,7 @@
           <a:p>
             <a:fld id="{5BCAD085-E8A6-8845-BD4E-CB4CCA059FC4}" type="datetimeFigureOut">
               <a:rPr lang="en-US" smtClean="0"/>
-              <a:t>1/27/13</a:t>
+              <a:t>7/9/2026</a:t>
             </a:fld>
             <a:endParaRPr lang="en-US"/>
           </a:p>
@@ -390,10 +404,9 @@
           <a:lstStyle/>
           <a:p>
             <a:r>
-              <a:rPr lang="en-US" smtClean="0"/>
+              <a:rPr lang="en-US"/>
               <a:t>Click to edit Master title style</a:t>
             </a:r>
-            <a:endParaRPr lang="en-US"/>
           </a:p>
         </p:txBody>
       </p:sp>
@@ -414,38 +427,37 @@
           <a:p>
             <a:pPr lvl="0"/>
             <a:r>
-              <a:rPr lang="en-US" smtClean="0"/>
+              <a:rPr lang="en-US"/>
               <a:t>Click to edit Master text styles</a:t>
             </a:r>
           </a:p>
           <a:p>
             <a:pPr lvl="1"/>
             <a:r>
-              <a:rPr lang="en-US" smtClean="0"/>
+              <a:rPr lang="en-US"/>
               <a:t>Second level</a:t>
             </a:r>
           </a:p>
           <a:p>
             <a:pPr lvl="2"/>
             <a:r>
-              <a:rPr lang="en-US" smtClean="0"/>
+              <a:rPr lang="en-US"/>
               <a:t>Third level</a:t>
             </a:r>
           </a:p>
           <a:p>
             <a:pPr lvl="3"/>
             <a:r>
-              <a:rPr lang="en-US" smtClean="0"/>
+              <a:rPr lang="en-US"/>
               <a:t>Fourth level</a:t>
             </a:r>
           </a:p>
           <a:p>
             <a:pPr lvl="4"/>
             <a:r>
-              <a:rPr lang="en-US" smtClean="0"/>
+              <a:rPr lang="en-US"/>
               <a:t>Fifth level</a:t>
             </a:r>
-            <a:endParaRPr lang="en-US"/>
           </a:p>
         </p:txBody>
       </p:sp>
@@ -466,7 +478,7 @@
           <a:p>
             <a:fld id="{5BCAD085-E8A6-8845-BD4E-CB4CCA059FC4}" type="datetimeFigureOut">
               <a:rPr lang="en-US" smtClean="0"/>
-              <a:t>1/27/13</a:t>
+              <a:t>7/9/2026</a:t>
             </a:fld>
             <a:endParaRPr lang="en-US"/>
           </a:p>
@@ -565,10 +577,9 @@
           <a:lstStyle/>
           <a:p>
             <a:r>
-              <a:rPr lang="en-US" smtClean="0"/>
+              <a:rPr lang="en-US"/>
               <a:t>Click to edit Master title style</a:t>
             </a:r>
-            <a:endParaRPr lang="en-US"/>
           </a:p>
         </p:txBody>
       </p:sp>
@@ -594,38 +605,37 @@
           <a:p>
             <a:pPr lvl="0"/>
             <a:r>
-              <a:rPr lang="en-US" smtClean="0"/>
+              <a:rPr lang="en-US"/>
               <a:t>Click to edit Master text styles</a:t>
             </a:r>
           </a:p>
           <a:p>
             <a:pPr lvl="1"/>
             <a:r>
-              <a:rPr lang="en-US" smtClean="0"/>
+              <a:rPr lang="en-US"/>
               <a:t>Second level</a:t>
             </a:r>
           </a:p>
           <a:p>
             <a:pPr lvl="2"/>
             <a:r>
-              <a:rPr lang="en-US" smtClean="0"/>
+              <a:rPr lang="en-US"/>
               <a:t>Third level</a:t>
             </a:r>
           </a:p>
           <a:p>
             <a:pPr lvl="3"/>
             <a:r>
-              <a:rPr lang="en-US" smtClean="0"/>
+              <a:rPr lang="en-US"/>
               <a:t>Fourth level</a:t>
             </a:r>
           </a:p>
           <a:p>
             <a:pPr lvl="4"/>
             <a:r>
-              <a:rPr lang="en-US" smtClean="0"/>
+              <a:rPr lang="en-US"/>
               <a:t>Fifth level</a:t>
             </a:r>
-            <a:endParaRPr lang="en-US"/>
           </a:p>
         </p:txBody>
       </p:sp>
@@ -646,7 +656,7 @@
           <a:p>
             <a:fld id="{5BCAD085-E8A6-8845-BD4E-CB4CCA059FC4}" type="datetimeFigureOut">
               <a:rPr lang="en-US" smtClean="0"/>
-              <a:t>1/27/13</a:t>
+              <a:t>7/9/2026</a:t>
             </a:fld>
             <a:endParaRPr lang="en-US"/>
           </a:p>
@@ -740,10 +750,9 @@
           <a:lstStyle/>
           <a:p>
             <a:r>
-              <a:rPr lang="en-US" smtClean="0"/>
+              <a:rPr lang="en-US"/>
               <a:t>Click to edit Master title style</a:t>
             </a:r>
-            <a:endParaRPr lang="en-US"/>
           </a:p>
         </p:txBody>
       </p:sp>
@@ -764,38 +773,37 @@
           <a:p>
             <a:pPr lvl="0"/>
             <a:r>
-              <a:rPr lang="en-US" smtClean="0"/>
+              <a:rPr lang="en-US"/>
               <a:t>Click to edit Master text styles</a:t>
             </a:r>
           </a:p>
           <a:p>
             <a:pPr lvl="1"/>
             <a:r>
-              <a:rPr lang="en-US" smtClean="0"/>
+              <a:rPr lang="en-US"/>
               <a:t>Second level</a:t>
             </a:r>
           </a:p>
           <a:p>
             <a:pPr lvl="2"/>
             <a:r>
-              <a:rPr lang="en-US" smtClean="0"/>
+              <a:rPr lang="en-US"/>
               <a:t>Third level</a:t>
             </a:r>
           </a:p>
           <a:p>
             <a:pPr lvl="3"/>
             <a:r>
-              <a:rPr lang="en-US" smtClean="0"/>
+              <a:rPr lang="en-US"/>
               <a:t>Fourth level</a:t>
             </a:r>
           </a:p>
           <a:p>
             <a:pPr lvl="4"/>
             <a:r>
-              <a:rPr lang="en-US" smtClean="0"/>
+              <a:rPr lang="en-US"/>
               <a:t>Fifth level</a:t>
             </a:r>
-            <a:endParaRPr lang="en-US"/>
           </a:p>
         </p:txBody>
       </p:sp>
@@ -816,7 +824,7 @@
           <a:p>
             <a:fld id="{5BCAD085-E8A6-8845-BD4E-CB4CCA059FC4}" type="datetimeFigureOut">
               <a:rPr lang="en-US" smtClean="0"/>
-              <a:t>1/27/13</a:t>
+              <a:t>7/9/2026</a:t>
             </a:fld>
             <a:endParaRPr lang="en-US"/>
           </a:p>
@@ -919,10 +927,9 @@
           </a:lstStyle>
           <a:p>
             <a:r>
-              <a:rPr lang="en-US" smtClean="0"/>
+              <a:rPr lang="en-US"/>
               <a:t>Click to edit Master title style</a:t>
             </a:r>
-            <a:endParaRPr lang="en-US"/>
           </a:p>
         </p:txBody>
       </p:sp>
@@ -1039,7 +1046,7 @@
           <a:p>
             <a:pPr lvl="0"/>
             <a:r>
-              <a:rPr lang="en-US" smtClean="0"/>
+              <a:rPr lang="en-US"/>
               <a:t>Click to edit Master text styles</a:t>
             </a:r>
           </a:p>
@@ -1062,7 +1069,7 @@
           <a:p>
             <a:fld id="{5BCAD085-E8A6-8845-BD4E-CB4CCA059FC4}" type="datetimeFigureOut">
               <a:rPr lang="en-US" smtClean="0"/>
-              <a:t>1/27/13</a:t>
+              <a:t>7/9/2026</a:t>
             </a:fld>
             <a:endParaRPr lang="en-US"/>
           </a:p>
@@ -1156,10 +1163,9 @@
           <a:lstStyle/>
           <a:p>
             <a:r>
-              <a:rPr lang="en-US" smtClean="0"/>
+              <a:rPr lang="en-US"/>
               <a:t>Click to edit Master title style</a:t>
             </a:r>
-            <a:endParaRPr lang="en-US"/>
           </a:p>
         </p:txBody>
       </p:sp>
@@ -1213,38 +1219,37 @@
           <a:p>
             <a:pPr lvl="0"/>
             <a:r>
-              <a:rPr lang="en-US" smtClean="0"/>
+              <a:rPr lang="en-US"/>
               <a:t>Click to edit Master text styles</a:t>
             </a:r>
           </a:p>
           <a:p>
             <a:pPr lvl="1"/>
             <a:r>
-              <a:rPr lang="en-US" smtClean="0"/>
+              <a:rPr lang="en-US"/>
               <a:t>Second level</a:t>
             </a:r>
           </a:p>
           <a:p>
             <a:pPr lvl="2"/>
             <a:r>
-              <a:rPr lang="en-US" smtClean="0"/>
+              <a:rPr lang="en-US"/>
               <a:t>Third level</a:t>
             </a:r>
           </a:p>
           <a:p>
             <a:pPr lvl="3"/>
             <a:r>
-              <a:rPr lang="en-US" smtClean="0"/>
+              <a:rPr lang="en-US"/>
               <a:t>Fourth level</a:t>
             </a:r>
           </a:p>
           <a:p>
             <a:pPr lvl="4"/>
             <a:r>
-              <a:rPr lang="en-US" smtClean="0"/>
+              <a:rPr lang="en-US"/>
               <a:t>Fifth level</a:t>
             </a:r>
-            <a:endParaRPr lang="en-US"/>
           </a:p>
         </p:txBody>
       </p:sp>
@@ -1298,38 +1303,37 @@
           <a:p>
             <a:pPr lvl="0"/>
             <a:r>
-              <a:rPr lang="en-US" smtClean="0"/>
+              <a:rPr lang="en-US"/>
               <a:t>Click to edit Master text styles</a:t>
             </a:r>
           </a:p>
           <a:p>
             <a:pPr lvl="1"/>
             <a:r>
-              <a:rPr lang="en-US" smtClean="0"/>
+              <a:rPr lang="en-US"/>
               <a:t>Second level</a:t>
             </a:r>
           </a:p>
           <a:p>
             <a:pPr lvl="2"/>
             <a:r>
-              <a:rPr lang="en-US" smtClean="0"/>
+              <a:rPr lang="en-US"/>
               <a:t>Third level</a:t>
             </a:r>
           </a:p>
           <a:p>
             <a:pPr lvl="3"/>
             <a:r>
-              <a:rPr lang="en-US" smtClean="0"/>
+              <a:rPr lang="en-US"/>
               <a:t>Fourth level</a:t>
             </a:r>
           </a:p>
           <a:p>
             <a:pPr lvl="4"/>
             <a:r>
-              <a:rPr lang="en-US" smtClean="0"/>
+              <a:rPr lang="en-US"/>
               <a:t>Fifth level</a:t>
             </a:r>
-            <a:endParaRPr lang="en-US"/>
           </a:p>
         </p:txBody>
       </p:sp>
@@ -1350,7 +1354,7 @@
           <a:p>
             <a:fld id="{5BCAD085-E8A6-8845-BD4E-CB4CCA059FC4}" type="datetimeFigureOut">
               <a:rPr lang="en-US" smtClean="0"/>
-              <a:t>1/27/13</a:t>
+              <a:t>7/9/2026</a:t>
             </a:fld>
             <a:endParaRPr lang="en-US"/>
           </a:p>
@@ -1448,10 +1452,9 @@
           </a:lstStyle>
           <a:p>
             <a:r>
-              <a:rPr lang="en-US" smtClean="0"/>
+              <a:rPr lang="en-US"/>
               <a:t>Click to edit Master title style</a:t>
             </a:r>
-            <a:endParaRPr lang="en-US"/>
           </a:p>
         </p:txBody>
       </p:sp>
@@ -1514,7 +1517,7 @@
           <a:p>
             <a:pPr lvl="0"/>
             <a:r>
-              <a:rPr lang="en-US" smtClean="0"/>
+              <a:rPr lang="en-US"/>
               <a:t>Click to edit Master text styles</a:t>
             </a:r>
           </a:p>
@@ -1570,38 +1573,37 @@
           <a:p>
             <a:pPr lvl="0"/>
             <a:r>
-              <a:rPr lang="en-US" smtClean="0"/>
+              <a:rPr lang="en-US"/>
               <a:t>Click to edit Master text styles</a:t>
             </a:r>
           </a:p>
           <a:p>
             <a:pPr lvl="1"/>
             <a:r>
-              <a:rPr lang="en-US" smtClean="0"/>
+              <a:rPr lang="en-US"/>
               <a:t>Second level</a:t>
             </a:r>
           </a:p>
           <a:p>
             <a:pPr lvl="2"/>
             <a:r>
-              <a:rPr lang="en-US" smtClean="0"/>
+              <a:rPr lang="en-US"/>
               <a:t>Third level</a:t>
             </a:r>
           </a:p>
           <a:p>
             <a:pPr lvl="3"/>
             <a:r>
-              <a:rPr lang="en-US" smtClean="0"/>
+              <a:rPr lang="en-US"/>
               <a:t>Fourth level</a:t>
             </a:r>
           </a:p>
           <a:p>
             <a:pPr lvl="4"/>
             <a:r>
-              <a:rPr lang="en-US" smtClean="0"/>
+              <a:rPr lang="en-US"/>
               <a:t>Fifth level</a:t>
             </a:r>
-            <a:endParaRPr lang="en-US"/>
           </a:p>
         </p:txBody>
       </p:sp>
@@ -1664,7 +1666,7 @@
           <a:p>
             <a:pPr lvl="0"/>
             <a:r>
-              <a:rPr lang="en-US" smtClean="0"/>
+              <a:rPr lang="en-US"/>
               <a:t>Click to edit Master text styles</a:t>
             </a:r>
           </a:p>
@@ -1720,38 +1722,37 @@
           <a:p>
             <a:pPr lvl="0"/>
             <a:r>
-              <a:rPr lang="en-US" smtClean="0"/>
+              <a:rPr lang="en-US"/>
               <a:t>Click to edit Master text styles</a:t>
             </a:r>
           </a:p>
           <a:p>
             <a:pPr lvl="1"/>
             <a:r>
-              <a:rPr lang="en-US" smtClean="0"/>
+              <a:rPr lang="en-US"/>
               <a:t>Second level</a:t>
             </a:r>
           </a:p>
           <a:p>
             <a:pPr lvl="2"/>
             <a:r>
-              <a:rPr lang="en-US" smtClean="0"/>
+              <a:rPr lang="en-US"/>
               <a:t>Third level</a:t>
             </a:r>
           </a:p>
           <a:p>
             <a:pPr lvl="3"/>
             <a:r>
-              <a:rPr lang="en-US" smtClean="0"/>
+              <a:rPr lang="en-US"/>
               <a:t>Fourth level</a:t>
             </a:r>
           </a:p>
           <a:p>
             <a:pPr lvl="4"/>
             <a:r>
-              <a:rPr lang="en-US" smtClean="0"/>
+              <a:rPr lang="en-US"/>
               <a:t>Fifth level</a:t>
             </a:r>
-            <a:endParaRPr lang="en-US"/>
           </a:p>
         </p:txBody>
       </p:sp>
@@ -1772,7 +1773,7 @@
           <a:p>
             <a:fld id="{5BCAD085-E8A6-8845-BD4E-CB4CCA059FC4}" type="datetimeFigureOut">
               <a:rPr lang="en-US" smtClean="0"/>
-              <a:t>1/27/13</a:t>
+              <a:t>7/9/2026</a:t>
             </a:fld>
             <a:endParaRPr lang="en-US"/>
           </a:p>
@@ -1866,10 +1867,9 @@
           <a:lstStyle/>
           <a:p>
             <a:r>
-              <a:rPr lang="en-US" smtClean="0"/>
+              <a:rPr lang="en-US"/>
               <a:t>Click to edit Master title style</a:t>
             </a:r>
-            <a:endParaRPr lang="en-US"/>
           </a:p>
         </p:txBody>
       </p:sp>
@@ -1890,7 +1890,7 @@
           <a:p>
             <a:fld id="{5BCAD085-E8A6-8845-BD4E-CB4CCA059FC4}" type="datetimeFigureOut">
               <a:rPr lang="en-US" smtClean="0"/>
-              <a:t>1/27/13</a:t>
+              <a:t>7/9/2026</a:t>
             </a:fld>
             <a:endParaRPr lang="en-US"/>
           </a:p>
@@ -1985,7 +1985,7 @@
           <a:p>
             <a:fld id="{5BCAD085-E8A6-8845-BD4E-CB4CCA059FC4}" type="datetimeFigureOut">
               <a:rPr lang="en-US" smtClean="0"/>
-              <a:t>1/27/13</a:t>
+              <a:t>7/9/2026</a:t>
             </a:fld>
             <a:endParaRPr lang="en-US"/>
           </a:p>
@@ -2088,10 +2088,9 @@
           </a:lstStyle>
           <a:p>
             <a:r>
-              <a:rPr lang="en-US" smtClean="0"/>
+              <a:rPr lang="en-US"/>
               <a:t>Click to edit Master title style</a:t>
             </a:r>
-            <a:endParaRPr lang="en-US"/>
           </a:p>
         </p:txBody>
       </p:sp>
@@ -2145,38 +2144,37 @@
           <a:p>
             <a:pPr lvl="0"/>
             <a:r>
-              <a:rPr lang="en-US" smtClean="0"/>
+              <a:rPr lang="en-US"/>
               <a:t>Click to edit Master text styles</a:t>
             </a:r>
           </a:p>
           <a:p>
             <a:pPr lvl="1"/>
             <a:r>
-              <a:rPr lang="en-US" smtClean="0"/>
+              <a:rPr lang="en-US"/>
               <a:t>Second level</a:t>
             </a:r>
           </a:p>
           <a:p>
             <a:pPr lvl="2"/>
             <a:r>
-              <a:rPr lang="en-US" smtClean="0"/>
+              <a:rPr lang="en-US"/>
               <a:t>Third level</a:t>
             </a:r>
           </a:p>
           <a:p>
             <a:pPr lvl="3"/>
             <a:r>
-              <a:rPr lang="en-US" smtClean="0"/>
+              <a:rPr lang="en-US"/>
               <a:t>Fourth level</a:t>
             </a:r>
           </a:p>
           <a:p>
             <a:pPr lvl="4"/>
             <a:r>
-              <a:rPr lang="en-US" smtClean="0"/>
+              <a:rPr lang="en-US"/>
               <a:t>Fifth level</a:t>
             </a:r>
-            <a:endParaRPr lang="en-US"/>
           </a:p>
         </p:txBody>
       </p:sp>
@@ -2239,7 +2237,7 @@
           <a:p>
             <a:pPr lvl="0"/>
             <a:r>
-              <a:rPr lang="en-US" smtClean="0"/>
+              <a:rPr lang="en-US"/>
               <a:t>Click to edit Master text styles</a:t>
             </a:r>
           </a:p>
@@ -2262,7 +2260,7 @@
           <a:p>
             <a:fld id="{5BCAD085-E8A6-8845-BD4E-CB4CCA059FC4}" type="datetimeFigureOut">
               <a:rPr lang="en-US" smtClean="0"/>
-              <a:t>1/27/13</a:t>
+              <a:t>7/9/2026</a:t>
             </a:fld>
             <a:endParaRPr lang="en-US"/>
           </a:p>
@@ -2365,10 +2363,9 @@
           </a:lstStyle>
           <a:p>
             <a:r>
-              <a:rPr lang="en-US" smtClean="0"/>
+              <a:rPr lang="en-US"/>
               <a:t>Click to edit Master title style</a:t>
             </a:r>
-            <a:endParaRPr lang="en-US"/>
           </a:p>
         </p:txBody>
       </p:sp>
@@ -2492,7 +2489,7 @@
           <a:p>
             <a:pPr lvl="0"/>
             <a:r>
-              <a:rPr lang="en-US" smtClean="0"/>
+              <a:rPr lang="en-US"/>
               <a:t>Click to edit Master text styles</a:t>
             </a:r>
           </a:p>
@@ -2515,7 +2512,7 @@
           <a:p>
             <a:fld id="{5BCAD085-E8A6-8845-BD4E-CB4CCA059FC4}" type="datetimeFigureOut">
               <a:rPr lang="en-US" smtClean="0"/>
-              <a:t>1/27/13</a:t>
+              <a:t>7/9/2026</a:t>
             </a:fld>
             <a:endParaRPr lang="en-US"/>
           </a:p>
@@ -2624,10 +2621,9 @@
           <a:lstStyle/>
           <a:p>
             <a:r>
-              <a:rPr lang="en-US" smtClean="0"/>
+              <a:rPr lang="en-US"/>
               <a:t>Click to edit Master title style</a:t>
             </a:r>
-            <a:endParaRPr lang="en-US"/>
           </a:p>
         </p:txBody>
       </p:sp>
@@ -2658,38 +2654,37 @@
           <a:p>
             <a:pPr lvl="0"/>
             <a:r>
-              <a:rPr lang="en-US" smtClean="0"/>
+              <a:rPr lang="en-US"/>
               <a:t>Click to edit Master text styles</a:t>
             </a:r>
           </a:p>
           <a:p>
             <a:pPr lvl="1"/>
             <a:r>
-              <a:rPr lang="en-US" smtClean="0"/>
+              <a:rPr lang="en-US"/>
               <a:t>Second level</a:t>
             </a:r>
           </a:p>
           <a:p>
             <a:pPr lvl="2"/>
             <a:r>
-              <a:rPr lang="en-US" smtClean="0"/>
+              <a:rPr lang="en-US"/>
               <a:t>Third level</a:t>
             </a:r>
           </a:p>
           <a:p>
             <a:pPr lvl="3"/>
             <a:r>
-              <a:rPr lang="en-US" smtClean="0"/>
+              <a:rPr lang="en-US"/>
               <a:t>Fourth level</a:t>
             </a:r>
           </a:p>
           <a:p>
             <a:pPr lvl="4"/>
             <a:r>
-              <a:rPr lang="en-US" smtClean="0"/>
+              <a:rPr lang="en-US"/>
               <a:t>Fifth level</a:t>
             </a:r>
-            <a:endParaRPr lang="en-US"/>
           </a:p>
         </p:txBody>
       </p:sp>
@@ -2728,7 +2723,7 @@
           <a:p>
             <a:fld id="{5BCAD085-E8A6-8845-BD4E-CB4CCA059FC4}" type="datetimeFigureOut">
               <a:rPr lang="en-US" smtClean="0"/>
-              <a:t>1/27/13</a:t>
+              <a:t>7/9/2026</a:t>
             </a:fld>
             <a:endParaRPr lang="en-US"/>
           </a:p>
@@ -3087,7 +3082,7 @@
 </file>
 
 <file path=ppt/slides/slide1.xml><?xml version="1.0" encoding="utf-8"?>
-<p:sld xmlns:a="http://schemas.openxmlformats.org/drawingml/2006/main" xmlns:p="http://schemas.openxmlformats.org/presentationml/2006/main" xmlns:r="http://schemas.openxmlformats.org/officeDocument/2006/relationships">
+<p:sld xmlns:a="http://schemas.openxmlformats.org/drawingml/2006/main" xmlns:r="http://schemas.openxmlformats.org/officeDocument/2006/relationships" xmlns:p="http://schemas.openxmlformats.org/presentationml/2006/main">
   <p:cSld>
     <p:bg>
       <p:bgPr>
@@ -3103,7 +3098,14 @@
         <p:cNvGrpSpPr/>
         <p:nvPr/>
       </p:nvGrpSpPr>
-      <p:grpSpPr/>
+      <p:grpSpPr>
+        <a:xfrm>
+          <a:off x="0" y="0"/>
+          <a:ext cx="0" cy="0"/>
+          <a:chOff x="0" y="0"/>
+          <a:chExt cx="0" cy="0"/>
+        </a:xfrm>
+      </p:grpSpPr>
       <p:sp>
         <p:nvSpPr>
           <p:cNvPr id="2" name="TextBox 1"/>
@@ -3121,7 +3123,7 @@
           <a:noFill/>
         </p:spPr>
         <p:txBody>
-          <a:bodyPr wrap="square" anchor="t" lIns="27432" rIns="27432" tIns="18288" bIns="18288">
+          <a:bodyPr wrap="square" lIns="27432" tIns="18288" rIns="27432" bIns="18288" anchor="t">
             <a:spAutoFit/>
           </a:bodyPr>
           <a:lstStyle/>
@@ -3160,7 +3162,7 @@
           <a:noFill/>
         </p:spPr>
         <p:txBody>
-          <a:bodyPr wrap="square" anchor="t" lIns="27432" rIns="27432" tIns="18288" bIns="18288">
+          <a:bodyPr wrap="square" lIns="27432" tIns="18288" rIns="27432" bIns="18288" anchor="t">
             <a:spAutoFit/>
           </a:bodyPr>
           <a:lstStyle/>
@@ -3199,7 +3201,7 @@
           <a:noFill/>
         </p:spPr>
         <p:txBody>
-          <a:bodyPr wrap="square" anchor="t" lIns="27432" rIns="27432" tIns="18288" bIns="18288">
+          <a:bodyPr wrap="square" lIns="27432" tIns="18288" rIns="27432" bIns="18288" anchor="t">
             <a:spAutoFit/>
           </a:bodyPr>
           <a:lstStyle/>
@@ -3238,7 +3240,7 @@
           <a:noFill/>
         </p:spPr>
         <p:txBody>
-          <a:bodyPr wrap="square" anchor="t" lIns="27432" rIns="27432" tIns="18288" bIns="18288">
+          <a:bodyPr wrap="square" lIns="27432" tIns="18288" rIns="27432" bIns="18288" anchor="t">
             <a:spAutoFit/>
           </a:bodyPr>
           <a:lstStyle/>
@@ -3277,7 +3279,7 @@
           <a:noFill/>
         </p:spPr>
         <p:txBody>
-          <a:bodyPr wrap="square" anchor="t" lIns="27432" rIns="27432" tIns="18288" bIns="18288">
+          <a:bodyPr wrap="square" lIns="27432" tIns="18288" rIns="27432" bIns="18288" anchor="t">
             <a:spAutoFit/>
           </a:bodyPr>
           <a:lstStyle/>
@@ -3316,7 +3318,7 @@
           <a:noFill/>
         </p:spPr>
         <p:txBody>
-          <a:bodyPr wrap="square" anchor="t" lIns="27432" rIns="27432" tIns="18288" bIns="18288">
+          <a:bodyPr wrap="square" lIns="27432" tIns="18288" rIns="27432" bIns="18288" anchor="t">
             <a:spAutoFit/>
           </a:bodyPr>
           <a:lstStyle/>
@@ -3347,7 +3349,7 @@
 </file>
 
 <file path=ppt/slides/slide2.xml><?xml version="1.0" encoding="utf-8"?>
-<p:sld xmlns:a="http://schemas.openxmlformats.org/drawingml/2006/main" xmlns:p="http://schemas.openxmlformats.org/presentationml/2006/main" xmlns:r="http://schemas.openxmlformats.org/officeDocument/2006/relationships">
+<p:sld xmlns:a="http://schemas.openxmlformats.org/drawingml/2006/main" xmlns:r="http://schemas.openxmlformats.org/officeDocument/2006/relationships" xmlns:p="http://schemas.openxmlformats.org/presentationml/2006/main">
   <p:cSld>
     <p:bg>
       <p:bgPr>
@@ -3363,7 +3365,14 @@
         <p:cNvGrpSpPr/>
         <p:nvPr/>
       </p:nvGrpSpPr>
-      <p:grpSpPr/>
+      <p:grpSpPr>
+        <a:xfrm>
+          <a:off x="0" y="0"/>
+          <a:ext cx="0" cy="0"/>
+          <a:chOff x="0" y="0"/>
+          <a:chExt cx="0" cy="0"/>
+        </a:xfrm>
+      </p:grpSpPr>
       <p:sp>
         <p:nvSpPr>
           <p:cNvPr id="2" name="TextBox 1"/>
@@ -3381,7 +3390,7 @@
           <a:noFill/>
         </p:spPr>
         <p:txBody>
-          <a:bodyPr wrap="square" anchor="t" lIns="27432" rIns="27432" tIns="18288" bIns="18288">
+          <a:bodyPr wrap="square" lIns="27432" tIns="18288" rIns="27432" bIns="18288" anchor="t">
             <a:spAutoFit/>
           </a:bodyPr>
           <a:lstStyle/>
@@ -3420,7 +3429,7 @@
           <a:noFill/>
         </p:spPr>
         <p:txBody>
-          <a:bodyPr wrap="square" anchor="t" lIns="27432" rIns="27432" tIns="18288" bIns="18288">
+          <a:bodyPr wrap="square" lIns="27432" tIns="18288" rIns="27432" bIns="18288" anchor="t">
             <a:spAutoFit/>
           </a:bodyPr>
           <a:lstStyle/>
@@ -3459,7 +3468,7 @@
           <a:noFill/>
         </p:spPr>
         <p:txBody>
-          <a:bodyPr wrap="square" anchor="t" lIns="27432" rIns="27432" tIns="18288" bIns="18288">
+          <a:bodyPr wrap="square" lIns="27432" tIns="18288" rIns="27432" bIns="18288" anchor="t">
             <a:spAutoFit/>
           </a:bodyPr>
           <a:lstStyle/>
@@ -3489,7 +3498,7 @@
         </p:nvSpPr>
         <p:spPr>
           <a:xfrm>
-            <a:off x="502920" y="6510528"/>
+            <a:off x="502920" y="6620256"/>
             <a:ext cx="4572000" cy="274320"/>
           </a:xfrm>
           <a:prstGeom prst="rect">
@@ -3498,7 +3507,7 @@
           <a:noFill/>
         </p:spPr>
         <p:txBody>
-          <a:bodyPr wrap="square" anchor="t" lIns="27432" rIns="27432" tIns="18288" bIns="18288">
+          <a:bodyPr wrap="square" lIns="27432" tIns="18288" rIns="27432" bIns="18288" anchor="t">
             <a:spAutoFit/>
           </a:bodyPr>
           <a:lstStyle/>
@@ -3537,7 +3546,7 @@
           <a:noFill/>
         </p:spPr>
         <p:txBody>
-          <a:bodyPr wrap="square" anchor="t" lIns="27432" rIns="27432" tIns="18288" bIns="18288">
+          <a:bodyPr wrap="square" lIns="27432" tIns="18288" rIns="27432" bIns="18288" anchor="t">
             <a:spAutoFit/>
           </a:bodyPr>
           <a:lstStyle/>
@@ -3599,7 +3608,7 @@
           </a:fontRef>
         </p:style>
         <p:txBody>
-          <a:bodyPr rtlCol="0" anchor="t" wrap="square" lIns="201168" rIns="201168" tIns="146304"/>
+          <a:bodyPr wrap="square" lIns="201168" tIns="146304" rIns="201168" rtlCol="0" anchor="t"/>
           <a:lstStyle/>
           <a:p>
             <a:pPr algn="l" latinLnBrk="0">
@@ -3675,7 +3684,7 @@
           </a:fontRef>
         </p:style>
         <p:txBody>
-          <a:bodyPr rtlCol="0" anchor="t" wrap="square" lIns="201168" rIns="201168" tIns="146304"/>
+          <a:bodyPr wrap="square" lIns="201168" tIns="146304" rIns="201168" rtlCol="0" anchor="t"/>
           <a:lstStyle/>
           <a:p>
             <a:pPr algn="l" latinLnBrk="0">
@@ -3751,7 +3760,7 @@
           </a:fontRef>
         </p:style>
         <p:txBody>
-          <a:bodyPr rtlCol="0" anchor="t" wrap="square" lIns="201168" rIns="201168" tIns="146304"/>
+          <a:bodyPr wrap="square" lIns="201168" tIns="146304" rIns="201168" rtlCol="0" anchor="t"/>
           <a:lstStyle/>
           <a:p>
             <a:pPr algn="l" latinLnBrk="0">
@@ -3827,7 +3836,7 @@
           </a:fontRef>
         </p:style>
         <p:txBody>
-          <a:bodyPr rtlCol="0" anchor="t" wrap="square" lIns="201168" rIns="201168" tIns="146304"/>
+          <a:bodyPr wrap="square" lIns="201168" tIns="146304" rIns="201168" rtlCol="0" anchor="t"/>
           <a:lstStyle/>
           <a:p>
             <a:pPr algn="l" latinLnBrk="0">
@@ -3901,7 +3910,7 @@
           </a:fontRef>
         </p:style>
         <p:txBody>
-          <a:bodyPr rtlCol="0" anchor="ctr" wrap="square"/>
+          <a:bodyPr wrap="square" rtlCol="0" anchor="ctr"/>
           <a:lstStyle/>
           <a:p>
             <a:pPr algn="ctr" latinLnBrk="0"/>
@@ -3926,7 +3935,7 @@
 </file>
 
 <file path=ppt/slides/slide3.xml><?xml version="1.0" encoding="utf-8"?>
-<p:sld xmlns:a="http://schemas.openxmlformats.org/drawingml/2006/main" xmlns:p="http://schemas.openxmlformats.org/presentationml/2006/main" xmlns:r="http://schemas.openxmlformats.org/officeDocument/2006/relationships">
+<p:sld xmlns:a="http://schemas.openxmlformats.org/drawingml/2006/main" xmlns:r="http://schemas.openxmlformats.org/officeDocument/2006/relationships" xmlns:p="http://schemas.openxmlformats.org/presentationml/2006/main">
   <p:cSld>
     <p:bg>
       <p:bgPr>
@@ -3942,7 +3951,14 @@
         <p:cNvGrpSpPr/>
         <p:nvPr/>
       </p:nvGrpSpPr>
-      <p:grpSpPr/>
+      <p:grpSpPr>
+        <a:xfrm>
+          <a:off x="0" y="0"/>
+          <a:ext cx="0" cy="0"/>
+          <a:chOff x="0" y="0"/>
+          <a:chExt cx="0" cy="0"/>
+        </a:xfrm>
+      </p:grpSpPr>
       <p:sp>
         <p:nvSpPr>
           <p:cNvPr id="2" name="TextBox 1"/>
@@ -3960,7 +3976,7 @@
           <a:noFill/>
         </p:spPr>
         <p:txBody>
-          <a:bodyPr wrap="square" anchor="t" lIns="27432" rIns="27432" tIns="18288" bIns="18288">
+          <a:bodyPr wrap="square" lIns="27432" tIns="18288" rIns="27432" bIns="18288" anchor="t">
             <a:spAutoFit/>
           </a:bodyPr>
           <a:lstStyle/>
@@ -3999,7 +4015,7 @@
           <a:noFill/>
         </p:spPr>
         <p:txBody>
-          <a:bodyPr wrap="square" anchor="t" lIns="27432" rIns="27432" tIns="18288" bIns="18288">
+          <a:bodyPr wrap="square" lIns="27432" tIns="18288" rIns="27432" bIns="18288" anchor="t">
             <a:spAutoFit/>
           </a:bodyPr>
           <a:lstStyle/>
@@ -4038,7 +4054,7 @@
           <a:noFill/>
         </p:spPr>
         <p:txBody>
-          <a:bodyPr wrap="square" anchor="t" lIns="27432" rIns="27432" tIns="18288" bIns="18288">
+          <a:bodyPr wrap="square" lIns="27432" tIns="18288" rIns="27432" bIns="18288" anchor="t">
             <a:spAutoFit/>
           </a:bodyPr>
           <a:lstStyle/>
@@ -4068,7 +4084,7 @@
         </p:nvSpPr>
         <p:spPr>
           <a:xfrm>
-            <a:off x="502920" y="6510528"/>
+            <a:off x="502920" y="6620256"/>
             <a:ext cx="4572000" cy="274320"/>
           </a:xfrm>
           <a:prstGeom prst="rect">
@@ -4077,7 +4093,7 @@
           <a:noFill/>
         </p:spPr>
         <p:txBody>
-          <a:bodyPr wrap="square" anchor="t" lIns="27432" rIns="27432" tIns="18288" bIns="18288">
+          <a:bodyPr wrap="square" lIns="27432" tIns="18288" rIns="27432" bIns="18288" anchor="t">
             <a:spAutoFit/>
           </a:bodyPr>
           <a:lstStyle/>
@@ -4116,7 +4132,7 @@
           <a:noFill/>
         </p:spPr>
         <p:txBody>
-          <a:bodyPr wrap="square" anchor="t" lIns="27432" rIns="27432" tIns="18288" bIns="18288">
+          <a:bodyPr wrap="square" lIns="27432" tIns="18288" rIns="27432" bIns="18288" anchor="t">
             <a:spAutoFit/>
           </a:bodyPr>
           <a:lstStyle/>
@@ -4178,7 +4194,7 @@
           </a:fontRef>
         </p:style>
         <p:txBody>
-          <a:bodyPr rtlCol="0" anchor="t" wrap="square" lIns="201168" rIns="201168" tIns="146304"/>
+          <a:bodyPr wrap="square" lIns="201168" tIns="146304" rIns="201168" rtlCol="0" anchor="t"/>
           <a:lstStyle/>
           <a:p>
             <a:pPr algn="l" latinLnBrk="0">
@@ -4254,7 +4270,7 @@
           </a:fontRef>
         </p:style>
         <p:txBody>
-          <a:bodyPr rtlCol="0" anchor="t" wrap="square" lIns="201168" rIns="201168" tIns="146304"/>
+          <a:bodyPr wrap="square" lIns="201168" tIns="146304" rIns="201168" rtlCol="0" anchor="t"/>
           <a:lstStyle/>
           <a:p>
             <a:pPr algn="l" latinLnBrk="0">
@@ -4330,7 +4346,7 @@
           </a:fontRef>
         </p:style>
         <p:txBody>
-          <a:bodyPr rtlCol="0" anchor="t" wrap="square" lIns="201168" rIns="201168" tIns="146304"/>
+          <a:bodyPr wrap="square" lIns="201168" tIns="146304" rIns="201168" rtlCol="0" anchor="t"/>
           <a:lstStyle/>
           <a:p>
             <a:pPr algn="l" latinLnBrk="0">
@@ -4406,7 +4422,7 @@
           </a:fontRef>
         </p:style>
         <p:txBody>
-          <a:bodyPr rtlCol="0" anchor="t" wrap="square" lIns="201168" rIns="201168" tIns="146304"/>
+          <a:bodyPr wrap="square" lIns="201168" tIns="146304" rIns="201168" rtlCol="0" anchor="t"/>
           <a:lstStyle/>
           <a:p>
             <a:pPr algn="l" latinLnBrk="0">
@@ -4482,7 +4498,7 @@
           </a:fontRef>
         </p:style>
         <p:txBody>
-          <a:bodyPr rtlCol="0" anchor="t" wrap="square" lIns="201168" rIns="201168" tIns="146304"/>
+          <a:bodyPr wrap="square" lIns="201168" tIns="146304" rIns="201168" rtlCol="0" anchor="t"/>
           <a:lstStyle/>
           <a:p>
             <a:pPr algn="l" latinLnBrk="0">
@@ -4556,7 +4572,7 @@
           </a:fontRef>
         </p:style>
         <p:txBody>
-          <a:bodyPr rtlCol="0" anchor="ctr" wrap="square"/>
+          <a:bodyPr wrap="square" rtlCol="0" anchor="ctr"/>
           <a:lstStyle/>
           <a:p>
             <a:pPr algn="ctr" latinLnBrk="0"/>
@@ -4581,7 +4597,7 @@
 </file>
 
 <file path=ppt/slides/slide4.xml><?xml version="1.0" encoding="utf-8"?>
-<p:sld xmlns:a="http://schemas.openxmlformats.org/drawingml/2006/main" xmlns:p="http://schemas.openxmlformats.org/presentationml/2006/main" xmlns:r="http://schemas.openxmlformats.org/officeDocument/2006/relationships">
+<p:sld xmlns:a="http://schemas.openxmlformats.org/drawingml/2006/main" xmlns:r="http://schemas.openxmlformats.org/officeDocument/2006/relationships" xmlns:p="http://schemas.openxmlformats.org/presentationml/2006/main">
   <p:cSld>
     <p:bg>
       <p:bgPr>
@@ -4597,7 +4613,14 @@
         <p:cNvGrpSpPr/>
         <p:nvPr/>
       </p:nvGrpSpPr>
-      <p:grpSpPr/>
+      <p:grpSpPr>
+        <a:xfrm>
+          <a:off x="0" y="0"/>
+          <a:ext cx="0" cy="0"/>
+          <a:chOff x="0" y="0"/>
+          <a:chExt cx="0" cy="0"/>
+        </a:xfrm>
+      </p:grpSpPr>
       <p:sp>
         <p:nvSpPr>
           <p:cNvPr id="2" name="TextBox 1"/>
@@ -4615,7 +4638,7 @@
           <a:noFill/>
         </p:spPr>
         <p:txBody>
-          <a:bodyPr wrap="square" anchor="t" lIns="27432" rIns="27432" tIns="18288" bIns="18288">
+          <a:bodyPr wrap="square" lIns="27432" tIns="18288" rIns="27432" bIns="18288" anchor="t">
             <a:spAutoFit/>
           </a:bodyPr>
           <a:lstStyle/>
@@ -4654,7 +4677,7 @@
           <a:noFill/>
         </p:spPr>
         <p:txBody>
-          <a:bodyPr wrap="square" anchor="t" lIns="27432" rIns="27432" tIns="18288" bIns="18288">
+          <a:bodyPr wrap="square" lIns="27432" tIns="18288" rIns="27432" bIns="18288" anchor="t">
             <a:spAutoFit/>
           </a:bodyPr>
           <a:lstStyle/>
@@ -4693,7 +4716,7 @@
           <a:noFill/>
         </p:spPr>
         <p:txBody>
-          <a:bodyPr wrap="square" anchor="t" lIns="27432" rIns="27432" tIns="18288" bIns="18288">
+          <a:bodyPr wrap="square" lIns="27432" tIns="18288" rIns="27432" bIns="18288" anchor="t">
             <a:spAutoFit/>
           </a:bodyPr>
           <a:lstStyle/>
@@ -4723,7 +4746,7 @@
         </p:nvSpPr>
         <p:spPr>
           <a:xfrm>
-            <a:off x="502920" y="6510528"/>
+            <a:off x="502920" y="6583680"/>
             <a:ext cx="4572000" cy="274320"/>
           </a:xfrm>
           <a:prstGeom prst="rect">
@@ -4732,7 +4755,7 @@
           <a:noFill/>
         </p:spPr>
         <p:txBody>
-          <a:bodyPr wrap="square" anchor="t" lIns="27432" rIns="27432" tIns="18288" bIns="18288">
+          <a:bodyPr wrap="square" lIns="27432" tIns="18288" rIns="27432" bIns="18288" anchor="t">
             <a:spAutoFit/>
           </a:bodyPr>
           <a:lstStyle/>
@@ -4743,7 +4766,7 @@
               </a:lnSpc>
             </a:pPr>
             <a:r>
-              <a:rPr sz="1000" b="0">
+              <a:rPr sz="1000" b="0" dirty="0">
                 <a:solidFill>
                   <a:srgbClr val="6E6A60"/>
                 </a:solidFill>
@@ -4794,7 +4817,7 @@
           </a:fontRef>
         </p:style>
         <p:txBody>
-          <a:bodyPr rtlCol="0" anchor="t" wrap="square" lIns="201168" rIns="201168" tIns="146304"/>
+          <a:bodyPr wrap="square" lIns="201168" tIns="146304" rIns="201168" rtlCol="0" anchor="t"/>
           <a:lstStyle/>
           <a:p>
             <a:pPr algn="l" latinLnBrk="0">
@@ -4918,7 +4941,7 @@
           </a:fontRef>
         </p:style>
         <p:txBody>
-          <a:bodyPr rtlCol="0" anchor="ctr" wrap="square"/>
+          <a:bodyPr wrap="square" rtlCol="0" anchor="ctr"/>
           <a:lstStyle/>
           <a:p>
             <a:pPr algn="ctr" latinLnBrk="0"/>
@@ -4986,7 +5009,7 @@
           </a:fontRef>
         </p:style>
         <p:txBody>
-          <a:bodyPr rtlCol="0" anchor="ctr" wrap="square"/>
+          <a:bodyPr wrap="square" rtlCol="0" anchor="ctr"/>
           <a:lstStyle/>
           <a:p>
             <a:pPr algn="ctr" latinLnBrk="0"/>
@@ -5054,7 +5077,7 @@
           </a:fontRef>
         </p:style>
         <p:txBody>
-          <a:bodyPr rtlCol="0" anchor="ctr" wrap="square"/>
+          <a:bodyPr wrap="square" rtlCol="0" anchor="ctr"/>
           <a:lstStyle/>
           <a:p>
             <a:pPr algn="ctr" latinLnBrk="0"/>
@@ -5099,7 +5122,7 @@
           <a:noFill/>
         </p:spPr>
         <p:txBody>
-          <a:bodyPr wrap="square" anchor="t" lIns="27432" rIns="27432" tIns="18288" bIns="18288">
+          <a:bodyPr wrap="square" lIns="27432" tIns="18288" rIns="27432" bIns="18288" anchor="t">
             <a:spAutoFit/>
           </a:bodyPr>
           <a:lstStyle/>
@@ -5159,7 +5182,7 @@
           </a:fontRef>
         </p:style>
         <p:txBody>
-          <a:bodyPr rtlCol="0" anchor="ctr" wrap="square"/>
+          <a:bodyPr wrap="square" rtlCol="0" anchor="ctr"/>
           <a:lstStyle/>
           <a:p>
             <a:pPr algn="ctr" latinLnBrk="0"/>
@@ -5184,7 +5207,7 @@
 </file>
 
 <file path=ppt/slides/slide5.xml><?xml version="1.0" encoding="utf-8"?>
-<p:sld xmlns:a="http://schemas.openxmlformats.org/drawingml/2006/main" xmlns:p="http://schemas.openxmlformats.org/presentationml/2006/main" xmlns:r="http://schemas.openxmlformats.org/officeDocument/2006/relationships">
+<p:sld xmlns:a="http://schemas.openxmlformats.org/drawingml/2006/main" xmlns:r="http://schemas.openxmlformats.org/officeDocument/2006/relationships" xmlns:p="http://schemas.openxmlformats.org/presentationml/2006/main">
   <p:cSld>
     <p:bg>
       <p:bgPr>
@@ -5200,7 +5223,14 @@
         <p:cNvGrpSpPr/>
         <p:nvPr/>
       </p:nvGrpSpPr>
-      <p:grpSpPr/>
+      <p:grpSpPr>
+        <a:xfrm>
+          <a:off x="0" y="0"/>
+          <a:ext cx="0" cy="0"/>
+          <a:chOff x="0" y="0"/>
+          <a:chExt cx="0" cy="0"/>
+        </a:xfrm>
+      </p:grpSpPr>
       <p:sp>
         <p:nvSpPr>
           <p:cNvPr id="2" name="TextBox 1"/>
@@ -5218,7 +5248,7 @@
           <a:noFill/>
         </p:spPr>
         <p:txBody>
-          <a:bodyPr wrap="square" anchor="t" lIns="27432" rIns="27432" tIns="18288" bIns="18288">
+          <a:bodyPr wrap="square" lIns="27432" tIns="18288" rIns="27432" bIns="18288" anchor="t">
             <a:spAutoFit/>
           </a:bodyPr>
           <a:lstStyle/>
@@ -5257,7 +5287,7 @@
           <a:noFill/>
         </p:spPr>
         <p:txBody>
-          <a:bodyPr wrap="square" anchor="t" lIns="27432" rIns="27432" tIns="18288" bIns="18288">
+          <a:bodyPr wrap="square" lIns="27432" tIns="18288" rIns="27432" bIns="18288" anchor="t">
             <a:spAutoFit/>
           </a:bodyPr>
           <a:lstStyle/>
@@ -5296,7 +5326,7 @@
           <a:noFill/>
         </p:spPr>
         <p:txBody>
-          <a:bodyPr wrap="square" anchor="t" lIns="27432" rIns="27432" tIns="18288" bIns="18288">
+          <a:bodyPr wrap="square" lIns="27432" tIns="18288" rIns="27432" bIns="18288" anchor="t">
             <a:spAutoFit/>
           </a:bodyPr>
           <a:lstStyle/>
@@ -5326,7 +5356,7 @@
         </p:nvSpPr>
         <p:spPr>
           <a:xfrm>
-            <a:off x="502920" y="6510528"/>
+            <a:off x="502920" y="6647688"/>
             <a:ext cx="4572000" cy="274320"/>
           </a:xfrm>
           <a:prstGeom prst="rect">
@@ -5335,7 +5365,7 @@
           <a:noFill/>
         </p:spPr>
         <p:txBody>
-          <a:bodyPr wrap="square" anchor="t" lIns="27432" rIns="27432" tIns="18288" bIns="18288">
+          <a:bodyPr wrap="square" lIns="27432" tIns="18288" rIns="27432" bIns="18288" anchor="t">
             <a:spAutoFit/>
           </a:bodyPr>
           <a:lstStyle/>
@@ -5398,7 +5428,7 @@
           <a:noFill/>
         </p:spPr>
         <p:txBody>
-          <a:bodyPr wrap="square" anchor="t" lIns="27432" rIns="27432" tIns="18288" bIns="18288">
+          <a:bodyPr wrap="square" lIns="27432" tIns="18288" rIns="27432" bIns="18288" anchor="t">
             <a:spAutoFit/>
           </a:bodyPr>
           <a:lstStyle/>
@@ -5465,7 +5495,7 @@
           </a:fontRef>
         </p:style>
         <p:txBody>
-          <a:bodyPr rtlCol="0" anchor="ctr" wrap="square"/>
+          <a:bodyPr wrap="square" rtlCol="0" anchor="ctr"/>
           <a:lstStyle/>
           <a:p>
             <a:pPr algn="ctr" latinLnBrk="0"/>
@@ -5490,7 +5520,7 @@
 </file>
 
 <file path=ppt/slides/slide6.xml><?xml version="1.0" encoding="utf-8"?>
-<p:sld xmlns:a="http://schemas.openxmlformats.org/drawingml/2006/main" xmlns:p="http://schemas.openxmlformats.org/presentationml/2006/main" xmlns:r="http://schemas.openxmlformats.org/officeDocument/2006/relationships">
+<p:sld xmlns:a="http://schemas.openxmlformats.org/drawingml/2006/main" xmlns:r="http://schemas.openxmlformats.org/officeDocument/2006/relationships" xmlns:p="http://schemas.openxmlformats.org/presentationml/2006/main">
   <p:cSld>
     <p:bg>
       <p:bgPr>
@@ -5506,7 +5536,14 @@
         <p:cNvGrpSpPr/>
         <p:nvPr/>
       </p:nvGrpSpPr>
-      <p:grpSpPr/>
+      <p:grpSpPr>
+        <a:xfrm>
+          <a:off x="0" y="0"/>
+          <a:ext cx="0" cy="0"/>
+          <a:chOff x="0" y="0"/>
+          <a:chExt cx="0" cy="0"/>
+        </a:xfrm>
+      </p:grpSpPr>
       <p:sp>
         <p:nvSpPr>
           <p:cNvPr id="2" name="TextBox 1"/>
@@ -5524,7 +5561,7 @@
           <a:noFill/>
         </p:spPr>
         <p:txBody>
-          <a:bodyPr wrap="square" anchor="t" lIns="27432" rIns="27432" tIns="18288" bIns="18288">
+          <a:bodyPr wrap="square" lIns="27432" tIns="18288" rIns="27432" bIns="18288" anchor="t">
             <a:spAutoFit/>
           </a:bodyPr>
           <a:lstStyle/>
@@ -5563,7 +5600,7 @@
           <a:noFill/>
         </p:spPr>
         <p:txBody>
-          <a:bodyPr wrap="square" anchor="t" lIns="27432" rIns="27432" tIns="18288" bIns="18288">
+          <a:bodyPr wrap="square" lIns="27432" tIns="18288" rIns="27432" bIns="18288" anchor="t">
             <a:spAutoFit/>
           </a:bodyPr>
           <a:lstStyle/>
@@ -5602,7 +5639,7 @@
           <a:noFill/>
         </p:spPr>
         <p:txBody>
-          <a:bodyPr wrap="square" anchor="t" lIns="27432" rIns="27432" tIns="18288" bIns="18288">
+          <a:bodyPr wrap="square" lIns="27432" tIns="18288" rIns="27432" bIns="18288" anchor="t">
             <a:spAutoFit/>
           </a:bodyPr>
           <a:lstStyle/>
@@ -5632,7 +5669,7 @@
         </p:nvSpPr>
         <p:spPr>
           <a:xfrm>
-            <a:off x="502920" y="6510528"/>
+            <a:off x="502920" y="6620256"/>
             <a:ext cx="4572000" cy="274320"/>
           </a:xfrm>
           <a:prstGeom prst="rect">
@@ -5641,7 +5678,7 @@
           <a:noFill/>
         </p:spPr>
         <p:txBody>
-          <a:bodyPr wrap="square" anchor="t" lIns="27432" rIns="27432" tIns="18288" bIns="18288">
+          <a:bodyPr wrap="square" lIns="27432" tIns="18288" rIns="27432" bIns="18288" anchor="t">
             <a:spAutoFit/>
           </a:bodyPr>
           <a:lstStyle/>
@@ -5652,7 +5689,7 @@
               </a:lnSpc>
             </a:pPr>
             <a:r>
-              <a:rPr sz="1000" b="0">
+              <a:rPr sz="1000" b="0" dirty="0">
                 <a:solidFill>
                   <a:srgbClr val="6E6A60"/>
                 </a:solidFill>
@@ -5703,7 +5740,7 @@
           </a:fontRef>
         </p:style>
         <p:txBody>
-          <a:bodyPr rtlCol="0" anchor="t" wrap="square" lIns="201168" rIns="201168" tIns="146304"/>
+          <a:bodyPr wrap="square" lIns="201168" tIns="146304" rIns="201168" rtlCol="0" anchor="t"/>
           <a:lstStyle/>
           <a:p>
             <a:pPr algn="l" latinLnBrk="0">
@@ -5795,7 +5832,7 @@
           </a:fontRef>
         </p:style>
         <p:txBody>
-          <a:bodyPr rtlCol="0" anchor="t" wrap="square" lIns="201168" rIns="201168" tIns="146304"/>
+          <a:bodyPr wrap="square" lIns="201168" tIns="146304" rIns="201168" rtlCol="0" anchor="t"/>
           <a:lstStyle/>
           <a:p>
             <a:pPr algn="l" latinLnBrk="0">
@@ -5871,7 +5908,7 @@
           </a:fontRef>
         </p:style>
         <p:txBody>
-          <a:bodyPr rtlCol="0" anchor="ctr" wrap="square"/>
+          <a:bodyPr wrap="square" rtlCol="0" anchor="ctr"/>
           <a:lstStyle/>
           <a:p>
             <a:pPr algn="ctr" latinLnBrk="0"/>
@@ -5939,7 +5976,7 @@
           </a:fontRef>
         </p:style>
         <p:txBody>
-          <a:bodyPr rtlCol="0" anchor="ctr" wrap="square"/>
+          <a:bodyPr wrap="square" rtlCol="0" anchor="ctr"/>
           <a:lstStyle/>
           <a:p>
             <a:pPr algn="ctr" latinLnBrk="0"/>
@@ -6007,7 +6044,7 @@
           </a:fontRef>
         </p:style>
         <p:txBody>
-          <a:bodyPr rtlCol="0" anchor="ctr" wrap="square"/>
+          <a:bodyPr wrap="square" rtlCol="0" anchor="ctr"/>
           <a:lstStyle/>
           <a:p>
             <a:pPr algn="ctr" latinLnBrk="0"/>
@@ -6052,7 +6089,7 @@
           <a:noFill/>
         </p:spPr>
         <p:txBody>
-          <a:bodyPr wrap="square" anchor="t" lIns="27432" rIns="27432" tIns="18288" bIns="18288">
+          <a:bodyPr wrap="square" lIns="27432" tIns="18288" rIns="27432" bIns="18288" anchor="t">
             <a:spAutoFit/>
           </a:bodyPr>
           <a:lstStyle/>
@@ -6082,7 +6119,7 @@
         </p:nvSpPr>
         <p:spPr>
           <a:xfrm>
-            <a:off x="502920" y="5074920"/>
+            <a:off x="502919" y="5225796"/>
             <a:ext cx="11185855" cy="777240"/>
           </a:xfrm>
           <a:prstGeom prst="rect">
@@ -6091,7 +6128,7 @@
           <a:noFill/>
         </p:spPr>
         <p:txBody>
-          <a:bodyPr wrap="square" anchor="t" lIns="27432" rIns="27432" tIns="18288" bIns="18288">
+          <a:bodyPr wrap="square" lIns="27432" tIns="18288" rIns="27432" bIns="18288" anchor="t">
             <a:spAutoFit/>
           </a:bodyPr>
           <a:lstStyle/>
@@ -6102,7 +6139,7 @@
               </a:lnSpc>
             </a:pPr>
             <a:r>
-              <a:rPr sz="1150" b="0">
+              <a:rPr sz="1150" b="0" dirty="0">
                 <a:solidFill>
                   <a:srgbClr val="6E6A60"/>
                 </a:solidFill>
@@ -6151,7 +6188,7 @@
           </a:fontRef>
         </p:style>
         <p:txBody>
-          <a:bodyPr rtlCol="0" anchor="ctr" wrap="square"/>
+          <a:bodyPr wrap="square" rtlCol="0" anchor="ctr"/>
           <a:lstStyle/>
           <a:p>
             <a:pPr algn="ctr" latinLnBrk="0"/>
@@ -6176,7 +6213,7 @@
 </file>
 
 <file path=ppt/slides/slide7.xml><?xml version="1.0" encoding="utf-8"?>
-<p:sld xmlns:a="http://schemas.openxmlformats.org/drawingml/2006/main" xmlns:p="http://schemas.openxmlformats.org/presentationml/2006/main" xmlns:r="http://schemas.openxmlformats.org/officeDocument/2006/relationships">
+<p:sld xmlns:a="http://schemas.openxmlformats.org/drawingml/2006/main" xmlns:r="http://schemas.openxmlformats.org/officeDocument/2006/relationships" xmlns:p="http://schemas.openxmlformats.org/presentationml/2006/main">
   <p:cSld>
     <p:bg>
       <p:bgPr>
@@ -6192,7 +6229,14 @@
         <p:cNvGrpSpPr/>
         <p:nvPr/>
       </p:nvGrpSpPr>
-      <p:grpSpPr/>
+      <p:grpSpPr>
+        <a:xfrm>
+          <a:off x="0" y="0"/>
+          <a:ext cx="0" cy="0"/>
+          <a:chOff x="0" y="0"/>
+          <a:chExt cx="0" cy="0"/>
+        </a:xfrm>
+      </p:grpSpPr>
       <p:sp>
         <p:nvSpPr>
           <p:cNvPr id="2" name="TextBox 1"/>
@@ -6210,7 +6254,7 @@
           <a:noFill/>
         </p:spPr>
         <p:txBody>
-          <a:bodyPr wrap="square" anchor="t" lIns="27432" rIns="27432" tIns="18288" bIns="18288">
+          <a:bodyPr wrap="square" lIns="27432" tIns="18288" rIns="27432" bIns="18288" anchor="t">
             <a:spAutoFit/>
           </a:bodyPr>
           <a:lstStyle/>
@@ -6249,7 +6293,7 @@
           <a:noFill/>
         </p:spPr>
         <p:txBody>
-          <a:bodyPr wrap="square" anchor="t" lIns="27432" rIns="27432" tIns="18288" bIns="18288">
+          <a:bodyPr wrap="square" lIns="27432" tIns="18288" rIns="27432" bIns="18288" anchor="t">
             <a:spAutoFit/>
           </a:bodyPr>
           <a:lstStyle/>
@@ -6288,7 +6332,7 @@
           <a:noFill/>
         </p:spPr>
         <p:txBody>
-          <a:bodyPr wrap="square" anchor="t" lIns="27432" rIns="27432" tIns="18288" bIns="18288">
+          <a:bodyPr wrap="square" lIns="27432" tIns="18288" rIns="27432" bIns="18288" anchor="t">
             <a:spAutoFit/>
           </a:bodyPr>
           <a:lstStyle/>
@@ -6318,7 +6362,7 @@
         </p:nvSpPr>
         <p:spPr>
           <a:xfrm>
-            <a:off x="502920" y="6510528"/>
+            <a:off x="502920" y="6620256"/>
             <a:ext cx="4572000" cy="274320"/>
           </a:xfrm>
           <a:prstGeom prst="rect">
@@ -6327,7 +6371,7 @@
           <a:noFill/>
         </p:spPr>
         <p:txBody>
-          <a:bodyPr wrap="square" anchor="t" lIns="27432" rIns="27432" tIns="18288" bIns="18288">
+          <a:bodyPr wrap="square" lIns="27432" tIns="18288" rIns="27432" bIns="18288" anchor="t">
             <a:spAutoFit/>
           </a:bodyPr>
           <a:lstStyle/>
@@ -6390,7 +6434,7 @@
           <a:noFill/>
         </p:spPr>
         <p:txBody>
-          <a:bodyPr wrap="square" anchor="t" lIns="27432" rIns="27432" tIns="18288" bIns="18288">
+          <a:bodyPr wrap="square" lIns="27432" tIns="18288" rIns="27432" bIns="18288" anchor="t">
             <a:spAutoFit/>
           </a:bodyPr>
           <a:lstStyle/>
@@ -6457,7 +6501,7 @@
           </a:fontRef>
         </p:style>
         <p:txBody>
-          <a:bodyPr rtlCol="0" anchor="ctr" wrap="square"/>
+          <a:bodyPr wrap="square" rtlCol="0" anchor="ctr"/>
           <a:lstStyle/>
           <a:p>
             <a:pPr algn="ctr" latinLnBrk="0"/>
@@ -6482,7 +6526,7 @@
 </file>
 
 <file path=ppt/slides/slide8.xml><?xml version="1.0" encoding="utf-8"?>
-<p:sld xmlns:a="http://schemas.openxmlformats.org/drawingml/2006/main" xmlns:p="http://schemas.openxmlformats.org/presentationml/2006/main" xmlns:r="http://schemas.openxmlformats.org/officeDocument/2006/relationships">
+<p:sld xmlns:a="http://schemas.openxmlformats.org/drawingml/2006/main" xmlns:r="http://schemas.openxmlformats.org/officeDocument/2006/relationships" xmlns:p="http://schemas.openxmlformats.org/presentationml/2006/main">
   <p:cSld>
     <p:bg>
       <p:bgPr>
@@ -6498,7 +6542,14 @@
         <p:cNvGrpSpPr/>
         <p:nvPr/>
       </p:nvGrpSpPr>
-      <p:grpSpPr/>
+      <p:grpSpPr>
+        <a:xfrm>
+          <a:off x="0" y="0"/>
+          <a:ext cx="0" cy="0"/>
+          <a:chOff x="0" y="0"/>
+          <a:chExt cx="0" cy="0"/>
+        </a:xfrm>
+      </p:grpSpPr>
       <p:sp>
         <p:nvSpPr>
           <p:cNvPr id="2" name="TextBox 1"/>
@@ -6516,7 +6567,7 @@
           <a:noFill/>
         </p:spPr>
         <p:txBody>
-          <a:bodyPr wrap="square" anchor="t" lIns="27432" rIns="27432" tIns="18288" bIns="18288">
+          <a:bodyPr wrap="square" lIns="27432" tIns="18288" rIns="27432" bIns="18288" anchor="t">
             <a:spAutoFit/>
           </a:bodyPr>
           <a:lstStyle/>
@@ -6555,7 +6606,7 @@
           <a:noFill/>
         </p:spPr>
         <p:txBody>
-          <a:bodyPr wrap="square" anchor="t" lIns="27432" rIns="27432" tIns="18288" bIns="18288">
+          <a:bodyPr wrap="square" lIns="27432" tIns="18288" rIns="27432" bIns="18288" anchor="t">
             <a:spAutoFit/>
           </a:bodyPr>
           <a:lstStyle/>
@@ -6594,7 +6645,7 @@
           <a:noFill/>
         </p:spPr>
         <p:txBody>
-          <a:bodyPr wrap="square" anchor="t" lIns="27432" rIns="27432" tIns="18288" bIns="18288">
+          <a:bodyPr wrap="square" lIns="27432" tIns="18288" rIns="27432" bIns="18288" anchor="t">
             <a:spAutoFit/>
           </a:bodyPr>
           <a:lstStyle/>
@@ -6624,7 +6675,7 @@
         </p:nvSpPr>
         <p:spPr>
           <a:xfrm>
-            <a:off x="502920" y="6510528"/>
+            <a:off x="502920" y="6629400"/>
             <a:ext cx="4572000" cy="274320"/>
           </a:xfrm>
           <a:prstGeom prst="rect">
@@ -6633,7 +6684,7 @@
           <a:noFill/>
         </p:spPr>
         <p:txBody>
-          <a:bodyPr wrap="square" anchor="t" lIns="27432" rIns="27432" tIns="18288" bIns="18288">
+          <a:bodyPr wrap="square" lIns="27432" tIns="18288" rIns="27432" bIns="18288" anchor="t">
             <a:spAutoFit/>
           </a:bodyPr>
           <a:lstStyle/>
@@ -6644,7 +6695,7 @@
               </a:lnSpc>
             </a:pPr>
             <a:r>
-              <a:rPr sz="1000" b="0">
+              <a:rPr sz="1000" b="0" dirty="0">
                 <a:solidFill>
                   <a:srgbClr val="6E6A60"/>
                 </a:solidFill>
@@ -6672,7 +6723,7 @@
           <a:noFill/>
         </p:spPr>
         <p:txBody>
-          <a:bodyPr wrap="square" anchor="t" lIns="27432" rIns="27432" tIns="18288" bIns="18288">
+          <a:bodyPr wrap="square" lIns="27432" tIns="18288" rIns="27432" bIns="18288" anchor="t">
             <a:spAutoFit/>
           </a:bodyPr>
           <a:lstStyle/>
@@ -6734,7 +6785,7 @@
           </a:fontRef>
         </p:style>
         <p:txBody>
-          <a:bodyPr rtlCol="0" anchor="t" wrap="square" lIns="201168" rIns="201168" tIns="146304"/>
+          <a:bodyPr wrap="square" lIns="201168" tIns="146304" rIns="201168" rtlCol="0" anchor="t"/>
           <a:lstStyle/>
           <a:p>
             <a:pPr algn="l" latinLnBrk="0">
@@ -6810,7 +6861,7 @@
           </a:fontRef>
         </p:style>
         <p:txBody>
-          <a:bodyPr rtlCol="0" anchor="t" wrap="square" lIns="201168" rIns="201168" tIns="146304"/>
+          <a:bodyPr wrap="square" lIns="201168" tIns="146304" rIns="201168" rtlCol="0" anchor="t"/>
           <a:lstStyle/>
           <a:p>
             <a:pPr algn="l" latinLnBrk="0">
@@ -6886,7 +6937,7 @@
           </a:fontRef>
         </p:style>
         <p:txBody>
-          <a:bodyPr rtlCol="0" anchor="t" wrap="square" lIns="201168" rIns="201168" tIns="146304"/>
+          <a:bodyPr wrap="square" lIns="201168" tIns="146304" rIns="201168" rtlCol="0" anchor="t"/>
           <a:lstStyle/>
           <a:p>
             <a:pPr algn="l" latinLnBrk="0">
@@ -6962,7 +7013,7 @@
           </a:fontRef>
         </p:style>
         <p:txBody>
-          <a:bodyPr rtlCol="0" anchor="t" wrap="square" lIns="201168" rIns="201168" tIns="146304"/>
+          <a:bodyPr wrap="square" lIns="201168" tIns="146304" rIns="201168" rtlCol="0" anchor="t"/>
           <a:lstStyle/>
           <a:p>
             <a:pPr algn="l" latinLnBrk="0">
@@ -7038,7 +7089,7 @@
           </a:fontRef>
         </p:style>
         <p:txBody>
-          <a:bodyPr rtlCol="0" anchor="t" wrap="square" lIns="201168" rIns="201168" tIns="146304"/>
+          <a:bodyPr wrap="square" lIns="201168" tIns="146304" rIns="201168" rtlCol="0" anchor="t"/>
           <a:lstStyle/>
           <a:p>
             <a:pPr algn="l" latinLnBrk="0">
@@ -7112,7 +7163,7 @@
           </a:fontRef>
         </p:style>
         <p:txBody>
-          <a:bodyPr rtlCol="0" anchor="ctr" wrap="square"/>
+          <a:bodyPr wrap="square" rtlCol="0" anchor="ctr"/>
           <a:lstStyle/>
           <a:p>
             <a:pPr algn="ctr" latinLnBrk="0"/>
@@ -7137,7 +7188,7 @@
 </file>
 
 <file path=ppt/slides/slide9.xml><?xml version="1.0" encoding="utf-8"?>
-<p:sld xmlns:a="http://schemas.openxmlformats.org/drawingml/2006/main" xmlns:p="http://schemas.openxmlformats.org/presentationml/2006/main" xmlns:r="http://schemas.openxmlformats.org/officeDocument/2006/relationships">
+<p:sld xmlns:a="http://schemas.openxmlformats.org/drawingml/2006/main" xmlns:r="http://schemas.openxmlformats.org/officeDocument/2006/relationships" xmlns:p="http://schemas.openxmlformats.org/presentationml/2006/main">
   <p:cSld>
     <p:bg>
       <p:bgPr>
@@ -7153,7 +7204,14 @@
         <p:cNvGrpSpPr/>
         <p:nvPr/>
       </p:nvGrpSpPr>
-      <p:grpSpPr/>
+      <p:grpSpPr>
+        <a:xfrm>
+          <a:off x="0" y="0"/>
+          <a:ext cx="0" cy="0"/>
+          <a:chOff x="0" y="0"/>
+          <a:chExt cx="0" cy="0"/>
+        </a:xfrm>
+      </p:grpSpPr>
       <p:sp>
         <p:nvSpPr>
           <p:cNvPr id="2" name="TextBox 1"/>
@@ -7171,7 +7229,7 @@
           <a:noFill/>
         </p:spPr>
         <p:txBody>
-          <a:bodyPr wrap="square" anchor="t" lIns="27432" rIns="27432" tIns="18288" bIns="18288">
+          <a:bodyPr wrap="square" lIns="27432" tIns="18288" rIns="27432" bIns="18288" anchor="t">
             <a:spAutoFit/>
           </a:bodyPr>
           <a:lstStyle/>
@@ -7210,7 +7268,7 @@
           <a:noFill/>
         </p:spPr>
         <p:txBody>
-          <a:bodyPr wrap="square" anchor="t" lIns="27432" rIns="27432" tIns="18288" bIns="18288">
+          <a:bodyPr wrap="square" lIns="27432" tIns="18288" rIns="27432" bIns="18288" anchor="t">
             <a:spAutoFit/>
           </a:bodyPr>
           <a:lstStyle/>
@@ -7249,7 +7307,7 @@
           <a:noFill/>
         </p:spPr>
         <p:txBody>
-          <a:bodyPr wrap="square" anchor="t" lIns="27432" rIns="27432" tIns="18288" bIns="18288">
+          <a:bodyPr wrap="square" lIns="27432" tIns="18288" rIns="27432" bIns="18288" anchor="t">
             <a:spAutoFit/>
           </a:bodyPr>
           <a:lstStyle/>
@@ -7288,7 +7346,7 @@
           <a:noFill/>
         </p:spPr>
         <p:txBody>
-          <a:bodyPr wrap="square" anchor="t" lIns="27432" rIns="27432" tIns="18288" bIns="18288">
+          <a:bodyPr wrap="square" lIns="27432" tIns="18288" rIns="27432" bIns="18288" anchor="t">
             <a:spAutoFit/>
           </a:bodyPr>
           <a:lstStyle/>
@@ -7350,7 +7408,7 @@
           </a:fontRef>
         </p:style>
         <p:txBody>
-          <a:bodyPr rtlCol="0" anchor="t" wrap="square" lIns="201168" rIns="201168" tIns="146304"/>
+          <a:bodyPr wrap="square" lIns="201168" tIns="146304" rIns="201168" rtlCol="0" anchor="t"/>
           <a:lstStyle/>
           <a:p>
             <a:pPr algn="l" latinLnBrk="0">
@@ -7458,7 +7516,7 @@
           </a:fontRef>
         </p:style>
         <p:txBody>
-          <a:bodyPr rtlCol="0" anchor="t" wrap="square" lIns="201168" rIns="201168" tIns="146304"/>
+          <a:bodyPr wrap="square" lIns="201168" tIns="146304" rIns="201168" rtlCol="0" anchor="t"/>
           <a:lstStyle/>
           <a:p>
             <a:pPr algn="l" latinLnBrk="0">
@@ -7566,7 +7624,7 @@
           </a:fontRef>
         </p:style>
         <p:txBody>
-          <a:bodyPr rtlCol="0" anchor="t" wrap="square" lIns="201168" rIns="201168" tIns="146304"/>
+          <a:bodyPr wrap="square" lIns="201168" tIns="146304" rIns="201168" rtlCol="0" anchor="t"/>
           <a:lstStyle/>
           <a:p>
             <a:pPr algn="l" latinLnBrk="0">
@@ -7651,7 +7709,7 @@
           <a:noFill/>
         </p:spPr>
         <p:txBody>
-          <a:bodyPr wrap="square" anchor="t" lIns="27432" rIns="27432" tIns="18288" bIns="18288">
+          <a:bodyPr wrap="square" lIns="27432" tIns="18288" rIns="27432" bIns="18288" anchor="t">
             <a:spAutoFit/>
           </a:bodyPr>
           <a:lstStyle/>

</xml_diff>

<commit_message>
fix(script): refine feedback questions for final presentation structure
</commit_message>
<xml_diff>
--- a/output/jul09_status_meeting_vi.pptx
+++ b/output/jul09_status_meeting_vi.pptx
@@ -129,6 +129,236 @@
     </p:ext>
   </p:extLst>
 </p:presentation>
+</file>
+
+<file path=ppt/changesInfos/changesInfo1.xml><?xml version="1.0" encoding="utf-8"?>
+<pc:chgInfo xmlns:a="http://schemas.openxmlformats.org/drawingml/2006/main" xmlns:r="http://schemas.openxmlformats.org/officeDocument/2006/relationships" xmlns:ac="http://schemas.microsoft.com/office/drawing/2013/main/command" xmlns:pc="http://schemas.microsoft.com/office/powerpoint/2013/main/command">
+  <pc:docChgLst>
+    <pc:chgData name="Saad Anwar" userId="895f82935b6f72c7" providerId="LiveId" clId="{CB245C93-BFC3-42DE-907C-BC8C402E9DA4}"/>
+    <pc:docChg chg="undo custSel modSld">
+      <pc:chgData name="Saad Anwar" userId="895f82935b6f72c7" providerId="LiveId" clId="{CB245C93-BFC3-42DE-907C-BC8C402E9DA4}" dt="2026-07-09T07:24:50.694" v="426" actId="1036"/>
+      <pc:docMkLst>
+        <pc:docMk/>
+      </pc:docMkLst>
+      <pc:sldChg chg="modSp mod">
+        <pc:chgData name="Saad Anwar" userId="895f82935b6f72c7" providerId="LiveId" clId="{CB245C93-BFC3-42DE-907C-BC8C402E9DA4}" dt="2026-07-09T07:24:02.105" v="422" actId="20577"/>
+        <pc:sldMkLst>
+          <pc:docMk/>
+          <pc:sldMk cId="0" sldId="256"/>
+        </pc:sldMkLst>
+        <pc:spChg chg="mod">
+          <ac:chgData name="Saad Anwar" userId="895f82935b6f72c7" providerId="LiveId" clId="{CB245C93-BFC3-42DE-907C-BC8C402E9DA4}" dt="2026-07-09T07:24:02.105" v="422" actId="20577"/>
+          <ac:spMkLst>
+            <pc:docMk/>
+            <pc:sldMk cId="0" sldId="256"/>
+            <ac:spMk id="5" creationId="{00000000-0000-0000-0000-000000000000}"/>
+          </ac:spMkLst>
+        </pc:spChg>
+      </pc:sldChg>
+      <pc:sldChg chg="modSp mod">
+        <pc:chgData name="Saad Anwar" userId="895f82935b6f72c7" providerId="LiveId" clId="{CB245C93-BFC3-42DE-907C-BC8C402E9DA4}" dt="2026-07-09T07:23:37.650" v="413" actId="1035"/>
+        <pc:sldMkLst>
+          <pc:docMk/>
+          <pc:sldMk cId="0" sldId="257"/>
+        </pc:sldMkLst>
+        <pc:spChg chg="mod">
+          <ac:chgData name="Saad Anwar" userId="895f82935b6f72c7" providerId="LiveId" clId="{CB245C93-BFC3-42DE-907C-BC8C402E9DA4}" dt="2026-07-09T07:23:35.367" v="410" actId="1035"/>
+          <ac:spMkLst>
+            <pc:docMk/>
+            <pc:sldMk cId="0" sldId="257"/>
+            <ac:spMk id="5" creationId="{00000000-0000-0000-0000-000000000000}"/>
+          </ac:spMkLst>
+        </pc:spChg>
+        <pc:spChg chg="mod">
+          <ac:chgData name="Saad Anwar" userId="895f82935b6f72c7" providerId="LiveId" clId="{CB245C93-BFC3-42DE-907C-BC8C402E9DA4}" dt="2026-07-09T07:23:37.650" v="413" actId="1035"/>
+          <ac:spMkLst>
+            <pc:docMk/>
+            <pc:sldMk cId="0" sldId="257"/>
+            <ac:spMk id="11" creationId="{00000000-0000-0000-0000-000000000000}"/>
+          </ac:spMkLst>
+        </pc:spChg>
+      </pc:sldChg>
+      <pc:sldChg chg="modSp mod">
+        <pc:chgData name="Saad Anwar" userId="895f82935b6f72c7" providerId="LiveId" clId="{CB245C93-BFC3-42DE-907C-BC8C402E9DA4}" dt="2026-07-09T07:23:09.233" v="379" actId="1035"/>
+        <pc:sldMkLst>
+          <pc:docMk/>
+          <pc:sldMk cId="0" sldId="258"/>
+        </pc:sldMkLst>
+        <pc:spChg chg="mod">
+          <ac:chgData name="Saad Anwar" userId="895f82935b6f72c7" providerId="LiveId" clId="{CB245C93-BFC3-42DE-907C-BC8C402E9DA4}" dt="2026-07-09T07:23:09.233" v="379" actId="1035"/>
+          <ac:spMkLst>
+            <pc:docMk/>
+            <pc:sldMk cId="0" sldId="258"/>
+            <ac:spMk id="5" creationId="{00000000-0000-0000-0000-000000000000}"/>
+          </ac:spMkLst>
+        </pc:spChg>
+        <pc:spChg chg="mod">
+          <ac:chgData name="Saad Anwar" userId="895f82935b6f72c7" providerId="LiveId" clId="{CB245C93-BFC3-42DE-907C-BC8C402E9DA4}" dt="2026-07-09T07:20:42.992" v="170" actId="14100"/>
+          <ac:spMkLst>
+            <pc:docMk/>
+            <pc:sldMk cId="0" sldId="258"/>
+            <ac:spMk id="7" creationId="{00000000-0000-0000-0000-000000000000}"/>
+          </ac:spMkLst>
+        </pc:spChg>
+        <pc:spChg chg="mod">
+          <ac:chgData name="Saad Anwar" userId="895f82935b6f72c7" providerId="LiveId" clId="{CB245C93-BFC3-42DE-907C-BC8C402E9DA4}" dt="2026-07-09T07:22:41.123" v="348" actId="14100"/>
+          <ac:spMkLst>
+            <pc:docMk/>
+            <pc:sldMk cId="0" sldId="258"/>
+            <ac:spMk id="8" creationId="{00000000-0000-0000-0000-000000000000}"/>
+          </ac:spMkLst>
+        </pc:spChg>
+        <pc:spChg chg="mod">
+          <ac:chgData name="Saad Anwar" userId="895f82935b6f72c7" providerId="LiveId" clId="{CB245C93-BFC3-42DE-907C-BC8C402E9DA4}" dt="2026-07-09T07:22:44.031" v="350" actId="1035"/>
+          <ac:spMkLst>
+            <pc:docMk/>
+            <pc:sldMk cId="0" sldId="258"/>
+            <ac:spMk id="9" creationId="{00000000-0000-0000-0000-000000000000}"/>
+          </ac:spMkLst>
+        </pc:spChg>
+        <pc:spChg chg="mod">
+          <ac:chgData name="Saad Anwar" userId="895f82935b6f72c7" providerId="LiveId" clId="{CB245C93-BFC3-42DE-907C-BC8C402E9DA4}" dt="2026-07-09T07:22:46.216" v="354" actId="1035"/>
+          <ac:spMkLst>
+            <pc:docMk/>
+            <pc:sldMk cId="0" sldId="258"/>
+            <ac:spMk id="10" creationId="{00000000-0000-0000-0000-000000000000}"/>
+          </ac:spMkLst>
+        </pc:spChg>
+        <pc:spChg chg="mod">
+          <ac:chgData name="Saad Anwar" userId="895f82935b6f72c7" providerId="LiveId" clId="{CB245C93-BFC3-42DE-907C-BC8C402E9DA4}" dt="2026-07-09T07:22:49.740" v="360" actId="1035"/>
+          <ac:spMkLst>
+            <pc:docMk/>
+            <pc:sldMk cId="0" sldId="258"/>
+            <ac:spMk id="11" creationId="{00000000-0000-0000-0000-000000000000}"/>
+          </ac:spMkLst>
+        </pc:spChg>
+        <pc:spChg chg="mod">
+          <ac:chgData name="Saad Anwar" userId="895f82935b6f72c7" providerId="LiveId" clId="{CB245C93-BFC3-42DE-907C-BC8C402E9DA4}" dt="2026-07-09T07:23:00.257" v="369" actId="1035"/>
+          <ac:spMkLst>
+            <pc:docMk/>
+            <pc:sldMk cId="0" sldId="258"/>
+            <ac:spMk id="12" creationId="{00000000-0000-0000-0000-000000000000}"/>
+          </ac:spMkLst>
+        </pc:spChg>
+      </pc:sldChg>
+      <pc:sldChg chg="modSp mod">
+        <pc:chgData name="Saad Anwar" userId="895f82935b6f72c7" providerId="LiveId" clId="{CB245C93-BFC3-42DE-907C-BC8C402E9DA4}" dt="2026-07-09T07:24:50.694" v="426" actId="1036"/>
+        <pc:sldMkLst>
+          <pc:docMk/>
+          <pc:sldMk cId="0" sldId="259"/>
+        </pc:sldMkLst>
+        <pc:spChg chg="mod">
+          <ac:chgData name="Saad Anwar" userId="895f82935b6f72c7" providerId="LiveId" clId="{CB245C93-BFC3-42DE-907C-BC8C402E9DA4}" dt="2026-07-09T07:20:01.658" v="158" actId="1035"/>
+          <ac:spMkLst>
+            <pc:docMk/>
+            <pc:sldMk cId="0" sldId="259"/>
+            <ac:spMk id="5" creationId="{00000000-0000-0000-0000-000000000000}"/>
+          </ac:spMkLst>
+        </pc:spChg>
+        <pc:spChg chg="mod">
+          <ac:chgData name="Saad Anwar" userId="895f82935b6f72c7" providerId="LiveId" clId="{CB245C93-BFC3-42DE-907C-BC8C402E9DA4}" dt="2026-07-09T07:24:50.694" v="426" actId="1036"/>
+          <ac:spMkLst>
+            <pc:docMk/>
+            <pc:sldMk cId="0" sldId="259"/>
+            <ac:spMk id="11" creationId="{00000000-0000-0000-0000-000000000000}"/>
+          </ac:spMkLst>
+        </pc:spChg>
+      </pc:sldChg>
+      <pc:sldChg chg="modSp mod">
+        <pc:chgData name="Saad Anwar" userId="895f82935b6f72c7" providerId="LiveId" clId="{CB245C93-BFC3-42DE-907C-BC8C402E9DA4}" dt="2026-07-09T07:19:40.626" v="123" actId="1036"/>
+        <pc:sldMkLst>
+          <pc:docMk/>
+          <pc:sldMk cId="0" sldId="260"/>
+        </pc:sldMkLst>
+        <pc:spChg chg="mod">
+          <ac:chgData name="Saad Anwar" userId="895f82935b6f72c7" providerId="LiveId" clId="{CB245C93-BFC3-42DE-907C-BC8C402E9DA4}" dt="2026-07-09T07:19:40.626" v="123" actId="1036"/>
+          <ac:spMkLst>
+            <pc:docMk/>
+            <pc:sldMk cId="0" sldId="260"/>
+            <ac:spMk id="5" creationId="{00000000-0000-0000-0000-000000000000}"/>
+          </ac:spMkLst>
+        </pc:spChg>
+        <pc:spChg chg="mod">
+          <ac:chgData name="Saad Anwar" userId="895f82935b6f72c7" providerId="LiveId" clId="{CB245C93-BFC3-42DE-907C-BC8C402E9DA4}" dt="2026-07-09T07:19:33.977" v="110" actId="1035"/>
+          <ac:spMkLst>
+            <pc:docMk/>
+            <pc:sldMk cId="0" sldId="260"/>
+            <ac:spMk id="8" creationId="{00000000-0000-0000-0000-000000000000}"/>
+          </ac:spMkLst>
+        </pc:spChg>
+      </pc:sldChg>
+      <pc:sldChg chg="modSp mod">
+        <pc:chgData name="Saad Anwar" userId="895f82935b6f72c7" providerId="LiveId" clId="{CB245C93-BFC3-42DE-907C-BC8C402E9DA4}" dt="2026-07-09T07:19:17.288" v="94" actId="1035"/>
+        <pc:sldMkLst>
+          <pc:docMk/>
+          <pc:sldMk cId="0" sldId="261"/>
+        </pc:sldMkLst>
+        <pc:spChg chg="mod">
+          <ac:chgData name="Saad Anwar" userId="895f82935b6f72c7" providerId="LiveId" clId="{CB245C93-BFC3-42DE-907C-BC8C402E9DA4}" dt="2026-07-09T07:19:17.288" v="94" actId="1035"/>
+          <ac:spMkLst>
+            <pc:docMk/>
+            <pc:sldMk cId="0" sldId="261"/>
+            <ac:spMk id="5" creationId="{00000000-0000-0000-0000-000000000000}"/>
+          </ac:spMkLst>
+        </pc:spChg>
+        <pc:spChg chg="mod">
+          <ac:chgData name="Saad Anwar" userId="895f82935b6f72c7" providerId="LiveId" clId="{CB245C93-BFC3-42DE-907C-BC8C402E9DA4}" dt="2026-07-09T07:19:06.371" v="79" actId="1035"/>
+          <ac:spMkLst>
+            <pc:docMk/>
+            <pc:sldMk cId="0" sldId="261"/>
+            <ac:spMk id="13" creationId="{00000000-0000-0000-0000-000000000000}"/>
+          </ac:spMkLst>
+        </pc:spChg>
+      </pc:sldChg>
+      <pc:sldChg chg="modSp mod">
+        <pc:chgData name="Saad Anwar" userId="895f82935b6f72c7" providerId="LiveId" clId="{CB245C93-BFC3-42DE-907C-BC8C402E9DA4}" dt="2026-07-09T07:24:38.769" v="424" actId="1036"/>
+        <pc:sldMkLst>
+          <pc:docMk/>
+          <pc:sldMk cId="0" sldId="262"/>
+        </pc:sldMkLst>
+        <pc:spChg chg="mod">
+          <ac:chgData name="Saad Anwar" userId="895f82935b6f72c7" providerId="LiveId" clId="{CB245C93-BFC3-42DE-907C-BC8C402E9DA4}" dt="2026-07-09T07:18:47.301" v="59" actId="1036"/>
+          <ac:spMkLst>
+            <pc:docMk/>
+            <pc:sldMk cId="0" sldId="262"/>
+            <ac:spMk id="5" creationId="{00000000-0000-0000-0000-000000000000}"/>
+          </ac:spMkLst>
+        </pc:spChg>
+        <pc:spChg chg="mod">
+          <ac:chgData name="Saad Anwar" userId="895f82935b6f72c7" providerId="LiveId" clId="{CB245C93-BFC3-42DE-907C-BC8C402E9DA4}" dt="2026-07-09T07:24:38.769" v="424" actId="1036"/>
+          <ac:spMkLst>
+            <pc:docMk/>
+            <pc:sldMk cId="0" sldId="262"/>
+            <ac:spMk id="8" creationId="{00000000-0000-0000-0000-000000000000}"/>
+          </ac:spMkLst>
+        </pc:spChg>
+      </pc:sldChg>
+      <pc:sldChg chg="modSp mod">
+        <pc:chgData name="Saad Anwar" userId="895f82935b6f72c7" providerId="LiveId" clId="{CB245C93-BFC3-42DE-907C-BC8C402E9DA4}" dt="2026-07-09T07:18:31.007" v="32" actId="1036"/>
+        <pc:sldMkLst>
+          <pc:docMk/>
+          <pc:sldMk cId="0" sldId="263"/>
+        </pc:sldMkLst>
+        <pc:spChg chg="mod">
+          <ac:chgData name="Saad Anwar" userId="895f82935b6f72c7" providerId="LiveId" clId="{CB245C93-BFC3-42DE-907C-BC8C402E9DA4}" dt="2026-07-09T07:18:31.007" v="32" actId="1036"/>
+          <ac:spMkLst>
+            <pc:docMk/>
+            <pc:sldMk cId="0" sldId="263"/>
+            <ac:spMk id="5" creationId="{00000000-0000-0000-0000-000000000000}"/>
+          </ac:spMkLst>
+        </pc:spChg>
+        <pc:spChg chg="mod">
+          <ac:chgData name="Saad Anwar" userId="895f82935b6f72c7" providerId="LiveId" clId="{CB245C93-BFC3-42DE-907C-BC8C402E9DA4}" dt="2026-07-09T07:18:19.893" v="20" actId="1035"/>
+          <ac:spMkLst>
+            <pc:docMk/>
+            <pc:sldMk cId="0" sldId="263"/>
+            <ac:spMk id="12" creationId="{00000000-0000-0000-0000-000000000000}"/>
+          </ac:spMkLst>
+        </pc:spChg>
+      </pc:sldChg>
+    </pc:docChg>
+  </pc:docChgLst>
+</pc:chgInfo>
 </file>
 
 <file path=ppt/slideLayouts/slideLayout1.xml><?xml version="1.0" encoding="utf-8"?>
@@ -3232,7 +3462,7 @@
         <p:spPr>
           <a:xfrm>
             <a:off x="502920" y="4434840"/>
-            <a:ext cx="11185855" cy="365760"/>
+            <a:ext cx="11185855" cy="283154"/>
           </a:xfrm>
           <a:prstGeom prst="rect">
             <a:avLst/>
@@ -3251,13 +3481,49 @@
               </a:lnSpc>
             </a:pPr>
             <a:r>
-              <a:rPr sz="1600" b="1">
+              <a:rPr sz="1600" b="1" dirty="0">
                 <a:solidFill>
                   <a:srgbClr val="FDFBF5"/>
                 </a:solidFill>
                 <a:latin typeface="Segoe UI"/>
               </a:rPr>
-              <a:t>Presented by Zuraiz, on behalf of the team</a:t>
+              <a:t>Presented by</a:t>
+            </a:r>
+            <a:r>
+              <a:rPr lang="en-US" sz="1600" b="1" dirty="0">
+                <a:solidFill>
+                  <a:srgbClr val="FDFBF5"/>
+                </a:solidFill>
+                <a:latin typeface="Segoe UI"/>
+              </a:rPr>
+              <a:t> Hammad &amp;</a:t>
+            </a:r>
+            <a:r>
+              <a:rPr sz="1600" b="1" dirty="0">
+                <a:solidFill>
+                  <a:srgbClr val="FDFBF5"/>
+                </a:solidFill>
+                <a:latin typeface="Segoe UI"/>
+              </a:rPr>
+              <a:t> </a:t>
+            </a:r>
+            <a:r>
+              <a:rPr sz="1600" b="1" dirty="0" err="1">
+                <a:solidFill>
+                  <a:srgbClr val="FDFBF5"/>
+                </a:solidFill>
+                <a:latin typeface="Segoe UI"/>
+              </a:rPr>
+              <a:t>Zuraiz</a:t>
+            </a:r>
+            <a:r>
+              <a:rPr sz="1600" b="1" dirty="0">
+                <a:solidFill>
+                  <a:srgbClr val="FDFBF5"/>
+                </a:solidFill>
+                <a:latin typeface="Segoe UI"/>
+              </a:rPr>
+              <a:t>, on behalf of the team</a:t>
             </a:r>
           </a:p>
         </p:txBody>
@@ -3498,7 +3764,7 @@
         </p:nvSpPr>
         <p:spPr>
           <a:xfrm>
-            <a:off x="502920" y="6620256"/>
+            <a:off x="502920" y="6539742"/>
             <a:ext cx="4572000" cy="274320"/>
           </a:xfrm>
           <a:prstGeom prst="rect">
@@ -3518,7 +3784,7 @@
               </a:lnSpc>
             </a:pPr>
             <a:r>
-              <a:rPr sz="1000" b="0">
+              <a:rPr sz="1000" b="0" dirty="0">
                 <a:solidFill>
                   <a:srgbClr val="6E6A60"/>
                 </a:solidFill>
@@ -3880,7 +4146,7 @@
         </p:nvSpPr>
         <p:spPr>
           <a:xfrm>
-            <a:off x="502920" y="6144768"/>
+            <a:off x="502920" y="5995242"/>
             <a:ext cx="11185855" cy="475488"/>
           </a:xfrm>
           <a:prstGeom prst="roundRect">
@@ -4065,7 +4331,7 @@
               </a:lnSpc>
             </a:pPr>
             <a:r>
-              <a:rPr sz="1000" b="0">
+              <a:rPr sz="1000" b="0" dirty="0">
                 <a:solidFill>
                   <a:srgbClr val="6E6A60"/>
                 </a:solidFill>
@@ -4084,7 +4350,7 @@
         </p:nvSpPr>
         <p:spPr>
           <a:xfrm>
-            <a:off x="502920" y="6620256"/>
+            <a:off x="502920" y="6533991"/>
             <a:ext cx="4572000" cy="274320"/>
           </a:xfrm>
           <a:prstGeom prst="rect">
@@ -4104,7 +4370,7 @@
               </a:lnSpc>
             </a:pPr>
             <a:r>
-              <a:rPr sz="1000" b="0">
+              <a:rPr sz="1000" b="0" dirty="0">
                 <a:solidFill>
                   <a:srgbClr val="6E6A60"/>
                 </a:solidFill>
@@ -4163,7 +4429,7 @@
         <p:spPr>
           <a:xfrm>
             <a:off x="502920" y="1874519"/>
-            <a:ext cx="11185855" cy="658368"/>
+            <a:ext cx="11185855" cy="749808"/>
           </a:xfrm>
           <a:prstGeom prst="roundRect">
             <a:avLst>
@@ -4238,8 +4504,8 @@
         </p:nvSpPr>
         <p:spPr>
           <a:xfrm>
-            <a:off x="502920" y="2624327"/>
-            <a:ext cx="11185855" cy="658368"/>
+            <a:off x="497169" y="2704841"/>
+            <a:ext cx="11185855" cy="721048"/>
           </a:xfrm>
           <a:prstGeom prst="roundRect">
             <a:avLst>
@@ -4314,8 +4580,8 @@
         </p:nvSpPr>
         <p:spPr>
           <a:xfrm>
-            <a:off x="502920" y="3374135"/>
-            <a:ext cx="11185855" cy="658368"/>
+            <a:off x="502920" y="3529411"/>
+            <a:ext cx="11185855" cy="744053"/>
           </a:xfrm>
           <a:prstGeom prst="roundRect">
             <a:avLst>
@@ -4355,7 +4621,7 @@
               </a:spcAft>
             </a:pPr>
             <a:r>
-              <a:rPr sz="1400" b="1">
+              <a:rPr sz="1400" b="1" dirty="0">
                 <a:solidFill>
                   <a:srgbClr val="0E4D5E"/>
                 </a:solidFill>
@@ -4371,7 +4637,7 @@
               </a:spcAft>
             </a:pPr>
             <a:r>
-              <a:rPr sz="1250" b="0">
+              <a:rPr sz="1250" b="0" dirty="0">
                 <a:solidFill>
                   <a:srgbClr val="24262E"/>
                 </a:solidFill>
@@ -4390,8 +4656,8 @@
         </p:nvSpPr>
         <p:spPr>
           <a:xfrm>
-            <a:off x="502920" y="4123943"/>
-            <a:ext cx="11185855" cy="658368"/>
+            <a:off x="502920" y="4376987"/>
+            <a:ext cx="11185855" cy="744052"/>
           </a:xfrm>
           <a:prstGeom prst="roundRect">
             <a:avLst>
@@ -4431,7 +4697,7 @@
               </a:spcAft>
             </a:pPr>
             <a:r>
-              <a:rPr sz="1400" b="1">
+              <a:rPr sz="1400" b="1" dirty="0">
                 <a:solidFill>
                   <a:srgbClr val="0E4D5E"/>
                 </a:solidFill>
@@ -4447,7 +4713,7 @@
               </a:spcAft>
             </a:pPr>
             <a:r>
-              <a:rPr sz="1250" b="0">
+              <a:rPr sz="1250" b="0" dirty="0">
                 <a:solidFill>
                   <a:srgbClr val="24262E"/>
                 </a:solidFill>
@@ -4466,8 +4732,8 @@
         </p:nvSpPr>
         <p:spPr>
           <a:xfrm>
-            <a:off x="502920" y="4873751"/>
-            <a:ext cx="11185855" cy="658368"/>
+            <a:off x="502920" y="5213056"/>
+            <a:ext cx="11185855" cy="690169"/>
           </a:xfrm>
           <a:prstGeom prst="roundRect">
             <a:avLst>
@@ -4542,7 +4808,7 @@
         </p:nvSpPr>
         <p:spPr>
           <a:xfrm>
-            <a:off x="502920" y="6144768"/>
+            <a:off x="502920" y="5989491"/>
             <a:ext cx="11185855" cy="475488"/>
           </a:xfrm>
           <a:prstGeom prst="roundRect">
@@ -4746,7 +5012,7 @@
         </p:nvSpPr>
         <p:spPr>
           <a:xfrm>
-            <a:off x="502920" y="6583680"/>
+            <a:off x="502920" y="6526170"/>
             <a:ext cx="4572000" cy="274320"/>
           </a:xfrm>
           <a:prstGeom prst="rect">
@@ -5152,7 +5418,7 @@
         </p:nvSpPr>
         <p:spPr>
           <a:xfrm>
-            <a:off x="502920" y="6144768"/>
+            <a:off x="502920" y="5960736"/>
             <a:ext cx="11185855" cy="475488"/>
           </a:xfrm>
           <a:prstGeom prst="roundRect">
@@ -5356,7 +5622,7 @@
         </p:nvSpPr>
         <p:spPr>
           <a:xfrm>
-            <a:off x="502920" y="6647688"/>
+            <a:off x="502920" y="6515415"/>
             <a:ext cx="4572000" cy="274320"/>
           </a:xfrm>
           <a:prstGeom prst="rect">
@@ -5376,7 +5642,7 @@
               </a:lnSpc>
             </a:pPr>
             <a:r>
-              <a:rPr sz="1000" b="0">
+              <a:rPr sz="1000" b="0" dirty="0">
                 <a:solidFill>
                   <a:srgbClr val="6E6A60"/>
                 </a:solidFill>
@@ -5465,7 +5731,7 @@
         </p:nvSpPr>
         <p:spPr>
           <a:xfrm>
-            <a:off x="502920" y="6144768"/>
+            <a:off x="502920" y="5966487"/>
             <a:ext cx="11185855" cy="475488"/>
           </a:xfrm>
           <a:prstGeom prst="roundRect">
@@ -5669,7 +5935,7 @@
         </p:nvSpPr>
         <p:spPr>
           <a:xfrm>
-            <a:off x="502920" y="6620256"/>
+            <a:off x="502920" y="6533991"/>
             <a:ext cx="4572000" cy="274320"/>
           </a:xfrm>
           <a:prstGeom prst="rect">
@@ -6158,7 +6424,7 @@
         </p:nvSpPr>
         <p:spPr>
           <a:xfrm>
-            <a:off x="502920" y="6144768"/>
+            <a:off x="502920" y="5989491"/>
             <a:ext cx="11185855" cy="475488"/>
           </a:xfrm>
           <a:prstGeom prst="roundRect">
@@ -6362,7 +6628,7 @@
         </p:nvSpPr>
         <p:spPr>
           <a:xfrm>
-            <a:off x="502920" y="6620256"/>
+            <a:off x="502920" y="6505236"/>
             <a:ext cx="4572000" cy="274320"/>
           </a:xfrm>
           <a:prstGeom prst="rect">
@@ -6382,7 +6648,7 @@
               </a:lnSpc>
             </a:pPr>
             <a:r>
-              <a:rPr sz="1000" b="0">
+              <a:rPr sz="1000" b="0" dirty="0">
                 <a:solidFill>
                   <a:srgbClr val="6E6A60"/>
                 </a:solidFill>
@@ -6471,7 +6737,7 @@
         </p:nvSpPr>
         <p:spPr>
           <a:xfrm>
-            <a:off x="502920" y="6144768"/>
+            <a:off x="502920" y="5977989"/>
             <a:ext cx="11185855" cy="475488"/>
           </a:xfrm>
           <a:prstGeom prst="roundRect">
@@ -6675,7 +6941,7 @@
         </p:nvSpPr>
         <p:spPr>
           <a:xfrm>
-            <a:off x="502920" y="6629400"/>
+            <a:off x="502920" y="6543135"/>
             <a:ext cx="4572000" cy="274320"/>
           </a:xfrm>
           <a:prstGeom prst="rect">
@@ -7133,7 +7399,7 @@
         </p:nvSpPr>
         <p:spPr>
           <a:xfrm>
-            <a:off x="502920" y="6144768"/>
+            <a:off x="502920" y="5995242"/>
             <a:ext cx="11185855" cy="475488"/>
           </a:xfrm>
           <a:prstGeom prst="roundRect">
@@ -7655,7 +7921,7 @@
                 </a:solidFill>
                 <a:latin typeface="Segoe UI"/>
               </a:rPr>
-              <a:t>Final structure: research question, hypotheses, method, results, implementation, limitations, next steps.</a:t>
+              <a:t>Report format: which specific format should we follow, and what main headings should the final report include?</a:t>
             </a:r>
           </a:p>
           <a:p>

</xml_diff>